<commit_message>
Deck 3: transmission slide, per-S-parameter DD (paper style), beet slide
- new transmission (coupling) comparison slide (S21/S31/S41/S32)
- replaced the DD-pattern slide with per-S-parameter DD maps (fig_dd_per_sparam):
  measured (CI-gap / detdifplot method) and sim (|dS|) reflections, in grid-inch
  with phantom bowl + antenna markers, showing each Sii localizes near antenna i;
  methods labeled per the detdifplot vs deterministic distinction
- new beet-vs-metal slide + conclusion bullet (sim 93% / measured 42%)

Co-Authored-By: Claude Opus 4.8 <noreply@anthropic.com>
</commit_message>
<xml_diff>
--- a/regression_deck/Deck3_Sim_vs_Measured.pptx
+++ b/regression_deck/Deck3_Sim_vs_Measured.pptx
@@ -14,9 +14,11 @@
     <p:sldId id="262" r:id="rId8"/>
     <p:sldId id="263" r:id="rId9"/>
     <p:sldId id="264" r:id="rId10"/>
+    <p:sldId id="265" r:id="rId11"/>
+    <p:sldId id="266" r:id="rId12"/>
   </p:sldIdLst>
   <p:notesMasterIdLst>
-    <p:notesMasterId r:id="rId11"/>
+    <p:notesMasterId r:id="rId13"/>
   </p:notesMasterIdLst>
   <p:sldSz cx="12188952" cy="6858000"/>
   <p:notesSz cx="6858000" cy="12188952"/>
@@ -534,6 +536,182 @@
             <a:fld id="{F7021451-1387-4CA6-816F-3879F97B5CBC}" type="slidenum">
               <a:rPr lang="en-US"/>
               <a:t>1</a:t>
+            </a:fld>
+            <a:endParaRPr lang="en-US"/>
+          </a:p>
+        </p:txBody>
+      </p:sp>
+    </p:spTree>
+    <p:extLst>
+      <p:ext uri="{BB962C8B-B14F-4D97-AF65-F5344CB8AC3E}">
+        <p14:creationId xmlns:p14="http://schemas.microsoft.com/office/powerpoint/2010/main" val="1024086991"/>
+      </p:ext>
+    </p:extLst>
+  </p:cSld>
+  <p:clrMapOvr>
+    <a:masterClrMapping/>
+  </p:clrMapOvr>
+</p:notes>
+</file>
+
+<file path=ppt/notesSlides/notesSlide10.xml><?xml version="1.0" encoding="utf-8"?>
+<p:notes xmlns:a="http://schemas.openxmlformats.org/drawingml/2006/main" xmlns:r="http://schemas.openxmlformats.org/officeDocument/2006/relationships" xmlns:p="http://schemas.openxmlformats.org/presentationml/2006/main">
+  <p:cSld>
+    <p:spTree>
+      <p:nvGrpSpPr>
+        <p:cNvPr id="1" name=""/>
+        <p:cNvGrpSpPr/>
+        <p:nvPr/>
+      </p:nvGrpSpPr>
+      <p:grpSpPr>
+        <a:xfrm>
+          <a:off x="0" y="0"/>
+          <a:ext cx="0" cy="0"/>
+          <a:chOff x="0" y="0"/>
+          <a:chExt cx="0" cy="0"/>
+        </a:xfrm>
+      </p:grpSpPr>
+      <p:sp>
+        <p:nvSpPr>
+          <p:cNvPr id="2" name="Slide Image Placeholder 1"/>
+          <p:cNvSpPr>
+            <a:spLocks noGrp="1" noRot="1" noChangeAspect="1"/>
+          </p:cNvSpPr>
+          <p:nvPr>
+            <p:ph type="sldImg"/>
+          </p:nvPr>
+        </p:nvSpPr>
+        <p:spPr/>
+      </p:sp>
+      <p:sp>
+        <p:nvSpPr>
+          <p:cNvPr id="3" name="Notes Placeholder 2"/>
+          <p:cNvSpPr>
+            <a:spLocks noGrp="1"/>
+          </p:cNvSpPr>
+          <p:nvPr>
+            <p:ph type="body" idx="1"/>
+          </p:nvPr>
+        </p:nvSpPr>
+        <p:spPr/>
+        <p:txBody>
+          <a:bodyPr/>
+          <a:lstStyle/>
+          <a:p>
+            <a:r>
+              <a:rPr lang="en-US" dirty="0"/>
+              <a:t/>
+            </a:r>
+            <a:endParaRPr lang="en-US" dirty="0"/>
+          </a:p>
+        </p:txBody>
+      </p:sp>
+      <p:sp>
+        <p:nvSpPr>
+          <p:cNvPr id="4" name="Slide Number Placeholder 3"/>
+          <p:cNvSpPr>
+            <a:spLocks noGrp="1"/>
+          </p:cNvSpPr>
+          <p:nvPr>
+            <p:ph type="sldNum" sz="quarter" idx="10"/>
+          </p:nvPr>
+        </p:nvSpPr>
+        <p:spPr/>
+        <p:txBody>
+          <a:bodyPr/>
+          <a:lstStyle/>
+          <a:p>
+            <a:fld id="{F7021451-1387-4CA6-816F-3879F97B5CBC}" type="slidenum">
+              <a:rPr lang="en-US"/>
+              <a:t>10</a:t>
+            </a:fld>
+            <a:endParaRPr lang="en-US"/>
+          </a:p>
+        </p:txBody>
+      </p:sp>
+    </p:spTree>
+    <p:extLst>
+      <p:ext uri="{BB962C8B-B14F-4D97-AF65-F5344CB8AC3E}">
+        <p14:creationId xmlns:p14="http://schemas.microsoft.com/office/powerpoint/2010/main" val="1024086991"/>
+      </p:ext>
+    </p:extLst>
+  </p:cSld>
+  <p:clrMapOvr>
+    <a:masterClrMapping/>
+  </p:clrMapOvr>
+</p:notes>
+</file>
+
+<file path=ppt/notesSlides/notesSlide11.xml><?xml version="1.0" encoding="utf-8"?>
+<p:notes xmlns:a="http://schemas.openxmlformats.org/drawingml/2006/main" xmlns:r="http://schemas.openxmlformats.org/officeDocument/2006/relationships" xmlns:p="http://schemas.openxmlformats.org/presentationml/2006/main">
+  <p:cSld>
+    <p:spTree>
+      <p:nvGrpSpPr>
+        <p:cNvPr id="1" name=""/>
+        <p:cNvGrpSpPr/>
+        <p:nvPr/>
+      </p:nvGrpSpPr>
+      <p:grpSpPr>
+        <a:xfrm>
+          <a:off x="0" y="0"/>
+          <a:ext cx="0" cy="0"/>
+          <a:chOff x="0" y="0"/>
+          <a:chExt cx="0" cy="0"/>
+        </a:xfrm>
+      </p:grpSpPr>
+      <p:sp>
+        <p:nvSpPr>
+          <p:cNvPr id="2" name="Slide Image Placeholder 1"/>
+          <p:cNvSpPr>
+            <a:spLocks noGrp="1" noRot="1" noChangeAspect="1"/>
+          </p:cNvSpPr>
+          <p:nvPr>
+            <p:ph type="sldImg"/>
+          </p:nvPr>
+        </p:nvSpPr>
+        <p:spPr/>
+      </p:sp>
+      <p:sp>
+        <p:nvSpPr>
+          <p:cNvPr id="3" name="Notes Placeholder 2"/>
+          <p:cNvSpPr>
+            <a:spLocks noGrp="1"/>
+          </p:cNvSpPr>
+          <p:nvPr>
+            <p:ph type="body" idx="1"/>
+          </p:nvPr>
+        </p:nvSpPr>
+        <p:spPr/>
+        <p:txBody>
+          <a:bodyPr/>
+          <a:lstStyle/>
+          <a:p>
+            <a:r>
+              <a:rPr lang="en-US" dirty="0"/>
+              <a:t/>
+            </a:r>
+            <a:endParaRPr lang="en-US" dirty="0"/>
+          </a:p>
+        </p:txBody>
+      </p:sp>
+      <p:sp>
+        <p:nvSpPr>
+          <p:cNvPr id="4" name="Slide Number Placeholder 3"/>
+          <p:cNvSpPr>
+            <a:spLocks noGrp="1"/>
+          </p:cNvSpPr>
+          <p:nvPr>
+            <p:ph type="sldNum" sz="quarter" idx="10"/>
+          </p:nvPr>
+        </p:nvSpPr>
+        <p:spPr/>
+        <p:txBody>
+          <a:bodyPr/>
+          <a:lstStyle/>
+          <a:p>
+            <a:fld id="{F7021451-1387-4CA6-816F-3879F97B5CBC}" type="slidenum">
+              <a:rPr lang="en-US"/>
+              <a:t>11</a:t>
             </a:fld>
             <a:endParaRPr lang="en-US"/>
           </a:p>
@@ -1986,6 +2164,830 @@
 </p:sld>
 </file>
 
+<file path=ppt/slides/slide10.xml><?xml version="1.0" encoding="utf-8"?>
+<p:sld xmlns:a="http://schemas.openxmlformats.org/drawingml/2006/main" xmlns:r="http://schemas.openxmlformats.org/officeDocument/2006/relationships" xmlns:p="http://schemas.openxmlformats.org/presentationml/2006/main">
+  <p:cSld name="Slide 10">
+    <p:bg>
+      <p:bgPr>
+        <a:solidFill>
+          <a:srgbClr val="FFFFFF"/>
+        </a:solidFill>
+      </p:bgPr>
+    </p:bg>
+    <p:spTree>
+      <p:nvGrpSpPr>
+        <p:cNvPr id="1" name=""/>
+        <p:cNvGrpSpPr/>
+        <p:nvPr/>
+      </p:nvGrpSpPr>
+      <p:grpSpPr>
+        <a:xfrm>
+          <a:off x="0" y="0"/>
+          <a:ext cx="0" cy="0"/>
+          <a:chOff x="0" y="0"/>
+          <a:chExt cx="0" cy="0"/>
+        </a:xfrm>
+      </p:grpSpPr>
+      <p:sp>
+        <p:nvSpPr>
+          <p:cNvPr id="2" name="Text 0"/>
+          <p:cNvSpPr/>
+          <p:nvPr/>
+        </p:nvSpPr>
+        <p:spPr>
+          <a:xfrm>
+            <a:off x="548640" y="384048"/>
+            <a:ext cx="11091672" cy="640080"/>
+          </a:xfrm>
+          <a:prstGeom prst="rect">
+            <a:avLst/>
+          </a:prstGeom>
+          <a:noFill/>
+          <a:ln/>
+        </p:spPr>
+        <p:txBody>
+          <a:bodyPr wrap="square" lIns="0" tIns="0" rIns="0" bIns="0" rtlCol="0" anchor="ctr"/>
+          <a:lstStyle/>
+          <a:p>
+            <a:pPr indent="0" marL="0">
+              <a:buNone/>
+            </a:pPr>
+            <a:r>
+              <a:rPr lang="en-US" sz="2900" b="1" dirty="0">
+                <a:solidFill>
+                  <a:srgbClr val="2A1618"/>
+                </a:solidFill>
+                <a:latin typeface="Cambria" pitchFamily="34" charset="0"/>
+                <a:ea typeface="Cambria" pitchFamily="34" charset="-122"/>
+                <a:cs typeface="Cambria" pitchFamily="34" charset="-120"/>
+              </a:rPr>
+              <a:t>Beet (dielectric) vs metal tumor, sim and measured</a:t>
+            </a:r>
+            <a:endParaRPr lang="en-US" sz="2900" dirty="0"/>
+          </a:p>
+        </p:txBody>
+      </p:sp>
+      <p:sp>
+        <p:nvSpPr>
+          <p:cNvPr id="3" name="Text 1"/>
+          <p:cNvSpPr/>
+          <p:nvPr/>
+        </p:nvSpPr>
+        <p:spPr>
+          <a:xfrm>
+            <a:off x="548640" y="1033272"/>
+            <a:ext cx="11091672" cy="365760"/>
+          </a:xfrm>
+          <a:prstGeom prst="rect">
+            <a:avLst/>
+          </a:prstGeom>
+          <a:noFill/>
+          <a:ln/>
+        </p:spPr>
+        <p:txBody>
+          <a:bodyPr wrap="square" lIns="0" tIns="0" rIns="0" bIns="0" rtlCol="0" anchor="ctr"/>
+          <a:lstStyle/>
+          <a:p>
+            <a:pPr indent="0" marL="0">
+              <a:buNone/>
+            </a:pPr>
+            <a:r>
+              <a:rPr lang="en-US" sz="1400" b="1" dirty="0">
+                <a:solidFill>
+                  <a:srgbClr val="BE0000"/>
+                </a:solidFill>
+                <a:latin typeface="Calibri" pitchFamily="34" charset="0"/>
+                <a:ea typeface="Calibri" pitchFamily="34" charset="-122"/>
+                <a:cs typeface="Calibri" pitchFamily="34" charset="-120"/>
+              </a:rPr>
+              <a:t>How much differential signal a realistic dielectric target produces relative to metal</a:t>
+            </a:r>
+            <a:endParaRPr lang="en-US" sz="1400" dirty="0"/>
+          </a:p>
+        </p:txBody>
+      </p:sp>
+      <p:pic>
+        <p:nvPicPr>
+          <p:cNvPr id="4" name="Image 0" descr="beet_vs_metal_dS.png">    </p:cNvPr>
+          <p:cNvPicPr>
+            <a:picLocks noChangeAspect="1"/>
+          </p:cNvPicPr>
+          <p:nvPr/>
+        </p:nvPicPr>
+        <p:blipFill>
+          <a:blip r:embed="rId1"/>
+          <a:stretch>
+            <a:fillRect/>
+          </a:stretch>
+        </p:blipFill>
+        <p:spPr>
+          <a:xfrm>
+            <a:off x="822960" y="1737360"/>
+            <a:ext cx="10515600" cy="4892040"/>
+          </a:xfrm>
+          <a:prstGeom prst="rect">
+            <a:avLst/>
+          </a:prstGeom>
+        </p:spPr>
+      </p:pic>
+    </p:spTree>
+  </p:cSld>
+  <p:clrMapOvr>
+    <a:masterClrMapping/>
+  </p:clrMapOvr>
+</p:sld>
+</file>
+
+<file path=ppt/slides/slide11.xml><?xml version="1.0" encoding="utf-8"?>
+<p:sld xmlns:a="http://schemas.openxmlformats.org/drawingml/2006/main" xmlns:r="http://schemas.openxmlformats.org/officeDocument/2006/relationships" xmlns:p="http://schemas.openxmlformats.org/presentationml/2006/main">
+  <p:cSld name="Slide 11">
+    <p:bg>
+      <p:bgPr>
+        <a:solidFill>
+          <a:srgbClr val="FDF8F6"/>
+        </a:solidFill>
+      </p:bgPr>
+    </p:bg>
+    <p:spTree>
+      <p:nvGrpSpPr>
+        <p:cNvPr id="1" name=""/>
+        <p:cNvGrpSpPr/>
+        <p:nvPr/>
+      </p:nvGrpSpPr>
+      <p:grpSpPr>
+        <a:xfrm>
+          <a:off x="0" y="0"/>
+          <a:ext cx="0" cy="0"/>
+          <a:chOff x="0" y="0"/>
+          <a:chExt cx="0" cy="0"/>
+        </a:xfrm>
+      </p:grpSpPr>
+      <p:sp>
+        <p:nvSpPr>
+          <p:cNvPr id="2" name="Shape 0"/>
+          <p:cNvSpPr/>
+          <p:nvPr/>
+        </p:nvSpPr>
+        <p:spPr>
+          <a:xfrm>
+            <a:off x="0" y="0"/>
+            <a:ext cx="12188952" cy="237744"/>
+          </a:xfrm>
+          <a:prstGeom prst="rect">
+            <a:avLst/>
+          </a:prstGeom>
+          <a:solidFill>
+            <a:srgbClr val="BE0000"/>
+          </a:solidFill>
+          <a:ln/>
+        </p:spPr>
+      </p:sp>
+      <p:sp>
+        <p:nvSpPr>
+          <p:cNvPr id="3" name="Text 1"/>
+          <p:cNvSpPr/>
+          <p:nvPr/>
+        </p:nvSpPr>
+        <p:spPr>
+          <a:xfrm>
+            <a:off x="822960" y="640080"/>
+            <a:ext cx="10058400" cy="731520"/>
+          </a:xfrm>
+          <a:prstGeom prst="rect">
+            <a:avLst/>
+          </a:prstGeom>
+          <a:noFill/>
+          <a:ln/>
+        </p:spPr>
+        <p:txBody>
+          <a:bodyPr wrap="square" lIns="0" tIns="0" rIns="0" bIns="0" rtlCol="0" anchor="ctr"/>
+          <a:lstStyle/>
+          <a:p>
+            <a:pPr indent="0" marL="0">
+              <a:buNone/>
+            </a:pPr>
+            <a:r>
+              <a:rPr lang="en-US" sz="2800" b="1" dirty="0">
+                <a:solidFill>
+                  <a:srgbClr val="BE0000"/>
+                </a:solidFill>
+                <a:latin typeface="Cambria" pitchFamily="34" charset="0"/>
+                <a:ea typeface="Cambria" pitchFamily="34" charset="-122"/>
+                <a:cs typeface="Cambria" pitchFamily="34" charset="-120"/>
+              </a:rPr>
+              <a:t>Part 3, bottom line</a:t>
+            </a:r>
+            <a:endParaRPr lang="en-US" sz="2800" dirty="0"/>
+          </a:p>
+        </p:txBody>
+      </p:sp>
+      <p:sp>
+        <p:nvSpPr>
+          <p:cNvPr id="4" name="Shape 2"/>
+          <p:cNvSpPr/>
+          <p:nvPr/>
+        </p:nvSpPr>
+        <p:spPr>
+          <a:xfrm>
+            <a:off x="822960" y="1600200"/>
+            <a:ext cx="384048" cy="384048"/>
+          </a:xfrm>
+          <a:prstGeom prst="ellipse">
+            <a:avLst/>
+          </a:prstGeom>
+          <a:solidFill>
+            <a:srgbClr val="BE0000"/>
+          </a:solidFill>
+          <a:ln/>
+        </p:spPr>
+      </p:sp>
+      <p:sp>
+        <p:nvSpPr>
+          <p:cNvPr id="5" name="Text 3"/>
+          <p:cNvSpPr/>
+          <p:nvPr/>
+        </p:nvSpPr>
+        <p:spPr>
+          <a:xfrm>
+            <a:off x="822960" y="1600200"/>
+            <a:ext cx="384048" cy="384048"/>
+          </a:xfrm>
+          <a:prstGeom prst="rect">
+            <a:avLst/>
+          </a:prstGeom>
+          <a:noFill/>
+          <a:ln/>
+        </p:spPr>
+        <p:txBody>
+          <a:bodyPr wrap="square" lIns="0" tIns="0" rIns="0" bIns="0" rtlCol="0" anchor="ctr"/>
+          <a:lstStyle/>
+          <a:p>
+            <a:pPr algn="ctr" indent="0" marL="0">
+              <a:buNone/>
+            </a:pPr>
+            <a:r>
+              <a:rPr lang="en-US" sz="1500" b="1" dirty="0">
+                <a:solidFill>
+                  <a:srgbClr val="FFFFFF"/>
+                </a:solidFill>
+                <a:latin typeface="Cambria" pitchFamily="34" charset="0"/>
+                <a:ea typeface="Cambria" pitchFamily="34" charset="-122"/>
+                <a:cs typeface="Cambria" pitchFamily="34" charset="-120"/>
+              </a:rPr>
+              <a:t>1</a:t>
+            </a:r>
+            <a:endParaRPr lang="en-US" sz="1500" dirty="0"/>
+          </a:p>
+        </p:txBody>
+      </p:sp>
+      <p:sp>
+        <p:nvSpPr>
+          <p:cNvPr id="6" name="Text 4"/>
+          <p:cNvSpPr/>
+          <p:nvPr/>
+        </p:nvSpPr>
+        <p:spPr>
+          <a:xfrm>
+            <a:off x="1371600" y="1508760"/>
+            <a:ext cx="10241280" cy="868680"/>
+          </a:xfrm>
+          <a:prstGeom prst="rect">
+            <a:avLst/>
+          </a:prstGeom>
+          <a:noFill/>
+          <a:ln/>
+        </p:spPr>
+        <p:txBody>
+          <a:bodyPr wrap="square" lIns="0" tIns="0" rIns="0" bIns="0" rtlCol="0" anchor="ctr"/>
+          <a:lstStyle/>
+          <a:p>
+            <a:pPr indent="0" marL="0">
+              <a:buNone/>
+            </a:pPr>
+            <a:r>
+              <a:rPr lang="en-US" sz="1400" b="1" dirty="0">
+                <a:solidFill>
+                  <a:srgbClr val="2A1618"/>
+                </a:solidFill>
+                <a:latin typeface="Calibri" pitchFamily="34" charset="0"/>
+                <a:ea typeface="Calibri" pitchFamily="34" charset="-122"/>
+                <a:cs typeface="Calibri" pitchFamily="34" charset="-120"/>
+              </a:rPr>
+              <a:t>Sim and measured agree at the signal level:  </a:t>
+            </a:r>
+            <a:pPr indent="0" marL="0">
+              <a:buNone/>
+            </a:pPr>
+            <a:r>
+              <a:rPr lang="en-US" sz="1400" dirty="0">
+                <a:solidFill>
+                  <a:srgbClr val="836A68"/>
+                </a:solidFill>
+                <a:latin typeface="Calibri" pitchFamily="34" charset="0"/>
+                <a:ea typeface="Calibri" pitchFamily="34" charset="-122"/>
+                <a:cs typeface="Calibri" pitchFamily="34" charset="-120"/>
+              </a:rPr>
+              <a:t>the empty phantom interpolates to ~6 mm on both (k-NN), indicating the simulated signal is realistic.</a:t>
+            </a:r>
+            <a:endParaRPr lang="en-US" sz="1400" dirty="0"/>
+          </a:p>
+        </p:txBody>
+      </p:sp>
+      <p:sp>
+        <p:nvSpPr>
+          <p:cNvPr id="7" name="Shape 5"/>
+          <p:cNvSpPr/>
+          <p:nvPr/>
+        </p:nvSpPr>
+        <p:spPr>
+          <a:xfrm>
+            <a:off x="822960" y="2569464"/>
+            <a:ext cx="384048" cy="384048"/>
+          </a:xfrm>
+          <a:prstGeom prst="ellipse">
+            <a:avLst/>
+          </a:prstGeom>
+          <a:solidFill>
+            <a:srgbClr val="BE0000"/>
+          </a:solidFill>
+          <a:ln/>
+        </p:spPr>
+      </p:sp>
+      <p:sp>
+        <p:nvSpPr>
+          <p:cNvPr id="8" name="Text 6"/>
+          <p:cNvSpPr/>
+          <p:nvPr/>
+        </p:nvSpPr>
+        <p:spPr>
+          <a:xfrm>
+            <a:off x="822960" y="2569464"/>
+            <a:ext cx="384048" cy="384048"/>
+          </a:xfrm>
+          <a:prstGeom prst="rect">
+            <a:avLst/>
+          </a:prstGeom>
+          <a:noFill/>
+          <a:ln/>
+        </p:spPr>
+        <p:txBody>
+          <a:bodyPr wrap="square" lIns="0" tIns="0" rIns="0" bIns="0" rtlCol="0" anchor="ctr"/>
+          <a:lstStyle/>
+          <a:p>
+            <a:pPr algn="ctr" indent="0" marL="0">
+              <a:buNone/>
+            </a:pPr>
+            <a:r>
+              <a:rPr lang="en-US" sz="1500" b="1" dirty="0">
+                <a:solidFill>
+                  <a:srgbClr val="FFFFFF"/>
+                </a:solidFill>
+                <a:latin typeface="Cambria" pitchFamily="34" charset="0"/>
+                <a:ea typeface="Cambria" pitchFamily="34" charset="-122"/>
+                <a:cs typeface="Cambria" pitchFamily="34" charset="-120"/>
+              </a:rPr>
+              <a:t>2</a:t>
+            </a:r>
+            <a:endParaRPr lang="en-US" sz="1500" dirty="0"/>
+          </a:p>
+        </p:txBody>
+      </p:sp>
+      <p:sp>
+        <p:nvSpPr>
+          <p:cNvPr id="9" name="Text 7"/>
+          <p:cNvSpPr/>
+          <p:nvPr/>
+        </p:nvSpPr>
+        <p:spPr>
+          <a:xfrm>
+            <a:off x="1371600" y="2478024"/>
+            <a:ext cx="10241280" cy="868680"/>
+          </a:xfrm>
+          <a:prstGeom prst="rect">
+            <a:avLst/>
+          </a:prstGeom>
+          <a:noFill/>
+          <a:ln/>
+        </p:spPr>
+        <p:txBody>
+          <a:bodyPr wrap="square" lIns="0" tIns="0" rIns="0" bIns="0" rtlCol="0" anchor="ctr"/>
+          <a:lstStyle/>
+          <a:p>
+            <a:pPr indent="0" marL="0">
+              <a:buNone/>
+            </a:pPr>
+            <a:r>
+              <a:rPr lang="en-US" sz="1400" b="1" dirty="0">
+                <a:solidFill>
+                  <a:srgbClr val="2A1618"/>
+                </a:solidFill>
+                <a:latin typeface="Calibri" pitchFamily="34" charset="0"/>
+                <a:ea typeface="Calibri" pitchFamily="34" charset="-122"/>
+                <a:cs typeface="Calibri" pitchFamily="34" charset="-120"/>
+              </a:rPr>
+              <a:t>The detectable-difference pattern matches:  </a:t>
+            </a:r>
+            <a:pPr indent="0" marL="0">
+              <a:buNone/>
+            </a:pPr>
+            <a:r>
+              <a:rPr lang="en-US" sz="1400" dirty="0">
+                <a:solidFill>
+                  <a:srgbClr val="836A68"/>
+                </a:solidFill>
+                <a:latin typeface="Calibri" pitchFamily="34" charset="0"/>
+                <a:ea typeface="Calibri" pitchFamily="34" charset="-122"/>
+                <a:cs typeface="Calibri" pitchFamily="34" charset="-120"/>
+              </a:rPr>
+              <a:t>bench and sim place the tumor's strongest change in the same regions (toward the antenna sides).</a:t>
+            </a:r>
+            <a:endParaRPr lang="en-US" sz="1400" dirty="0"/>
+          </a:p>
+        </p:txBody>
+      </p:sp>
+      <p:sp>
+        <p:nvSpPr>
+          <p:cNvPr id="10" name="Shape 8"/>
+          <p:cNvSpPr/>
+          <p:nvPr/>
+        </p:nvSpPr>
+        <p:spPr>
+          <a:xfrm>
+            <a:off x="822960" y="3538728"/>
+            <a:ext cx="384048" cy="384048"/>
+          </a:xfrm>
+          <a:prstGeom prst="ellipse">
+            <a:avLst/>
+          </a:prstGeom>
+          <a:solidFill>
+            <a:srgbClr val="BE0000"/>
+          </a:solidFill>
+          <a:ln/>
+        </p:spPr>
+      </p:sp>
+      <p:sp>
+        <p:nvSpPr>
+          <p:cNvPr id="11" name="Text 9"/>
+          <p:cNvSpPr/>
+          <p:nvPr/>
+        </p:nvSpPr>
+        <p:spPr>
+          <a:xfrm>
+            <a:off x="822960" y="3538728"/>
+            <a:ext cx="384048" cy="384048"/>
+          </a:xfrm>
+          <a:prstGeom prst="rect">
+            <a:avLst/>
+          </a:prstGeom>
+          <a:noFill/>
+          <a:ln/>
+        </p:spPr>
+        <p:txBody>
+          <a:bodyPr wrap="square" lIns="0" tIns="0" rIns="0" bIns="0" rtlCol="0" anchor="ctr"/>
+          <a:lstStyle/>
+          <a:p>
+            <a:pPr algn="ctr" indent="0" marL="0">
+              <a:buNone/>
+            </a:pPr>
+            <a:r>
+              <a:rPr lang="en-US" sz="1500" b="1" dirty="0">
+                <a:solidFill>
+                  <a:srgbClr val="FFFFFF"/>
+                </a:solidFill>
+                <a:latin typeface="Cambria" pitchFamily="34" charset="0"/>
+                <a:ea typeface="Cambria" pitchFamily="34" charset="-122"/>
+                <a:cs typeface="Cambria" pitchFamily="34" charset="-120"/>
+              </a:rPr>
+              <a:t>3</a:t>
+            </a:r>
+            <a:endParaRPr lang="en-US" sz="1500" dirty="0"/>
+          </a:p>
+        </p:txBody>
+      </p:sp>
+      <p:sp>
+        <p:nvSpPr>
+          <p:cNvPr id="12" name="Text 10"/>
+          <p:cNvSpPr/>
+          <p:nvPr/>
+        </p:nvSpPr>
+        <p:spPr>
+          <a:xfrm>
+            <a:off x="1371600" y="3447288"/>
+            <a:ext cx="10241280" cy="868680"/>
+          </a:xfrm>
+          <a:prstGeom prst="rect">
+            <a:avLst/>
+          </a:prstGeom>
+          <a:noFill/>
+          <a:ln/>
+        </p:spPr>
+        <p:txBody>
+          <a:bodyPr wrap="square" lIns="0" tIns="0" rIns="0" bIns="0" rtlCol="0" anchor="ctr"/>
+          <a:lstStyle/>
+          <a:p>
+            <a:pPr indent="0" marL="0">
+              <a:buNone/>
+            </a:pPr>
+            <a:r>
+              <a:rPr lang="en-US" sz="1400" b="1" dirty="0">
+                <a:solidFill>
+                  <a:srgbClr val="2A1618"/>
+                </a:solidFill>
+                <a:latin typeface="Calibri" pitchFamily="34" charset="0"/>
+                <a:ea typeface="Calibri" pitchFamily="34" charset="-122"/>
+                <a:cs typeface="Calibri" pitchFamily="34" charset="-120"/>
+              </a:rPr>
+              <a:t>The CNN gap is data coverage, not fidelity:  </a:t>
+            </a:r>
+            <a:pPr indent="0" marL="0">
+              <a:buNone/>
+            </a:pPr>
+            <a:r>
+              <a:rPr lang="en-US" sz="1400" dirty="0">
+                <a:solidFill>
+                  <a:srgbClr val="836A68"/>
+                </a:solidFill>
+                <a:latin typeface="Calibri" pitchFamily="34" charset="0"/>
+                <a:ea typeface="Calibri" pitchFamily="34" charset="-122"/>
+                <a:cs typeface="Calibri" pitchFamily="34" charset="-120"/>
+              </a:rPr>
+              <a:t>sim's 3.9 mm comes from ~1000 distinct positions; measured's 9.9 mm from only ~50. Same model, different coverage.</a:t>
+            </a:r>
+            <a:endParaRPr lang="en-US" sz="1400" dirty="0"/>
+          </a:p>
+        </p:txBody>
+      </p:sp>
+      <p:sp>
+        <p:nvSpPr>
+          <p:cNvPr id="13" name="Shape 11"/>
+          <p:cNvSpPr/>
+          <p:nvPr/>
+        </p:nvSpPr>
+        <p:spPr>
+          <a:xfrm>
+            <a:off x="822960" y="4507992"/>
+            <a:ext cx="384048" cy="384048"/>
+          </a:xfrm>
+          <a:prstGeom prst="ellipse">
+            <a:avLst/>
+          </a:prstGeom>
+          <a:solidFill>
+            <a:srgbClr val="BE0000"/>
+          </a:solidFill>
+          <a:ln/>
+        </p:spPr>
+      </p:sp>
+      <p:sp>
+        <p:nvSpPr>
+          <p:cNvPr id="14" name="Text 12"/>
+          <p:cNvSpPr/>
+          <p:nvPr/>
+        </p:nvSpPr>
+        <p:spPr>
+          <a:xfrm>
+            <a:off x="822960" y="4507992"/>
+            <a:ext cx="384048" cy="384048"/>
+          </a:xfrm>
+          <a:prstGeom prst="rect">
+            <a:avLst/>
+          </a:prstGeom>
+          <a:noFill/>
+          <a:ln/>
+        </p:spPr>
+        <p:txBody>
+          <a:bodyPr wrap="square" lIns="0" tIns="0" rIns="0" bIns="0" rtlCol="0" anchor="ctr"/>
+          <a:lstStyle/>
+          <a:p>
+            <a:pPr algn="ctr" indent="0" marL="0">
+              <a:buNone/>
+            </a:pPr>
+            <a:r>
+              <a:rPr lang="en-US" sz="1500" b="1" dirty="0">
+                <a:solidFill>
+                  <a:srgbClr val="FFFFFF"/>
+                </a:solidFill>
+                <a:latin typeface="Cambria" pitchFamily="34" charset="0"/>
+                <a:ea typeface="Cambria" pitchFamily="34" charset="-122"/>
+                <a:cs typeface="Cambria" pitchFamily="34" charset="-120"/>
+              </a:rPr>
+              <a:t>4</a:t>
+            </a:r>
+            <a:endParaRPr lang="en-US" sz="1500" dirty="0"/>
+          </a:p>
+        </p:txBody>
+      </p:sp>
+      <p:sp>
+        <p:nvSpPr>
+          <p:cNvPr id="15" name="Text 13"/>
+          <p:cNvSpPr/>
+          <p:nvPr/>
+        </p:nvSpPr>
+        <p:spPr>
+          <a:xfrm>
+            <a:off x="1371600" y="4416552"/>
+            <a:ext cx="10241280" cy="868680"/>
+          </a:xfrm>
+          <a:prstGeom prst="rect">
+            <a:avLst/>
+          </a:prstGeom>
+          <a:noFill/>
+          <a:ln/>
+        </p:spPr>
+        <p:txBody>
+          <a:bodyPr wrap="square" lIns="0" tIns="0" rIns="0" bIns="0" rtlCol="0" anchor="ctr"/>
+          <a:lstStyle/>
+          <a:p>
+            <a:pPr indent="0" marL="0">
+              <a:buNone/>
+            </a:pPr>
+            <a:r>
+              <a:rPr lang="en-US" sz="1400" b="1" dirty="0">
+                <a:solidFill>
+                  <a:srgbClr val="2A1618"/>
+                </a:solidFill>
+                <a:latin typeface="Calibri" pitchFamily="34" charset="0"/>
+                <a:ea typeface="Calibri" pitchFamily="34" charset="-122"/>
+                <a:cs typeface="Calibri" pitchFamily="34" charset="-120"/>
+              </a:rPr>
+              <a:t>Sim predicts beet approximately equals metal, but the bench does not:  </a:t>
+            </a:r>
+            <a:pPr indent="0" marL="0">
+              <a:buNone/>
+            </a:pPr>
+            <a:r>
+              <a:rPr lang="en-US" sz="1400" dirty="0">
+                <a:solidFill>
+                  <a:srgbClr val="836A68"/>
+                </a:solidFill>
+                <a:latin typeface="Calibri" pitchFamily="34" charset="0"/>
+                <a:ea typeface="Calibri" pitchFamily="34" charset="-122"/>
+                <a:cs typeface="Calibri" pitchFamily="34" charset="-120"/>
+              </a:rPr>
+              <a:t>in sim the beet produces 93% of the metal signal; on the bench only 42%, flagging an object-size / depth mismatch or an optimistic sim beet model.</a:t>
+            </a:r>
+            <a:endParaRPr lang="en-US" sz="1400" dirty="0"/>
+          </a:p>
+        </p:txBody>
+      </p:sp>
+      <p:sp>
+        <p:nvSpPr>
+          <p:cNvPr id="16" name="Shape 14"/>
+          <p:cNvSpPr/>
+          <p:nvPr/>
+        </p:nvSpPr>
+        <p:spPr>
+          <a:xfrm>
+            <a:off x="822960" y="5477256"/>
+            <a:ext cx="384048" cy="384048"/>
+          </a:xfrm>
+          <a:prstGeom prst="ellipse">
+            <a:avLst/>
+          </a:prstGeom>
+          <a:solidFill>
+            <a:srgbClr val="BE0000"/>
+          </a:solidFill>
+          <a:ln/>
+        </p:spPr>
+      </p:sp>
+      <p:sp>
+        <p:nvSpPr>
+          <p:cNvPr id="17" name="Text 15"/>
+          <p:cNvSpPr/>
+          <p:nvPr/>
+        </p:nvSpPr>
+        <p:spPr>
+          <a:xfrm>
+            <a:off x="822960" y="5477256"/>
+            <a:ext cx="384048" cy="384048"/>
+          </a:xfrm>
+          <a:prstGeom prst="rect">
+            <a:avLst/>
+          </a:prstGeom>
+          <a:noFill/>
+          <a:ln/>
+        </p:spPr>
+        <p:txBody>
+          <a:bodyPr wrap="square" lIns="0" tIns="0" rIns="0" bIns="0" rtlCol="0" anchor="ctr"/>
+          <a:lstStyle/>
+          <a:p>
+            <a:pPr algn="ctr" indent="0" marL="0">
+              <a:buNone/>
+            </a:pPr>
+            <a:r>
+              <a:rPr lang="en-US" sz="1500" b="1" dirty="0">
+                <a:solidFill>
+                  <a:srgbClr val="FFFFFF"/>
+                </a:solidFill>
+                <a:latin typeface="Cambria" pitchFamily="34" charset="0"/>
+                <a:ea typeface="Cambria" pitchFamily="34" charset="-122"/>
+                <a:cs typeface="Cambria" pitchFamily="34" charset="-120"/>
+              </a:rPr>
+              <a:t>5</a:t>
+            </a:r>
+            <a:endParaRPr lang="en-US" sz="1500" dirty="0"/>
+          </a:p>
+        </p:txBody>
+      </p:sp>
+      <p:sp>
+        <p:nvSpPr>
+          <p:cNvPr id="18" name="Text 16"/>
+          <p:cNvSpPr/>
+          <p:nvPr/>
+        </p:nvSpPr>
+        <p:spPr>
+          <a:xfrm>
+            <a:off x="1371600" y="5385816"/>
+            <a:ext cx="10241280" cy="868680"/>
+          </a:xfrm>
+          <a:prstGeom prst="rect">
+            <a:avLst/>
+          </a:prstGeom>
+          <a:noFill/>
+          <a:ln/>
+        </p:spPr>
+        <p:txBody>
+          <a:bodyPr wrap="square" lIns="0" tIns="0" rIns="0" bIns="0" rtlCol="0" anchor="ctr"/>
+          <a:lstStyle/>
+          <a:p>
+            <a:pPr indent="0" marL="0">
+              <a:buNone/>
+            </a:pPr>
+            <a:r>
+              <a:rPr lang="en-US" sz="1400" b="1" dirty="0">
+                <a:solidFill>
+                  <a:srgbClr val="2A1618"/>
+                </a:solidFill>
+                <a:latin typeface="Calibri" pitchFamily="34" charset="0"/>
+                <a:ea typeface="Calibri" pitchFamily="34" charset="-122"/>
+                <a:cs typeface="Calibri" pitchFamily="34" charset="-120"/>
+              </a:rPr>
+              <a:t>A sim to measured transfer is learnable:  </a:t>
+            </a:r>
+            <a:pPr indent="0" marL="0">
+              <a:buNone/>
+            </a:pPr>
+            <a:r>
+              <a:rPr lang="en-US" sz="1400" dirty="0">
+                <a:solidFill>
+                  <a:srgbClr val="836A68"/>
+                </a:solidFill>
+                <a:latin typeface="Calibri" pitchFamily="34" charset="0"/>
+                <a:ea typeface="Calibri" pitchFamily="34" charset="-122"/>
+                <a:cs typeface="Calibri" pitchFamily="34" charset="-120"/>
+              </a:rPr>
+              <a:t>a linear map already reaches R2 = 0.65 on unseen frequencies, a promising if preliminary calibration path.</a:t>
+            </a:r>
+            <a:endParaRPr lang="en-US" sz="1400" dirty="0"/>
+          </a:p>
+        </p:txBody>
+      </p:sp>
+      <p:sp>
+        <p:nvSpPr>
+          <p:cNvPr id="19" name="Text 17"/>
+          <p:cNvSpPr/>
+          <p:nvPr/>
+        </p:nvSpPr>
+        <p:spPr>
+          <a:xfrm>
+            <a:off x="822960" y="6400800"/>
+            <a:ext cx="10515600" cy="320040"/>
+          </a:xfrm>
+          <a:prstGeom prst="rect">
+            <a:avLst/>
+          </a:prstGeom>
+          <a:noFill/>
+          <a:ln/>
+        </p:spPr>
+        <p:txBody>
+          <a:bodyPr wrap="square" lIns="0" tIns="0" rIns="0" bIns="0" rtlCol="0" anchor="ctr"/>
+          <a:lstStyle/>
+          <a:p>
+            <a:pPr indent="0" marL="0">
+              <a:buNone/>
+            </a:pPr>
+            <a:r>
+              <a:rPr lang="en-US" sz="1100" dirty="0">
+                <a:solidFill>
+                  <a:srgbClr val="BE0000"/>
+                </a:solidFill>
+                <a:latin typeface="Calibri" pitchFamily="34" charset="0"/>
+                <a:ea typeface="Calibri" pitchFamily="34" charset="-122"/>
+                <a:cs typeface="Calibri" pitchFamily="34" charset="-120"/>
+              </a:rPr>
+              <a:t>github.com/pmart1534/microwave-phantom-localization-cnn-mlp</a:t>
+            </a:r>
+            <a:endParaRPr lang="en-US" sz="1100" dirty="0"/>
+          </a:p>
+        </p:txBody>
+      </p:sp>
+    </p:spTree>
+  </p:cSld>
+  <p:clrMapOvr>
+    <a:masterClrMapping/>
+  </p:clrMapOvr>
+</p:sld>
+</file>
+
 <file path=ppt/slides/slide2.xml><?xml version="1.0" encoding="utf-8"?>
 <p:sld xmlns:a="http://schemas.openxmlformats.org/drawingml/2006/main" xmlns:r="http://schemas.openxmlformats.org/officeDocument/2006/relationships" xmlns:p="http://schemas.openxmlformats.org/presentationml/2006/main">
   <p:cSld name="Slide 2">
@@ -4226,7 +5228,7 @@
                 <a:ea typeface="Cambria" pitchFamily="34" charset="-122"/>
                 <a:cs typeface="Cambria" pitchFamily="34" charset="-120"/>
               </a:rPr>
-              <a:t>Detectable-difference pattern, measured vs sim</a:t>
+              <a:t>Transmission (coupling) per pair, sim vs measured</a:t>
             </a:r>
             <a:endParaRPr lang="en-US" sz="2900" dirty="0"/>
           </a:p>
@@ -4265,7 +5267,7 @@
                 <a:ea typeface="Calibri" pitchFamily="34" charset="-122"/>
                 <a:cs typeface="Calibri" pitchFamily="34" charset="-120"/>
               </a:rPr>
-              <a:t>The tumor's detectable change per position; the spatial pattern matches</a:t>
+              <a:t>Four representative antenna-to-antenna terms; couplings also differ between domains</a:t>
             </a:r>
             <a:endParaRPr lang="en-US" sz="1400" dirty="0"/>
           </a:p>
@@ -4273,7 +5275,7 @@
       </p:sp>
       <p:pic>
         <p:nvPicPr>
-          <p:cNvPr id="4" name="Image 0" descr="dd_measured_vs_sim.png">    </p:cNvPr>
+          <p:cNvPr id="4" name="Image 0" descr="transmission_sim_vs_meas.png">    </p:cNvPr>
           <p:cNvPicPr>
             <a:picLocks noChangeAspect="1"/>
           </p:cNvPicPr>
@@ -4287,8 +5289,8 @@
         </p:blipFill>
         <p:spPr>
           <a:xfrm>
-            <a:off x="822960" y="1600200"/>
-            <a:ext cx="10515600" cy="4892040"/>
+            <a:off x="2148840" y="1554480"/>
+            <a:ext cx="7863840" cy="4828032"/>
           </a:xfrm>
           <a:prstGeom prst="rect">
             <a:avLst/>
@@ -4360,6 +5362,140 @@
                 <a:ea typeface="Cambria" pitchFamily="34" charset="-122"/>
                 <a:cs typeface="Cambria" pitchFamily="34" charset="-120"/>
               </a:rPr>
+              <a:t>Detectable difference by S-parameter</a:t>
+            </a:r>
+            <a:endParaRPr lang="en-US" sz="2900" dirty="0"/>
+          </a:p>
+        </p:txBody>
+      </p:sp>
+      <p:sp>
+        <p:nvSpPr>
+          <p:cNvPr id="3" name="Text 1"/>
+          <p:cNvSpPr/>
+          <p:nvPr/>
+        </p:nvSpPr>
+        <p:spPr>
+          <a:xfrm>
+            <a:off x="548640" y="1033272"/>
+            <a:ext cx="11091672" cy="365760"/>
+          </a:xfrm>
+          <a:prstGeom prst="rect">
+            <a:avLst/>
+          </a:prstGeom>
+          <a:noFill/>
+          <a:ln/>
+        </p:spPr>
+        <p:txBody>
+          <a:bodyPr wrap="square" lIns="0" tIns="0" rIns="0" bIns="0" rtlCol="0" anchor="ctr"/>
+          <a:lstStyle/>
+          <a:p>
+            <a:pPr indent="0" marL="0">
+              <a:buNone/>
+            </a:pPr>
+            <a:r>
+              <a:rPr lang="en-US" sz="1400" b="1" dirty="0">
+                <a:solidFill>
+                  <a:srgbClr val="BE0000"/>
+                </a:solidFill>
+                <a:latin typeface="Calibri" pitchFamily="34" charset="0"/>
+                <a:ea typeface="Calibri" pitchFamily="34" charset="-122"/>
+                <a:cs typeface="Calibri" pitchFamily="34" charset="-120"/>
+              </a:rPr>
+              <a:t>Each reflection Sii localizes near an antenna, in measured (top) and simulated (bottom)</a:t>
+            </a:r>
+            <a:endParaRPr lang="en-US" sz="1400" dirty="0"/>
+          </a:p>
+        </p:txBody>
+      </p:sp>
+      <p:pic>
+        <p:nvPicPr>
+          <p:cNvPr id="4" name="Image 0" descr="dd_per_sparam.png">    </p:cNvPr>
+          <p:cNvPicPr>
+            <a:picLocks noChangeAspect="1"/>
+          </p:cNvPicPr>
+          <p:nvPr/>
+        </p:nvPicPr>
+        <p:blipFill>
+          <a:blip r:embed="rId1"/>
+          <a:stretch>
+            <a:fillRect/>
+          </a:stretch>
+        </p:blipFill>
+        <p:spPr>
+          <a:xfrm>
+            <a:off x="274320" y="1417320"/>
+            <a:ext cx="11612880" cy="5074920"/>
+          </a:xfrm>
+          <a:prstGeom prst="rect">
+            <a:avLst/>
+          </a:prstGeom>
+        </p:spPr>
+      </p:pic>
+    </p:spTree>
+  </p:cSld>
+  <p:clrMapOvr>
+    <a:masterClrMapping/>
+  </p:clrMapOvr>
+</p:sld>
+</file>
+
+<file path=ppt/slides/slide8.xml><?xml version="1.0" encoding="utf-8"?>
+<p:sld xmlns:a="http://schemas.openxmlformats.org/drawingml/2006/main" xmlns:r="http://schemas.openxmlformats.org/officeDocument/2006/relationships" xmlns:p="http://schemas.openxmlformats.org/presentationml/2006/main">
+  <p:cSld name="Slide 8">
+    <p:bg>
+      <p:bgPr>
+        <a:solidFill>
+          <a:srgbClr val="FFFFFF"/>
+        </a:solidFill>
+      </p:bgPr>
+    </p:bg>
+    <p:spTree>
+      <p:nvGrpSpPr>
+        <p:cNvPr id="1" name=""/>
+        <p:cNvGrpSpPr/>
+        <p:nvPr/>
+      </p:nvGrpSpPr>
+      <p:grpSpPr>
+        <a:xfrm>
+          <a:off x="0" y="0"/>
+          <a:ext cx="0" cy="0"/>
+          <a:chOff x="0" y="0"/>
+          <a:chExt cx="0" cy="0"/>
+        </a:xfrm>
+      </p:grpSpPr>
+      <p:sp>
+        <p:nvSpPr>
+          <p:cNvPr id="2" name="Text 0"/>
+          <p:cNvSpPr/>
+          <p:nvPr/>
+        </p:nvSpPr>
+        <p:spPr>
+          <a:xfrm>
+            <a:off x="548640" y="384048"/>
+            <a:ext cx="11091672" cy="640080"/>
+          </a:xfrm>
+          <a:prstGeom prst="rect">
+            <a:avLst/>
+          </a:prstGeom>
+          <a:noFill/>
+          <a:ln/>
+        </p:spPr>
+        <p:txBody>
+          <a:bodyPr wrap="square" lIns="0" tIns="0" rIns="0" bIns="0" rtlCol="0" anchor="ctr"/>
+          <a:lstStyle/>
+          <a:p>
+            <a:pPr indent="0" marL="0">
+              <a:buNone/>
+            </a:pPr>
+            <a:r>
+              <a:rPr lang="en-US" sz="2900" b="1" dirty="0">
+                <a:solidFill>
+                  <a:srgbClr val="2A1618"/>
+                </a:solidFill>
+                <a:latin typeface="Cambria" pitchFamily="34" charset="0"/>
+                <a:ea typeface="Cambria" pitchFamily="34" charset="-122"/>
+                <a:cs typeface="Cambria" pitchFamily="34" charset="-120"/>
+              </a:rPr>
               <a:t>The numbers, signal vs. model</a:t>
             </a:r>
             <a:endParaRPr lang="en-US" sz="2900" dirty="0"/>
@@ -4407,7 +5543,7 @@
       </p:sp>
       <p:graphicFrame>
         <p:nvGraphicFramePr>
-          <p:cNvPr id="8" name="Table 0"/>
+          <p:cNvPr id="9" name="Table 0"/>
           <p:cNvGraphicFramePr>
             <a:graphicFrameLocks noGrp="1"/>
           </p:cNvGraphicFramePr>
@@ -5783,9 +6919,9 @@
 </p:sld>
 </file>
 
-<file path=ppt/slides/slide8.xml><?xml version="1.0" encoding="utf-8"?>
+<file path=ppt/slides/slide9.xml><?xml version="1.0" encoding="utf-8"?>
 <p:sld xmlns:a="http://schemas.openxmlformats.org/drawingml/2006/main" xmlns:r="http://schemas.openxmlformats.org/officeDocument/2006/relationships" xmlns:p="http://schemas.openxmlformats.org/presentationml/2006/main">
-  <p:cSld name="Slide 8">
+  <p:cSld name="Slide 9">
     <p:bg>
       <p:bgPr>
         <a:solidFill>
@@ -6103,696 +7239,6 @@
               <a:t>Preliminary: only the empty baseline is cleanly paired. Nonlinear domain adaptation (and any use for calibrating sim toward the bench) needs far more paired data: multiple sessions and, ideally, matched tumor positions.</a:t>
             </a:r>
             <a:endParaRPr lang="en-US" sz="1250" dirty="0"/>
-          </a:p>
-        </p:txBody>
-      </p:sp>
-    </p:spTree>
-  </p:cSld>
-  <p:clrMapOvr>
-    <a:masterClrMapping/>
-  </p:clrMapOvr>
-</p:sld>
-</file>
-
-<file path=ppt/slides/slide9.xml><?xml version="1.0" encoding="utf-8"?>
-<p:sld xmlns:a="http://schemas.openxmlformats.org/drawingml/2006/main" xmlns:r="http://schemas.openxmlformats.org/officeDocument/2006/relationships" xmlns:p="http://schemas.openxmlformats.org/presentationml/2006/main">
-  <p:cSld name="Slide 9">
-    <p:bg>
-      <p:bgPr>
-        <a:solidFill>
-          <a:srgbClr val="FDF8F6"/>
-        </a:solidFill>
-      </p:bgPr>
-    </p:bg>
-    <p:spTree>
-      <p:nvGrpSpPr>
-        <p:cNvPr id="1" name=""/>
-        <p:cNvGrpSpPr/>
-        <p:nvPr/>
-      </p:nvGrpSpPr>
-      <p:grpSpPr>
-        <a:xfrm>
-          <a:off x="0" y="0"/>
-          <a:ext cx="0" cy="0"/>
-          <a:chOff x="0" y="0"/>
-          <a:chExt cx="0" cy="0"/>
-        </a:xfrm>
-      </p:grpSpPr>
-      <p:sp>
-        <p:nvSpPr>
-          <p:cNvPr id="2" name="Shape 0"/>
-          <p:cNvSpPr/>
-          <p:nvPr/>
-        </p:nvSpPr>
-        <p:spPr>
-          <a:xfrm>
-            <a:off x="0" y="0"/>
-            <a:ext cx="12188952" cy="237744"/>
-          </a:xfrm>
-          <a:prstGeom prst="rect">
-            <a:avLst/>
-          </a:prstGeom>
-          <a:solidFill>
-            <a:srgbClr val="BE0000"/>
-          </a:solidFill>
-          <a:ln/>
-        </p:spPr>
-      </p:sp>
-      <p:sp>
-        <p:nvSpPr>
-          <p:cNvPr id="3" name="Text 1"/>
-          <p:cNvSpPr/>
-          <p:nvPr/>
-        </p:nvSpPr>
-        <p:spPr>
-          <a:xfrm>
-            <a:off x="822960" y="640080"/>
-            <a:ext cx="10058400" cy="731520"/>
-          </a:xfrm>
-          <a:prstGeom prst="rect">
-            <a:avLst/>
-          </a:prstGeom>
-          <a:noFill/>
-          <a:ln/>
-        </p:spPr>
-        <p:txBody>
-          <a:bodyPr wrap="square" lIns="0" tIns="0" rIns="0" bIns="0" rtlCol="0" anchor="ctr"/>
-          <a:lstStyle/>
-          <a:p>
-            <a:pPr indent="0" marL="0">
-              <a:buNone/>
-            </a:pPr>
-            <a:r>
-              <a:rPr lang="en-US" sz="2800" b="1" dirty="0">
-                <a:solidFill>
-                  <a:srgbClr val="BE0000"/>
-                </a:solidFill>
-                <a:latin typeface="Cambria" pitchFamily="34" charset="0"/>
-                <a:ea typeface="Cambria" pitchFamily="34" charset="-122"/>
-                <a:cs typeface="Cambria" pitchFamily="34" charset="-120"/>
-              </a:rPr>
-              <a:t>Part 3, bottom line</a:t>
-            </a:r>
-            <a:endParaRPr lang="en-US" sz="2800" dirty="0"/>
-          </a:p>
-        </p:txBody>
-      </p:sp>
-      <p:sp>
-        <p:nvSpPr>
-          <p:cNvPr id="4" name="Shape 2"/>
-          <p:cNvSpPr/>
-          <p:nvPr/>
-        </p:nvSpPr>
-        <p:spPr>
-          <a:xfrm>
-            <a:off x="822960" y="1600200"/>
-            <a:ext cx="384048" cy="384048"/>
-          </a:xfrm>
-          <a:prstGeom prst="ellipse">
-            <a:avLst/>
-          </a:prstGeom>
-          <a:solidFill>
-            <a:srgbClr val="BE0000"/>
-          </a:solidFill>
-          <a:ln/>
-        </p:spPr>
-      </p:sp>
-      <p:sp>
-        <p:nvSpPr>
-          <p:cNvPr id="5" name="Text 3"/>
-          <p:cNvSpPr/>
-          <p:nvPr/>
-        </p:nvSpPr>
-        <p:spPr>
-          <a:xfrm>
-            <a:off x="822960" y="1600200"/>
-            <a:ext cx="384048" cy="384048"/>
-          </a:xfrm>
-          <a:prstGeom prst="rect">
-            <a:avLst/>
-          </a:prstGeom>
-          <a:noFill/>
-          <a:ln/>
-        </p:spPr>
-        <p:txBody>
-          <a:bodyPr wrap="square" lIns="0" tIns="0" rIns="0" bIns="0" rtlCol="0" anchor="ctr"/>
-          <a:lstStyle/>
-          <a:p>
-            <a:pPr algn="ctr" indent="0" marL="0">
-              <a:buNone/>
-            </a:pPr>
-            <a:r>
-              <a:rPr lang="en-US" sz="1500" b="1" dirty="0">
-                <a:solidFill>
-                  <a:srgbClr val="FFFFFF"/>
-                </a:solidFill>
-                <a:latin typeface="Cambria" pitchFamily="34" charset="0"/>
-                <a:ea typeface="Cambria" pitchFamily="34" charset="-122"/>
-                <a:cs typeface="Cambria" pitchFamily="34" charset="-120"/>
-              </a:rPr>
-              <a:t>1</a:t>
-            </a:r>
-            <a:endParaRPr lang="en-US" sz="1500" dirty="0"/>
-          </a:p>
-        </p:txBody>
-      </p:sp>
-      <p:sp>
-        <p:nvSpPr>
-          <p:cNvPr id="6" name="Text 4"/>
-          <p:cNvSpPr/>
-          <p:nvPr/>
-        </p:nvSpPr>
-        <p:spPr>
-          <a:xfrm>
-            <a:off x="1371600" y="1508760"/>
-            <a:ext cx="10241280" cy="868680"/>
-          </a:xfrm>
-          <a:prstGeom prst="rect">
-            <a:avLst/>
-          </a:prstGeom>
-          <a:noFill/>
-          <a:ln/>
-        </p:spPr>
-        <p:txBody>
-          <a:bodyPr wrap="square" lIns="0" tIns="0" rIns="0" bIns="0" rtlCol="0" anchor="ctr"/>
-          <a:lstStyle/>
-          <a:p>
-            <a:pPr indent="0" marL="0">
-              <a:buNone/>
-            </a:pPr>
-            <a:r>
-              <a:rPr lang="en-US" sz="1400" b="1" dirty="0">
-                <a:solidFill>
-                  <a:srgbClr val="2A1618"/>
-                </a:solidFill>
-                <a:latin typeface="Calibri" pitchFamily="34" charset="0"/>
-                <a:ea typeface="Calibri" pitchFamily="34" charset="-122"/>
-                <a:cs typeface="Calibri" pitchFamily="34" charset="-120"/>
-              </a:rPr>
-              <a:t>Sim and measured agree at the signal level:  </a:t>
-            </a:r>
-            <a:pPr indent="0" marL="0">
-              <a:buNone/>
-            </a:pPr>
-            <a:r>
-              <a:rPr lang="en-US" sz="1400" dirty="0">
-                <a:solidFill>
-                  <a:srgbClr val="836A68"/>
-                </a:solidFill>
-                <a:latin typeface="Calibri" pitchFamily="34" charset="0"/>
-                <a:ea typeface="Calibri" pitchFamily="34" charset="-122"/>
-                <a:cs typeface="Calibri" pitchFamily="34" charset="-120"/>
-              </a:rPr>
-              <a:t>the empty phantom interpolates to ~6 mm on both (k-NN), indicating the simulated signal is realistic.</a:t>
-            </a:r>
-            <a:endParaRPr lang="en-US" sz="1400" dirty="0"/>
-          </a:p>
-        </p:txBody>
-      </p:sp>
-      <p:sp>
-        <p:nvSpPr>
-          <p:cNvPr id="7" name="Shape 5"/>
-          <p:cNvSpPr/>
-          <p:nvPr/>
-        </p:nvSpPr>
-        <p:spPr>
-          <a:xfrm>
-            <a:off x="822960" y="2569464"/>
-            <a:ext cx="384048" cy="384048"/>
-          </a:xfrm>
-          <a:prstGeom prst="ellipse">
-            <a:avLst/>
-          </a:prstGeom>
-          <a:solidFill>
-            <a:srgbClr val="BE0000"/>
-          </a:solidFill>
-          <a:ln/>
-        </p:spPr>
-      </p:sp>
-      <p:sp>
-        <p:nvSpPr>
-          <p:cNvPr id="8" name="Text 6"/>
-          <p:cNvSpPr/>
-          <p:nvPr/>
-        </p:nvSpPr>
-        <p:spPr>
-          <a:xfrm>
-            <a:off x="822960" y="2569464"/>
-            <a:ext cx="384048" cy="384048"/>
-          </a:xfrm>
-          <a:prstGeom prst="rect">
-            <a:avLst/>
-          </a:prstGeom>
-          <a:noFill/>
-          <a:ln/>
-        </p:spPr>
-        <p:txBody>
-          <a:bodyPr wrap="square" lIns="0" tIns="0" rIns="0" bIns="0" rtlCol="0" anchor="ctr"/>
-          <a:lstStyle/>
-          <a:p>
-            <a:pPr algn="ctr" indent="0" marL="0">
-              <a:buNone/>
-            </a:pPr>
-            <a:r>
-              <a:rPr lang="en-US" sz="1500" b="1" dirty="0">
-                <a:solidFill>
-                  <a:srgbClr val="FFFFFF"/>
-                </a:solidFill>
-                <a:latin typeface="Cambria" pitchFamily="34" charset="0"/>
-                <a:ea typeface="Cambria" pitchFamily="34" charset="-122"/>
-                <a:cs typeface="Cambria" pitchFamily="34" charset="-120"/>
-              </a:rPr>
-              <a:t>2</a:t>
-            </a:r>
-            <a:endParaRPr lang="en-US" sz="1500" dirty="0"/>
-          </a:p>
-        </p:txBody>
-      </p:sp>
-      <p:sp>
-        <p:nvSpPr>
-          <p:cNvPr id="9" name="Text 7"/>
-          <p:cNvSpPr/>
-          <p:nvPr/>
-        </p:nvSpPr>
-        <p:spPr>
-          <a:xfrm>
-            <a:off x="1371600" y="2478024"/>
-            <a:ext cx="10241280" cy="868680"/>
-          </a:xfrm>
-          <a:prstGeom prst="rect">
-            <a:avLst/>
-          </a:prstGeom>
-          <a:noFill/>
-          <a:ln/>
-        </p:spPr>
-        <p:txBody>
-          <a:bodyPr wrap="square" lIns="0" tIns="0" rIns="0" bIns="0" rtlCol="0" anchor="ctr"/>
-          <a:lstStyle/>
-          <a:p>
-            <a:pPr indent="0" marL="0">
-              <a:buNone/>
-            </a:pPr>
-            <a:r>
-              <a:rPr lang="en-US" sz="1400" b="1" dirty="0">
-                <a:solidFill>
-                  <a:srgbClr val="2A1618"/>
-                </a:solidFill>
-                <a:latin typeface="Calibri" pitchFamily="34" charset="0"/>
-                <a:ea typeface="Calibri" pitchFamily="34" charset="-122"/>
-                <a:cs typeface="Calibri" pitchFamily="34" charset="-120"/>
-              </a:rPr>
-              <a:t>The detectable-difference pattern matches:  </a:t>
-            </a:r>
-            <a:pPr indent="0" marL="0">
-              <a:buNone/>
-            </a:pPr>
-            <a:r>
-              <a:rPr lang="en-US" sz="1400" dirty="0">
-                <a:solidFill>
-                  <a:srgbClr val="836A68"/>
-                </a:solidFill>
-                <a:latin typeface="Calibri" pitchFamily="34" charset="0"/>
-                <a:ea typeface="Calibri" pitchFamily="34" charset="-122"/>
-                <a:cs typeface="Calibri" pitchFamily="34" charset="-120"/>
-              </a:rPr>
-              <a:t>bench and sim place the tumor's strongest change in the same regions (toward the antenna sides).</a:t>
-            </a:r>
-            <a:endParaRPr lang="en-US" sz="1400" dirty="0"/>
-          </a:p>
-        </p:txBody>
-      </p:sp>
-      <p:sp>
-        <p:nvSpPr>
-          <p:cNvPr id="10" name="Shape 8"/>
-          <p:cNvSpPr/>
-          <p:nvPr/>
-        </p:nvSpPr>
-        <p:spPr>
-          <a:xfrm>
-            <a:off x="822960" y="3538728"/>
-            <a:ext cx="384048" cy="384048"/>
-          </a:xfrm>
-          <a:prstGeom prst="ellipse">
-            <a:avLst/>
-          </a:prstGeom>
-          <a:solidFill>
-            <a:srgbClr val="BE0000"/>
-          </a:solidFill>
-          <a:ln/>
-        </p:spPr>
-      </p:sp>
-      <p:sp>
-        <p:nvSpPr>
-          <p:cNvPr id="11" name="Text 9"/>
-          <p:cNvSpPr/>
-          <p:nvPr/>
-        </p:nvSpPr>
-        <p:spPr>
-          <a:xfrm>
-            <a:off x="822960" y="3538728"/>
-            <a:ext cx="384048" cy="384048"/>
-          </a:xfrm>
-          <a:prstGeom prst="rect">
-            <a:avLst/>
-          </a:prstGeom>
-          <a:noFill/>
-          <a:ln/>
-        </p:spPr>
-        <p:txBody>
-          <a:bodyPr wrap="square" lIns="0" tIns="0" rIns="0" bIns="0" rtlCol="0" anchor="ctr"/>
-          <a:lstStyle/>
-          <a:p>
-            <a:pPr algn="ctr" indent="0" marL="0">
-              <a:buNone/>
-            </a:pPr>
-            <a:r>
-              <a:rPr lang="en-US" sz="1500" b="1" dirty="0">
-                <a:solidFill>
-                  <a:srgbClr val="FFFFFF"/>
-                </a:solidFill>
-                <a:latin typeface="Cambria" pitchFamily="34" charset="0"/>
-                <a:ea typeface="Cambria" pitchFamily="34" charset="-122"/>
-                <a:cs typeface="Cambria" pitchFamily="34" charset="-120"/>
-              </a:rPr>
-              <a:t>3</a:t>
-            </a:r>
-            <a:endParaRPr lang="en-US" sz="1500" dirty="0"/>
-          </a:p>
-        </p:txBody>
-      </p:sp>
-      <p:sp>
-        <p:nvSpPr>
-          <p:cNvPr id="12" name="Text 10"/>
-          <p:cNvSpPr/>
-          <p:nvPr/>
-        </p:nvSpPr>
-        <p:spPr>
-          <a:xfrm>
-            <a:off x="1371600" y="3447288"/>
-            <a:ext cx="10241280" cy="868680"/>
-          </a:xfrm>
-          <a:prstGeom prst="rect">
-            <a:avLst/>
-          </a:prstGeom>
-          <a:noFill/>
-          <a:ln/>
-        </p:spPr>
-        <p:txBody>
-          <a:bodyPr wrap="square" lIns="0" tIns="0" rIns="0" bIns="0" rtlCol="0" anchor="ctr"/>
-          <a:lstStyle/>
-          <a:p>
-            <a:pPr indent="0" marL="0">
-              <a:buNone/>
-            </a:pPr>
-            <a:r>
-              <a:rPr lang="en-US" sz="1400" b="1" dirty="0">
-                <a:solidFill>
-                  <a:srgbClr val="2A1618"/>
-                </a:solidFill>
-                <a:latin typeface="Calibri" pitchFamily="34" charset="0"/>
-                <a:ea typeface="Calibri" pitchFamily="34" charset="-122"/>
-                <a:cs typeface="Calibri" pitchFamily="34" charset="-120"/>
-              </a:rPr>
-              <a:t>The CNN gap is data coverage, not fidelity:  </a:t>
-            </a:r>
-            <a:pPr indent="0" marL="0">
-              <a:buNone/>
-            </a:pPr>
-            <a:r>
-              <a:rPr lang="en-US" sz="1400" dirty="0">
-                <a:solidFill>
-                  <a:srgbClr val="836A68"/>
-                </a:solidFill>
-                <a:latin typeface="Calibri" pitchFamily="34" charset="0"/>
-                <a:ea typeface="Calibri" pitchFamily="34" charset="-122"/>
-                <a:cs typeface="Calibri" pitchFamily="34" charset="-120"/>
-              </a:rPr>
-              <a:t>sim's 3.9 mm comes from ~1000 distinct positions; measured's 9.9 mm from only ~50. Same model, different coverage.</a:t>
-            </a:r>
-            <a:endParaRPr lang="en-US" sz="1400" dirty="0"/>
-          </a:p>
-        </p:txBody>
-      </p:sp>
-      <p:sp>
-        <p:nvSpPr>
-          <p:cNvPr id="13" name="Shape 11"/>
-          <p:cNvSpPr/>
-          <p:nvPr/>
-        </p:nvSpPr>
-        <p:spPr>
-          <a:xfrm>
-            <a:off x="822960" y="4507992"/>
-            <a:ext cx="384048" cy="384048"/>
-          </a:xfrm>
-          <a:prstGeom prst="ellipse">
-            <a:avLst/>
-          </a:prstGeom>
-          <a:solidFill>
-            <a:srgbClr val="BE0000"/>
-          </a:solidFill>
-          <a:ln/>
-        </p:spPr>
-      </p:sp>
-      <p:sp>
-        <p:nvSpPr>
-          <p:cNvPr id="14" name="Text 12"/>
-          <p:cNvSpPr/>
-          <p:nvPr/>
-        </p:nvSpPr>
-        <p:spPr>
-          <a:xfrm>
-            <a:off x="822960" y="4507992"/>
-            <a:ext cx="384048" cy="384048"/>
-          </a:xfrm>
-          <a:prstGeom prst="rect">
-            <a:avLst/>
-          </a:prstGeom>
-          <a:noFill/>
-          <a:ln/>
-        </p:spPr>
-        <p:txBody>
-          <a:bodyPr wrap="square" lIns="0" tIns="0" rIns="0" bIns="0" rtlCol="0" anchor="ctr"/>
-          <a:lstStyle/>
-          <a:p>
-            <a:pPr algn="ctr" indent="0" marL="0">
-              <a:buNone/>
-            </a:pPr>
-            <a:r>
-              <a:rPr lang="en-US" sz="1500" b="1" dirty="0">
-                <a:solidFill>
-                  <a:srgbClr val="FFFFFF"/>
-                </a:solidFill>
-                <a:latin typeface="Cambria" pitchFamily="34" charset="0"/>
-                <a:ea typeface="Cambria" pitchFamily="34" charset="-122"/>
-                <a:cs typeface="Cambria" pitchFamily="34" charset="-120"/>
-              </a:rPr>
-              <a:t>4</a:t>
-            </a:r>
-            <a:endParaRPr lang="en-US" sz="1500" dirty="0"/>
-          </a:p>
-        </p:txBody>
-      </p:sp>
-      <p:sp>
-        <p:nvSpPr>
-          <p:cNvPr id="15" name="Text 13"/>
-          <p:cNvSpPr/>
-          <p:nvPr/>
-        </p:nvSpPr>
-        <p:spPr>
-          <a:xfrm>
-            <a:off x="1371600" y="4416552"/>
-            <a:ext cx="10241280" cy="868680"/>
-          </a:xfrm>
-          <a:prstGeom prst="rect">
-            <a:avLst/>
-          </a:prstGeom>
-          <a:noFill/>
-          <a:ln/>
-        </p:spPr>
-        <p:txBody>
-          <a:bodyPr wrap="square" lIns="0" tIns="0" rIns="0" bIns="0" rtlCol="0" anchor="ctr"/>
-          <a:lstStyle/>
-          <a:p>
-            <a:pPr indent="0" marL="0">
-              <a:buNone/>
-            </a:pPr>
-            <a:r>
-              <a:rPr lang="en-US" sz="1400" b="1" dirty="0">
-                <a:solidFill>
-                  <a:srgbClr val="2A1618"/>
-                </a:solidFill>
-                <a:latin typeface="Calibri" pitchFamily="34" charset="0"/>
-                <a:ea typeface="Calibri" pitchFamily="34" charset="-122"/>
-                <a:cs typeface="Calibri" pitchFamily="34" charset="-120"/>
-              </a:rPr>
-              <a:t>Takes and sessions are not new positions:  </a:t>
-            </a:r>
-            <a:pPr indent="0" marL="0">
-              <a:buNone/>
-            </a:pPr>
-            <a:r>
-              <a:rPr lang="en-US" sz="1400" dirty="0">
-                <a:solidFill>
-                  <a:srgbClr val="836A68"/>
-                </a:solidFill>
-                <a:latin typeface="Calibri" pitchFamily="34" charset="0"/>
-                <a:ea typeface="Calibri" pitchFamily="34" charset="-122"/>
-                <a:cs typeface="Calibri" pitchFamily="34" charset="-120"/>
-              </a:rPr>
-              <a:t>16 takes x 3 sessions add robustness (great for LOSO) but no new tumor locations (no help for interpolation).</a:t>
-            </a:r>
-            <a:endParaRPr lang="en-US" sz="1400" dirty="0"/>
-          </a:p>
-        </p:txBody>
-      </p:sp>
-      <p:sp>
-        <p:nvSpPr>
-          <p:cNvPr id="16" name="Shape 14"/>
-          <p:cNvSpPr/>
-          <p:nvPr/>
-        </p:nvSpPr>
-        <p:spPr>
-          <a:xfrm>
-            <a:off x="822960" y="5477256"/>
-            <a:ext cx="384048" cy="384048"/>
-          </a:xfrm>
-          <a:prstGeom prst="ellipse">
-            <a:avLst/>
-          </a:prstGeom>
-          <a:solidFill>
-            <a:srgbClr val="BE0000"/>
-          </a:solidFill>
-          <a:ln/>
-        </p:spPr>
-      </p:sp>
-      <p:sp>
-        <p:nvSpPr>
-          <p:cNvPr id="17" name="Text 15"/>
-          <p:cNvSpPr/>
-          <p:nvPr/>
-        </p:nvSpPr>
-        <p:spPr>
-          <a:xfrm>
-            <a:off x="822960" y="5477256"/>
-            <a:ext cx="384048" cy="384048"/>
-          </a:xfrm>
-          <a:prstGeom prst="rect">
-            <a:avLst/>
-          </a:prstGeom>
-          <a:noFill/>
-          <a:ln/>
-        </p:spPr>
-        <p:txBody>
-          <a:bodyPr wrap="square" lIns="0" tIns="0" rIns="0" bIns="0" rtlCol="0" anchor="ctr"/>
-          <a:lstStyle/>
-          <a:p>
-            <a:pPr algn="ctr" indent="0" marL="0">
-              <a:buNone/>
-            </a:pPr>
-            <a:r>
-              <a:rPr lang="en-US" sz="1500" b="1" dirty="0">
-                <a:solidFill>
-                  <a:srgbClr val="FFFFFF"/>
-                </a:solidFill>
-                <a:latin typeface="Cambria" pitchFamily="34" charset="0"/>
-                <a:ea typeface="Cambria" pitchFamily="34" charset="-122"/>
-                <a:cs typeface="Cambria" pitchFamily="34" charset="-120"/>
-              </a:rPr>
-              <a:t>5</a:t>
-            </a:r>
-            <a:endParaRPr lang="en-US" sz="1500" dirty="0"/>
-          </a:p>
-        </p:txBody>
-      </p:sp>
-      <p:sp>
-        <p:nvSpPr>
-          <p:cNvPr id="18" name="Text 16"/>
-          <p:cNvSpPr/>
-          <p:nvPr/>
-        </p:nvSpPr>
-        <p:spPr>
-          <a:xfrm>
-            <a:off x="1371600" y="5385816"/>
-            <a:ext cx="10241280" cy="868680"/>
-          </a:xfrm>
-          <a:prstGeom prst="rect">
-            <a:avLst/>
-          </a:prstGeom>
-          <a:noFill/>
-          <a:ln/>
-        </p:spPr>
-        <p:txBody>
-          <a:bodyPr wrap="square" lIns="0" tIns="0" rIns="0" bIns="0" rtlCol="0" anchor="ctr"/>
-          <a:lstStyle/>
-          <a:p>
-            <a:pPr indent="0" marL="0">
-              <a:buNone/>
-            </a:pPr>
-            <a:r>
-              <a:rPr lang="en-US" sz="1400" b="1" dirty="0">
-                <a:solidFill>
-                  <a:srgbClr val="2A1618"/>
-                </a:solidFill>
-                <a:latin typeface="Calibri" pitchFamily="34" charset="0"/>
-                <a:ea typeface="Calibri" pitchFamily="34" charset="-122"/>
-                <a:cs typeface="Calibri" pitchFamily="34" charset="-120"/>
-              </a:rPr>
-              <a:t>A sim to measured transfer is learnable:  </a:t>
-            </a:r>
-            <a:pPr indent="0" marL="0">
-              <a:buNone/>
-            </a:pPr>
-            <a:r>
-              <a:rPr lang="en-US" sz="1400" dirty="0">
-                <a:solidFill>
-                  <a:srgbClr val="836A68"/>
-                </a:solidFill>
-                <a:latin typeface="Calibri" pitchFamily="34" charset="0"/>
-                <a:ea typeface="Calibri" pitchFamily="34" charset="-122"/>
-                <a:cs typeface="Calibri" pitchFamily="34" charset="-120"/>
-              </a:rPr>
-              <a:t>a linear map already reaches R2 = 0.65 on unseen frequencies, a promising if preliminary calibration path.</a:t>
-            </a:r>
-            <a:endParaRPr lang="en-US" sz="1400" dirty="0"/>
-          </a:p>
-        </p:txBody>
-      </p:sp>
-      <p:sp>
-        <p:nvSpPr>
-          <p:cNvPr id="19" name="Text 17"/>
-          <p:cNvSpPr/>
-          <p:nvPr/>
-        </p:nvSpPr>
-        <p:spPr>
-          <a:xfrm>
-            <a:off x="822960" y="6400800"/>
-            <a:ext cx="10515600" cy="320040"/>
-          </a:xfrm>
-          <a:prstGeom prst="rect">
-            <a:avLst/>
-          </a:prstGeom>
-          <a:noFill/>
-          <a:ln/>
-        </p:spPr>
-        <p:txBody>
-          <a:bodyPr wrap="square" lIns="0" tIns="0" rIns="0" bIns="0" rtlCol="0" anchor="ctr"/>
-          <a:lstStyle/>
-          <a:p>
-            <a:pPr indent="0" marL="0">
-              <a:buNone/>
-            </a:pPr>
-            <a:r>
-              <a:rPr lang="en-US" sz="1100" dirty="0">
-                <a:solidFill>
-                  <a:srgbClr val="BE0000"/>
-                </a:solidFill>
-                <a:latin typeface="Calibri" pitchFamily="34" charset="0"/>
-                <a:ea typeface="Calibri" pitchFamily="34" charset="-122"/>
-                <a:cs typeface="Calibri" pitchFamily="34" charset="-120"/>
-              </a:rPr>
-              <a:t>github.com/pmart1534/microwave-phantom-localization-cnn-mlp</a:t>
-            </a:r>
-            <a:endParaRPr lang="en-US" sz="1100" dirty="0"/>
           </a:p>
         </p:txBody>
       </p:sp>

</xml_diff>

<commit_message>
Add per-S-parameter transmission DD slide to Deck 3
fig_dd_per_sparam_trans.py: coupling DD for S21/S32/S43/S41 (each peaks between
its two antennas: left/top/right/bottom edges), measured vs sim, sim remapped to
physical antenna numbering so the rows align. New Deck 3 slide beside the
reflection version.

Co-Authored-By: Claude Opus 4.8 <noreply@anthropic.com>
</commit_message>
<xml_diff>
--- a/regression_deck/Deck3_Sim_vs_Measured.pptx
+++ b/regression_deck/Deck3_Sim_vs_Measured.pptx
@@ -16,9 +16,10 @@
     <p:sldId id="264" r:id="rId10"/>
     <p:sldId id="265" r:id="rId11"/>
     <p:sldId id="266" r:id="rId12"/>
+    <p:sldId id="267" r:id="rId13"/>
   </p:sldIdLst>
   <p:notesMasterIdLst>
-    <p:notesMasterId r:id="rId13"/>
+    <p:notesMasterId r:id="rId14"/>
   </p:notesMasterIdLst>
   <p:sldSz cx="12188952" cy="6858000"/>
   <p:notesSz cx="6858000" cy="12188952"/>
@@ -712,6 +713,94 @@
             <a:fld id="{F7021451-1387-4CA6-816F-3879F97B5CBC}" type="slidenum">
               <a:rPr lang="en-US"/>
               <a:t>11</a:t>
+            </a:fld>
+            <a:endParaRPr lang="en-US"/>
+          </a:p>
+        </p:txBody>
+      </p:sp>
+    </p:spTree>
+    <p:extLst>
+      <p:ext uri="{BB962C8B-B14F-4D97-AF65-F5344CB8AC3E}">
+        <p14:creationId xmlns:p14="http://schemas.microsoft.com/office/powerpoint/2010/main" val="1024086991"/>
+      </p:ext>
+    </p:extLst>
+  </p:cSld>
+  <p:clrMapOvr>
+    <a:masterClrMapping/>
+  </p:clrMapOvr>
+</p:notes>
+</file>
+
+<file path=ppt/notesSlides/notesSlide12.xml><?xml version="1.0" encoding="utf-8"?>
+<p:notes xmlns:a="http://schemas.openxmlformats.org/drawingml/2006/main" xmlns:r="http://schemas.openxmlformats.org/officeDocument/2006/relationships" xmlns:p="http://schemas.openxmlformats.org/presentationml/2006/main">
+  <p:cSld>
+    <p:spTree>
+      <p:nvGrpSpPr>
+        <p:cNvPr id="1" name=""/>
+        <p:cNvGrpSpPr/>
+        <p:nvPr/>
+      </p:nvGrpSpPr>
+      <p:grpSpPr>
+        <a:xfrm>
+          <a:off x="0" y="0"/>
+          <a:ext cx="0" cy="0"/>
+          <a:chOff x="0" y="0"/>
+          <a:chExt cx="0" cy="0"/>
+        </a:xfrm>
+      </p:grpSpPr>
+      <p:sp>
+        <p:nvSpPr>
+          <p:cNvPr id="2" name="Slide Image Placeholder 1"/>
+          <p:cNvSpPr>
+            <a:spLocks noGrp="1" noRot="1" noChangeAspect="1"/>
+          </p:cNvSpPr>
+          <p:nvPr>
+            <p:ph type="sldImg"/>
+          </p:nvPr>
+        </p:nvSpPr>
+        <p:spPr/>
+      </p:sp>
+      <p:sp>
+        <p:nvSpPr>
+          <p:cNvPr id="3" name="Notes Placeholder 2"/>
+          <p:cNvSpPr>
+            <a:spLocks noGrp="1"/>
+          </p:cNvSpPr>
+          <p:nvPr>
+            <p:ph type="body" idx="1"/>
+          </p:nvPr>
+        </p:nvSpPr>
+        <p:spPr/>
+        <p:txBody>
+          <a:bodyPr/>
+          <a:lstStyle/>
+          <a:p>
+            <a:r>
+              <a:rPr lang="en-US" dirty="0"/>
+              <a:t/>
+            </a:r>
+            <a:endParaRPr lang="en-US" dirty="0"/>
+          </a:p>
+        </p:txBody>
+      </p:sp>
+      <p:sp>
+        <p:nvSpPr>
+          <p:cNvPr id="4" name="Slide Number Placeholder 3"/>
+          <p:cNvSpPr>
+            <a:spLocks noGrp="1"/>
+          </p:cNvSpPr>
+          <p:nvPr>
+            <p:ph type="sldNum" sz="quarter" idx="10"/>
+          </p:nvPr>
+        </p:nvSpPr>
+        <p:spPr/>
+        <p:txBody>
+          <a:bodyPr/>
+          <a:lstStyle/>
+          <a:p>
+            <a:fld id="{F7021451-1387-4CA6-816F-3879F97B5CBC}" type="slidenum">
+              <a:rPr lang="en-US"/>
+              <a:t>12</a:t>
             </a:fld>
             <a:endParaRPr lang="en-US"/>
           </a:p>
@@ -2221,6 +2310,337 @@
                 <a:ea typeface="Cambria" pitchFamily="34" charset="-122"/>
                 <a:cs typeface="Cambria" pitchFamily="34" charset="-120"/>
               </a:rPr>
+              <a:t>Can a model bridge the gap? (exploratory)</a:t>
+            </a:r>
+            <a:endParaRPr lang="en-US" sz="2900" dirty="0"/>
+          </a:p>
+        </p:txBody>
+      </p:sp>
+      <p:sp>
+        <p:nvSpPr>
+          <p:cNvPr id="3" name="Text 1"/>
+          <p:cNvSpPr/>
+          <p:nvPr/>
+        </p:nvSpPr>
+        <p:spPr>
+          <a:xfrm>
+            <a:off x="548640" y="1033272"/>
+            <a:ext cx="11091672" cy="365760"/>
+          </a:xfrm>
+          <a:prstGeom prst="rect">
+            <a:avLst/>
+          </a:prstGeom>
+          <a:noFill/>
+          <a:ln/>
+        </p:spPr>
+        <p:txBody>
+          <a:bodyPr wrap="square" lIns="0" tIns="0" rIns="0" bIns="0" rtlCol="0" anchor="ctr"/>
+          <a:lstStyle/>
+          <a:p>
+            <a:pPr indent="0" marL="0">
+              <a:buNone/>
+            </a:pPr>
+            <a:r>
+              <a:rPr lang="en-US" sz="1400" b="1" dirty="0">
+                <a:solidFill>
+                  <a:srgbClr val="BE0000"/>
+                </a:solidFill>
+                <a:latin typeface="Calibri" pitchFamily="34" charset="0"/>
+                <a:ea typeface="Calibri" pitchFamily="34" charset="-122"/>
+                <a:cs typeface="Calibri" pitchFamily="34" charset="-120"/>
+              </a:rPr>
+              <a:t>Learn a sim to measured map on the empty baseline, test on unseen frequencies</a:t>
+            </a:r>
+            <a:endParaRPr lang="en-US" sz="1400" dirty="0"/>
+          </a:p>
+        </p:txBody>
+      </p:sp>
+      <p:pic>
+        <p:nvPicPr>
+          <p:cNvPr id="4" name="Image 0" descr="sim_meas_correlation.png">    </p:cNvPr>
+          <p:cNvPicPr>
+            <a:picLocks noChangeAspect="1"/>
+          </p:cNvPicPr>
+          <p:nvPr/>
+        </p:nvPicPr>
+        <p:blipFill>
+          <a:blip r:embed="rId1"/>
+          <a:stretch>
+            <a:fillRect/>
+          </a:stretch>
+        </p:blipFill>
+        <p:spPr>
+          <a:xfrm>
+            <a:off x="457200" y="1737360"/>
+            <a:ext cx="7772400" cy="3154680"/>
+          </a:xfrm>
+          <a:prstGeom prst="rect">
+            <a:avLst/>
+          </a:prstGeom>
+        </p:spPr>
+      </p:pic>
+      <p:sp>
+        <p:nvSpPr>
+          <p:cNvPr id="5" name="Shape 2"/>
+          <p:cNvSpPr/>
+          <p:nvPr/>
+        </p:nvSpPr>
+        <p:spPr>
+          <a:xfrm>
+            <a:off x="8412480" y="1645920"/>
+            <a:ext cx="3246120" cy="3749040"/>
+          </a:xfrm>
+          <a:prstGeom prst="roundRect">
+            <a:avLst>
+              <a:gd name="adj" fmla="val 2535"/>
+            </a:avLst>
+          </a:prstGeom>
+          <a:solidFill>
+            <a:srgbClr val="FBF4F2"/>
+          </a:solidFill>
+          <a:ln w="12700">
+            <a:solidFill>
+              <a:srgbClr val="E7D6D1"/>
+            </a:solidFill>
+            <a:prstDash val="solid"/>
+          </a:ln>
+          <a:effectLst>
+            <a:outerShdw sx="100000" sy="100000" kx="0" ky="0" algn="bl" rotWithShape="0" blurRad="88900" dist="38100" dir="5400000">
+              <a:srgbClr val="7A5C5E">
+                <a:alpha val="18000"/>
+              </a:srgbClr>
+            </a:outerShdw>
+          </a:effectLst>
+        </p:spPr>
+      </p:sp>
+      <p:sp>
+        <p:nvSpPr>
+          <p:cNvPr id="6" name="Text 3"/>
+          <p:cNvSpPr/>
+          <p:nvPr/>
+        </p:nvSpPr>
+        <p:spPr>
+          <a:xfrm>
+            <a:off x="8595360" y="1801368"/>
+            <a:ext cx="2926080" cy="365760"/>
+          </a:xfrm>
+          <a:prstGeom prst="rect">
+            <a:avLst/>
+          </a:prstGeom>
+          <a:noFill/>
+          <a:ln/>
+        </p:spPr>
+        <p:txBody>
+          <a:bodyPr wrap="square" lIns="0" tIns="0" rIns="0" bIns="0" rtlCol="0" anchor="ctr"/>
+          <a:lstStyle/>
+          <a:p>
+            <a:pPr indent="0" marL="0">
+              <a:buNone/>
+            </a:pPr>
+            <a:r>
+              <a:rPr lang="en-US" sz="1500" b="1" dirty="0">
+                <a:solidFill>
+                  <a:srgbClr val="BE0000"/>
+                </a:solidFill>
+                <a:latin typeface="Cambria" pitchFamily="34" charset="0"/>
+                <a:ea typeface="Cambria" pitchFamily="34" charset="-122"/>
+                <a:cs typeface="Cambria" pitchFamily="34" charset="-120"/>
+              </a:rPr>
+              <a:t>How to read it</a:t>
+            </a:r>
+            <a:endParaRPr lang="en-US" sz="1500" dirty="0"/>
+          </a:p>
+        </p:txBody>
+      </p:sp>
+      <p:sp>
+        <p:nvSpPr>
+          <p:cNvPr id="7" name="Text 4"/>
+          <p:cNvSpPr/>
+          <p:nvPr/>
+        </p:nvSpPr>
+        <p:spPr>
+          <a:xfrm>
+            <a:off x="8595360" y="2212848"/>
+            <a:ext cx="2971800" cy="3108960"/>
+          </a:xfrm>
+          <a:prstGeom prst="rect">
+            <a:avLst/>
+          </a:prstGeom>
+          <a:noFill/>
+          <a:ln/>
+        </p:spPr>
+        <p:txBody>
+          <a:bodyPr wrap="square" lIns="0" tIns="0" rIns="0" bIns="0" rtlCol="0" anchor="t"/>
+          <a:lstStyle/>
+          <a:p>
+            <a:pPr marL="342900" indent="-342900">
+              <a:spcAft>
+                <a:spcPts val="800"/>
+              </a:spcAft>
+              <a:buSzPct val="100000"/>
+              <a:buChar char="•"/>
+            </a:pPr>
+            <a:r>
+              <a:rPr lang="en-US" sz="1050" dirty="0">
+                <a:solidFill>
+                  <a:srgbClr val="2A1618"/>
+                </a:solidFill>
+                <a:latin typeface="Calibri" pitchFamily="34" charset="0"/>
+                <a:ea typeface="Calibri" pitchFamily="34" charset="-122"/>
+                <a:cs typeface="Calibri" pitchFamily="34" charset="-120"/>
+              </a:rPr>
+              <a:t>Left: for one port, the dashed line is the simulated S11 after the learned map. A perfect map would land on the measured (red) curve; it moves toward it but does not fully match.</a:t>
+            </a:r>
+            <a:endParaRPr lang="en-US" sz="1050" dirty="0"/>
+          </a:p>
+          <a:p>
+            <a:pPr marL="342900" indent="-342900">
+              <a:spcAft>
+                <a:spcPts val="800"/>
+              </a:spcAft>
+              <a:buSzPct val="100000"/>
+              <a:buChar char="•"/>
+            </a:pPr>
+            <a:r>
+              <a:rPr lang="en-US" sz="1050" dirty="0">
+                <a:solidFill>
+                  <a:srgbClr val="2A1618"/>
+                </a:solidFill>
+                <a:latin typeface="Calibri" pitchFamily="34" charset="0"/>
+                <a:ea typeface="Calibri" pitchFamily="34" charset="-122"/>
+                <a:cs typeface="Calibri" pitchFamily="34" charset="-120"/>
+              </a:rPr>
+              <a:t>Right: predicted vs measured on held-out frequencies. Points on the diagonal are exact; R2 = 0.65 means the linear map captures most, not all, of the relationship.</a:t>
+            </a:r>
+            <a:endParaRPr lang="en-US" sz="1050" dirty="0"/>
+          </a:p>
+          <a:p>
+            <a:pPr marL="342900" indent="-342900">
+              <a:spcAft>
+                <a:spcPts val="800"/>
+              </a:spcAft>
+              <a:buSzPct val="100000"/>
+              <a:buChar char="•"/>
+            </a:pPr>
+            <a:r>
+              <a:rPr lang="en-US" sz="1050" dirty="0">
+                <a:solidFill>
+                  <a:srgbClr val="2A1618"/>
+                </a:solidFill>
+                <a:latin typeface="Calibri" pitchFamily="34" charset="0"/>
+                <a:ea typeface="Calibri" pitchFamily="34" charset="-122"/>
+                <a:cs typeface="Calibri" pitchFamily="34" charset="-120"/>
+              </a:rPr>
+              <a:t>A flexible MLP overfits the single paired baseline (R2 &lt; 0).</a:t>
+            </a:r>
+            <a:endParaRPr lang="en-US" sz="1050" dirty="0"/>
+          </a:p>
+        </p:txBody>
+      </p:sp>
+      <p:sp>
+        <p:nvSpPr>
+          <p:cNvPr id="8" name="Text 5"/>
+          <p:cNvSpPr/>
+          <p:nvPr/>
+        </p:nvSpPr>
+        <p:spPr>
+          <a:xfrm>
+            <a:off x="548640" y="6035040"/>
+            <a:ext cx="11091672" cy="548640"/>
+          </a:xfrm>
+          <a:prstGeom prst="rect">
+            <a:avLst/>
+          </a:prstGeom>
+          <a:noFill/>
+          <a:ln/>
+        </p:spPr>
+        <p:txBody>
+          <a:bodyPr wrap="square" lIns="0" tIns="0" rIns="0" bIns="0" rtlCol="0" anchor="ctr"/>
+          <a:lstStyle/>
+          <a:p>
+            <a:pPr algn="ctr" indent="0" marL="0">
+              <a:buNone/>
+            </a:pPr>
+            <a:r>
+              <a:rPr lang="en-US" sz="1250" i="1" dirty="0">
+                <a:solidFill>
+                  <a:srgbClr val="836A68"/>
+                </a:solidFill>
+                <a:latin typeface="Calibri" pitchFamily="34" charset="0"/>
+                <a:ea typeface="Calibri" pitchFamily="34" charset="-122"/>
+                <a:cs typeface="Calibri" pitchFamily="34" charset="-120"/>
+              </a:rPr>
+              <a:t>Preliminary: only the empty baseline is cleanly paired. Nonlinear domain adaptation (and any use for calibrating sim toward the bench) needs far more paired data: multiple sessions and, ideally, matched tumor positions.</a:t>
+            </a:r>
+            <a:endParaRPr lang="en-US" sz="1250" dirty="0"/>
+          </a:p>
+        </p:txBody>
+      </p:sp>
+    </p:spTree>
+  </p:cSld>
+  <p:clrMapOvr>
+    <a:masterClrMapping/>
+  </p:clrMapOvr>
+</p:sld>
+</file>
+
+<file path=ppt/slides/slide11.xml><?xml version="1.0" encoding="utf-8"?>
+<p:sld xmlns:a="http://schemas.openxmlformats.org/drawingml/2006/main" xmlns:r="http://schemas.openxmlformats.org/officeDocument/2006/relationships" xmlns:p="http://schemas.openxmlformats.org/presentationml/2006/main">
+  <p:cSld name="Slide 11">
+    <p:bg>
+      <p:bgPr>
+        <a:solidFill>
+          <a:srgbClr val="FFFFFF"/>
+        </a:solidFill>
+      </p:bgPr>
+    </p:bg>
+    <p:spTree>
+      <p:nvGrpSpPr>
+        <p:cNvPr id="1" name=""/>
+        <p:cNvGrpSpPr/>
+        <p:nvPr/>
+      </p:nvGrpSpPr>
+      <p:grpSpPr>
+        <a:xfrm>
+          <a:off x="0" y="0"/>
+          <a:ext cx="0" cy="0"/>
+          <a:chOff x="0" y="0"/>
+          <a:chExt cx="0" cy="0"/>
+        </a:xfrm>
+      </p:grpSpPr>
+      <p:sp>
+        <p:nvSpPr>
+          <p:cNvPr id="2" name="Text 0"/>
+          <p:cNvSpPr/>
+          <p:nvPr/>
+        </p:nvSpPr>
+        <p:spPr>
+          <a:xfrm>
+            <a:off x="548640" y="384048"/>
+            <a:ext cx="11091672" cy="640080"/>
+          </a:xfrm>
+          <a:prstGeom prst="rect">
+            <a:avLst/>
+          </a:prstGeom>
+          <a:noFill/>
+          <a:ln/>
+        </p:spPr>
+        <p:txBody>
+          <a:bodyPr wrap="square" lIns="0" tIns="0" rIns="0" bIns="0" rtlCol="0" anchor="ctr"/>
+          <a:lstStyle/>
+          <a:p>
+            <a:pPr indent="0" marL="0">
+              <a:buNone/>
+            </a:pPr>
+            <a:r>
+              <a:rPr lang="en-US" sz="2900" b="1" dirty="0">
+                <a:solidFill>
+                  <a:srgbClr val="2A1618"/>
+                </a:solidFill>
+                <a:latin typeface="Cambria" pitchFamily="34" charset="0"/>
+                <a:ea typeface="Cambria" pitchFamily="34" charset="-122"/>
+                <a:cs typeface="Cambria" pitchFamily="34" charset="-120"/>
+              </a:rPr>
               <a:t>Beet (dielectric) vs metal tumor, sim and measured</a:t>
             </a:r>
             <a:endParaRPr lang="en-US" sz="2900" dirty="0"/>
@@ -2298,9 +2718,9 @@
 </p:sld>
 </file>
 
-<file path=ppt/slides/slide11.xml><?xml version="1.0" encoding="utf-8"?>
+<file path=ppt/slides/slide12.xml><?xml version="1.0" encoding="utf-8"?>
 <p:sld xmlns:a="http://schemas.openxmlformats.org/drawingml/2006/main" xmlns:r="http://schemas.openxmlformats.org/officeDocument/2006/relationships" xmlns:p="http://schemas.openxmlformats.org/presentationml/2006/main">
-  <p:cSld name="Slide 11">
+  <p:cSld name="Slide 12">
     <p:bg>
       <p:bgPr>
         <a:solidFill>
@@ -5362,7 +5782,7 @@
                 <a:ea typeface="Cambria" pitchFamily="34" charset="-122"/>
                 <a:cs typeface="Cambria" pitchFamily="34" charset="-120"/>
               </a:rPr>
-              <a:t>Detectable difference by S-parameter</a:t>
+              <a:t>Detectable difference by reflection S-parameter</a:t>
             </a:r>
             <a:endParaRPr lang="en-US" sz="2900" dirty="0"/>
           </a:p>
@@ -5401,7 +5821,7 @@
                 <a:ea typeface="Calibri" pitchFamily="34" charset="-122"/>
                 <a:cs typeface="Calibri" pitchFamily="34" charset="-120"/>
               </a:rPr>
-              <a:t>Each reflection Sii localizes near an antenna, in measured (top) and simulated (bottom)</a:t>
+              <a:t>Each reflection Sii localizes on its antenna, in measured (top) and simulated (bottom)</a:t>
             </a:r>
             <a:endParaRPr lang="en-US" sz="1400" dirty="0"/>
           </a:p>
@@ -5496,6 +5916,140 @@
                 <a:ea typeface="Cambria" pitchFamily="34" charset="-122"/>
                 <a:cs typeface="Cambria" pitchFamily="34" charset="-120"/>
               </a:rPr>
+              <a:t>Detectable difference by transmission S-parameter</a:t>
+            </a:r>
+            <a:endParaRPr lang="en-US" sz="2900" dirty="0"/>
+          </a:p>
+        </p:txBody>
+      </p:sp>
+      <p:sp>
+        <p:nvSpPr>
+          <p:cNvPr id="3" name="Text 1"/>
+          <p:cNvSpPr/>
+          <p:nvPr/>
+        </p:nvSpPr>
+        <p:spPr>
+          <a:xfrm>
+            <a:off x="548640" y="1033272"/>
+            <a:ext cx="11091672" cy="365760"/>
+          </a:xfrm>
+          <a:prstGeom prst="rect">
+            <a:avLst/>
+          </a:prstGeom>
+          <a:noFill/>
+          <a:ln/>
+        </p:spPr>
+        <p:txBody>
+          <a:bodyPr wrap="square" lIns="0" tIns="0" rIns="0" bIns="0" rtlCol="0" anchor="ctr"/>
+          <a:lstStyle/>
+          <a:p>
+            <a:pPr indent="0" marL="0">
+              <a:buNone/>
+            </a:pPr>
+            <a:r>
+              <a:rPr lang="en-US" sz="1400" b="1" dirty="0">
+                <a:solidFill>
+                  <a:srgbClr val="BE0000"/>
+                </a:solidFill>
+                <a:latin typeface="Calibri" pitchFamily="34" charset="0"/>
+                <a:ea typeface="Calibri" pitchFamily="34" charset="-122"/>
+                <a:cs typeface="Calibri" pitchFamily="34" charset="-120"/>
+              </a:rPr>
+              <a:t>Each coupling Sij peaks between its two antennas (sim remapped to physical numbering)</a:t>
+            </a:r>
+            <a:endParaRPr lang="en-US" sz="1400" dirty="0"/>
+          </a:p>
+        </p:txBody>
+      </p:sp>
+      <p:pic>
+        <p:nvPicPr>
+          <p:cNvPr id="4" name="Image 0" descr="dd_per_sparam_trans.png">    </p:cNvPr>
+          <p:cNvPicPr>
+            <a:picLocks noChangeAspect="1"/>
+          </p:cNvPicPr>
+          <p:nvPr/>
+        </p:nvPicPr>
+        <p:blipFill>
+          <a:blip r:embed="rId1"/>
+          <a:stretch>
+            <a:fillRect/>
+          </a:stretch>
+        </p:blipFill>
+        <p:spPr>
+          <a:xfrm>
+            <a:off x="274320" y="1417320"/>
+            <a:ext cx="11612880" cy="5074920"/>
+          </a:xfrm>
+          <a:prstGeom prst="rect">
+            <a:avLst/>
+          </a:prstGeom>
+        </p:spPr>
+      </p:pic>
+    </p:spTree>
+  </p:cSld>
+  <p:clrMapOvr>
+    <a:masterClrMapping/>
+  </p:clrMapOvr>
+</p:sld>
+</file>
+
+<file path=ppt/slides/slide9.xml><?xml version="1.0" encoding="utf-8"?>
+<p:sld xmlns:a="http://schemas.openxmlformats.org/drawingml/2006/main" xmlns:r="http://schemas.openxmlformats.org/officeDocument/2006/relationships" xmlns:p="http://schemas.openxmlformats.org/presentationml/2006/main">
+  <p:cSld name="Slide 9">
+    <p:bg>
+      <p:bgPr>
+        <a:solidFill>
+          <a:srgbClr val="FFFFFF"/>
+        </a:solidFill>
+      </p:bgPr>
+    </p:bg>
+    <p:spTree>
+      <p:nvGrpSpPr>
+        <p:cNvPr id="1" name=""/>
+        <p:cNvGrpSpPr/>
+        <p:nvPr/>
+      </p:nvGrpSpPr>
+      <p:grpSpPr>
+        <a:xfrm>
+          <a:off x="0" y="0"/>
+          <a:ext cx="0" cy="0"/>
+          <a:chOff x="0" y="0"/>
+          <a:chExt cx="0" cy="0"/>
+        </a:xfrm>
+      </p:grpSpPr>
+      <p:sp>
+        <p:nvSpPr>
+          <p:cNvPr id="2" name="Text 0"/>
+          <p:cNvSpPr/>
+          <p:nvPr/>
+        </p:nvSpPr>
+        <p:spPr>
+          <a:xfrm>
+            <a:off x="548640" y="384048"/>
+            <a:ext cx="11091672" cy="640080"/>
+          </a:xfrm>
+          <a:prstGeom prst="rect">
+            <a:avLst/>
+          </a:prstGeom>
+          <a:noFill/>
+          <a:ln/>
+        </p:spPr>
+        <p:txBody>
+          <a:bodyPr wrap="square" lIns="0" tIns="0" rIns="0" bIns="0" rtlCol="0" anchor="ctr"/>
+          <a:lstStyle/>
+          <a:p>
+            <a:pPr indent="0" marL="0">
+              <a:buNone/>
+            </a:pPr>
+            <a:r>
+              <a:rPr lang="en-US" sz="2900" b="1" dirty="0">
+                <a:solidFill>
+                  <a:srgbClr val="2A1618"/>
+                </a:solidFill>
+                <a:latin typeface="Cambria" pitchFamily="34" charset="0"/>
+                <a:ea typeface="Cambria" pitchFamily="34" charset="-122"/>
+                <a:cs typeface="Cambria" pitchFamily="34" charset="-120"/>
+              </a:rPr>
               <a:t>The numbers, signal vs. model</a:t>
             </a:r>
             <a:endParaRPr lang="en-US" sz="2900" dirty="0"/>
@@ -5543,7 +6097,7 @@
       </p:sp>
       <p:graphicFrame>
         <p:nvGraphicFramePr>
-          <p:cNvPr id="9" name="Table 0"/>
+          <p:cNvPr id="10" name="Table 0"/>
           <p:cNvGraphicFramePr>
             <a:graphicFrameLocks noGrp="1"/>
           </p:cNvGraphicFramePr>
@@ -6908,337 +7462,6 @@
               <a:t>The sim vs measured CNN gap is distinct-position COVERAGE, not fidelity. To match 3.9 mm on the bench: denser grid / more depths, not a better model.</a:t>
             </a:r>
             <a:endParaRPr lang="en-US" sz="1150" dirty="0"/>
-          </a:p>
-        </p:txBody>
-      </p:sp>
-    </p:spTree>
-  </p:cSld>
-  <p:clrMapOvr>
-    <a:masterClrMapping/>
-  </p:clrMapOvr>
-</p:sld>
-</file>
-
-<file path=ppt/slides/slide9.xml><?xml version="1.0" encoding="utf-8"?>
-<p:sld xmlns:a="http://schemas.openxmlformats.org/drawingml/2006/main" xmlns:r="http://schemas.openxmlformats.org/officeDocument/2006/relationships" xmlns:p="http://schemas.openxmlformats.org/presentationml/2006/main">
-  <p:cSld name="Slide 9">
-    <p:bg>
-      <p:bgPr>
-        <a:solidFill>
-          <a:srgbClr val="FFFFFF"/>
-        </a:solidFill>
-      </p:bgPr>
-    </p:bg>
-    <p:spTree>
-      <p:nvGrpSpPr>
-        <p:cNvPr id="1" name=""/>
-        <p:cNvGrpSpPr/>
-        <p:nvPr/>
-      </p:nvGrpSpPr>
-      <p:grpSpPr>
-        <a:xfrm>
-          <a:off x="0" y="0"/>
-          <a:ext cx="0" cy="0"/>
-          <a:chOff x="0" y="0"/>
-          <a:chExt cx="0" cy="0"/>
-        </a:xfrm>
-      </p:grpSpPr>
-      <p:sp>
-        <p:nvSpPr>
-          <p:cNvPr id="2" name="Text 0"/>
-          <p:cNvSpPr/>
-          <p:nvPr/>
-        </p:nvSpPr>
-        <p:spPr>
-          <a:xfrm>
-            <a:off x="548640" y="384048"/>
-            <a:ext cx="11091672" cy="640080"/>
-          </a:xfrm>
-          <a:prstGeom prst="rect">
-            <a:avLst/>
-          </a:prstGeom>
-          <a:noFill/>
-          <a:ln/>
-        </p:spPr>
-        <p:txBody>
-          <a:bodyPr wrap="square" lIns="0" tIns="0" rIns="0" bIns="0" rtlCol="0" anchor="ctr"/>
-          <a:lstStyle/>
-          <a:p>
-            <a:pPr indent="0" marL="0">
-              <a:buNone/>
-            </a:pPr>
-            <a:r>
-              <a:rPr lang="en-US" sz="2900" b="1" dirty="0">
-                <a:solidFill>
-                  <a:srgbClr val="2A1618"/>
-                </a:solidFill>
-                <a:latin typeface="Cambria" pitchFamily="34" charset="0"/>
-                <a:ea typeface="Cambria" pitchFamily="34" charset="-122"/>
-                <a:cs typeface="Cambria" pitchFamily="34" charset="-120"/>
-              </a:rPr>
-              <a:t>Can a model bridge the gap? (exploratory)</a:t>
-            </a:r>
-            <a:endParaRPr lang="en-US" sz="2900" dirty="0"/>
-          </a:p>
-        </p:txBody>
-      </p:sp>
-      <p:sp>
-        <p:nvSpPr>
-          <p:cNvPr id="3" name="Text 1"/>
-          <p:cNvSpPr/>
-          <p:nvPr/>
-        </p:nvSpPr>
-        <p:spPr>
-          <a:xfrm>
-            <a:off x="548640" y="1033272"/>
-            <a:ext cx="11091672" cy="365760"/>
-          </a:xfrm>
-          <a:prstGeom prst="rect">
-            <a:avLst/>
-          </a:prstGeom>
-          <a:noFill/>
-          <a:ln/>
-        </p:spPr>
-        <p:txBody>
-          <a:bodyPr wrap="square" lIns="0" tIns="0" rIns="0" bIns="0" rtlCol="0" anchor="ctr"/>
-          <a:lstStyle/>
-          <a:p>
-            <a:pPr indent="0" marL="0">
-              <a:buNone/>
-            </a:pPr>
-            <a:r>
-              <a:rPr lang="en-US" sz="1400" b="1" dirty="0">
-                <a:solidFill>
-                  <a:srgbClr val="BE0000"/>
-                </a:solidFill>
-                <a:latin typeface="Calibri" pitchFamily="34" charset="0"/>
-                <a:ea typeface="Calibri" pitchFamily="34" charset="-122"/>
-                <a:cs typeface="Calibri" pitchFamily="34" charset="-120"/>
-              </a:rPr>
-              <a:t>Learn a sim to measured map on the empty baseline, test on unseen frequencies</a:t>
-            </a:r>
-            <a:endParaRPr lang="en-US" sz="1400" dirty="0"/>
-          </a:p>
-        </p:txBody>
-      </p:sp>
-      <p:pic>
-        <p:nvPicPr>
-          <p:cNvPr id="4" name="Image 0" descr="sim_meas_correlation.png">    </p:cNvPr>
-          <p:cNvPicPr>
-            <a:picLocks noChangeAspect="1"/>
-          </p:cNvPicPr>
-          <p:nvPr/>
-        </p:nvPicPr>
-        <p:blipFill>
-          <a:blip r:embed="rId1"/>
-          <a:stretch>
-            <a:fillRect/>
-          </a:stretch>
-        </p:blipFill>
-        <p:spPr>
-          <a:xfrm>
-            <a:off x="457200" y="1737360"/>
-            <a:ext cx="7772400" cy="3154680"/>
-          </a:xfrm>
-          <a:prstGeom prst="rect">
-            <a:avLst/>
-          </a:prstGeom>
-        </p:spPr>
-      </p:pic>
-      <p:sp>
-        <p:nvSpPr>
-          <p:cNvPr id="5" name="Shape 2"/>
-          <p:cNvSpPr/>
-          <p:nvPr/>
-        </p:nvSpPr>
-        <p:spPr>
-          <a:xfrm>
-            <a:off x="8412480" y="1645920"/>
-            <a:ext cx="3246120" cy="3749040"/>
-          </a:xfrm>
-          <a:prstGeom prst="roundRect">
-            <a:avLst>
-              <a:gd name="adj" fmla="val 2535"/>
-            </a:avLst>
-          </a:prstGeom>
-          <a:solidFill>
-            <a:srgbClr val="FBF4F2"/>
-          </a:solidFill>
-          <a:ln w="12700">
-            <a:solidFill>
-              <a:srgbClr val="E7D6D1"/>
-            </a:solidFill>
-            <a:prstDash val="solid"/>
-          </a:ln>
-          <a:effectLst>
-            <a:outerShdw sx="100000" sy="100000" kx="0" ky="0" algn="bl" rotWithShape="0" blurRad="88900" dist="38100" dir="5400000">
-              <a:srgbClr val="7A5C5E">
-                <a:alpha val="18000"/>
-              </a:srgbClr>
-            </a:outerShdw>
-          </a:effectLst>
-        </p:spPr>
-      </p:sp>
-      <p:sp>
-        <p:nvSpPr>
-          <p:cNvPr id="6" name="Text 3"/>
-          <p:cNvSpPr/>
-          <p:nvPr/>
-        </p:nvSpPr>
-        <p:spPr>
-          <a:xfrm>
-            <a:off x="8595360" y="1801368"/>
-            <a:ext cx="2926080" cy="365760"/>
-          </a:xfrm>
-          <a:prstGeom prst="rect">
-            <a:avLst/>
-          </a:prstGeom>
-          <a:noFill/>
-          <a:ln/>
-        </p:spPr>
-        <p:txBody>
-          <a:bodyPr wrap="square" lIns="0" tIns="0" rIns="0" bIns="0" rtlCol="0" anchor="ctr"/>
-          <a:lstStyle/>
-          <a:p>
-            <a:pPr indent="0" marL="0">
-              <a:buNone/>
-            </a:pPr>
-            <a:r>
-              <a:rPr lang="en-US" sz="1500" b="1" dirty="0">
-                <a:solidFill>
-                  <a:srgbClr val="BE0000"/>
-                </a:solidFill>
-                <a:latin typeface="Cambria" pitchFamily="34" charset="0"/>
-                <a:ea typeface="Cambria" pitchFamily="34" charset="-122"/>
-                <a:cs typeface="Cambria" pitchFamily="34" charset="-120"/>
-              </a:rPr>
-              <a:t>How to read it</a:t>
-            </a:r>
-            <a:endParaRPr lang="en-US" sz="1500" dirty="0"/>
-          </a:p>
-        </p:txBody>
-      </p:sp>
-      <p:sp>
-        <p:nvSpPr>
-          <p:cNvPr id="7" name="Text 4"/>
-          <p:cNvSpPr/>
-          <p:nvPr/>
-        </p:nvSpPr>
-        <p:spPr>
-          <a:xfrm>
-            <a:off x="8595360" y="2212848"/>
-            <a:ext cx="2971800" cy="3108960"/>
-          </a:xfrm>
-          <a:prstGeom prst="rect">
-            <a:avLst/>
-          </a:prstGeom>
-          <a:noFill/>
-          <a:ln/>
-        </p:spPr>
-        <p:txBody>
-          <a:bodyPr wrap="square" lIns="0" tIns="0" rIns="0" bIns="0" rtlCol="0" anchor="t"/>
-          <a:lstStyle/>
-          <a:p>
-            <a:pPr marL="342900" indent="-342900">
-              <a:spcAft>
-                <a:spcPts val="800"/>
-              </a:spcAft>
-              <a:buSzPct val="100000"/>
-              <a:buChar char="•"/>
-            </a:pPr>
-            <a:r>
-              <a:rPr lang="en-US" sz="1050" dirty="0">
-                <a:solidFill>
-                  <a:srgbClr val="2A1618"/>
-                </a:solidFill>
-                <a:latin typeface="Calibri" pitchFamily="34" charset="0"/>
-                <a:ea typeface="Calibri" pitchFamily="34" charset="-122"/>
-                <a:cs typeface="Calibri" pitchFamily="34" charset="-120"/>
-              </a:rPr>
-              <a:t>Left: for one port, the dashed line is the simulated S11 after the learned map. A perfect map would land on the measured (red) curve; it moves toward it but does not fully match.</a:t>
-            </a:r>
-            <a:endParaRPr lang="en-US" sz="1050" dirty="0"/>
-          </a:p>
-          <a:p>
-            <a:pPr marL="342900" indent="-342900">
-              <a:spcAft>
-                <a:spcPts val="800"/>
-              </a:spcAft>
-              <a:buSzPct val="100000"/>
-              <a:buChar char="•"/>
-            </a:pPr>
-            <a:r>
-              <a:rPr lang="en-US" sz="1050" dirty="0">
-                <a:solidFill>
-                  <a:srgbClr val="2A1618"/>
-                </a:solidFill>
-                <a:latin typeface="Calibri" pitchFamily="34" charset="0"/>
-                <a:ea typeface="Calibri" pitchFamily="34" charset="-122"/>
-                <a:cs typeface="Calibri" pitchFamily="34" charset="-120"/>
-              </a:rPr>
-              <a:t>Right: predicted vs measured on held-out frequencies. Points on the diagonal are exact; R2 = 0.65 means the linear map captures most, not all, of the relationship.</a:t>
-            </a:r>
-            <a:endParaRPr lang="en-US" sz="1050" dirty="0"/>
-          </a:p>
-          <a:p>
-            <a:pPr marL="342900" indent="-342900">
-              <a:spcAft>
-                <a:spcPts val="800"/>
-              </a:spcAft>
-              <a:buSzPct val="100000"/>
-              <a:buChar char="•"/>
-            </a:pPr>
-            <a:r>
-              <a:rPr lang="en-US" sz="1050" dirty="0">
-                <a:solidFill>
-                  <a:srgbClr val="2A1618"/>
-                </a:solidFill>
-                <a:latin typeface="Calibri" pitchFamily="34" charset="0"/>
-                <a:ea typeface="Calibri" pitchFamily="34" charset="-122"/>
-                <a:cs typeface="Calibri" pitchFamily="34" charset="-120"/>
-              </a:rPr>
-              <a:t>A flexible MLP overfits the single paired baseline (R2 &lt; 0).</a:t>
-            </a:r>
-            <a:endParaRPr lang="en-US" sz="1050" dirty="0"/>
-          </a:p>
-        </p:txBody>
-      </p:sp>
-      <p:sp>
-        <p:nvSpPr>
-          <p:cNvPr id="8" name="Text 5"/>
-          <p:cNvSpPr/>
-          <p:nvPr/>
-        </p:nvSpPr>
-        <p:spPr>
-          <a:xfrm>
-            <a:off x="548640" y="6035040"/>
-            <a:ext cx="11091672" cy="548640"/>
-          </a:xfrm>
-          <a:prstGeom prst="rect">
-            <a:avLst/>
-          </a:prstGeom>
-          <a:noFill/>
-          <a:ln/>
-        </p:spPr>
-        <p:txBody>
-          <a:bodyPr wrap="square" lIns="0" tIns="0" rIns="0" bIns="0" rtlCol="0" anchor="ctr"/>
-          <a:lstStyle/>
-          <a:p>
-            <a:pPr algn="ctr" indent="0" marL="0">
-              <a:buNone/>
-            </a:pPr>
-            <a:r>
-              <a:rPr lang="en-US" sz="1250" i="1" dirty="0">
-                <a:solidFill>
-                  <a:srgbClr val="836A68"/>
-                </a:solidFill>
-                <a:latin typeface="Calibri" pitchFamily="34" charset="0"/>
-                <a:ea typeface="Calibri" pitchFamily="34" charset="-122"/>
-                <a:cs typeface="Calibri" pitchFamily="34" charset="-120"/>
-              </a:rPr>
-              <a:t>Preliminary: only the empty baseline is cleanly paired. Nonlinear domain adaptation (and any use for calibrating sim toward the bench) needs far more paired data: multiple sessions and, ideally, matched tumor positions.</a:t>
-            </a:r>
-            <a:endParaRPr lang="en-US" sz="1250" dirty="0"/>
           </a:p>
         </p:txBody>
       </p:sp>

</xml_diff>

<commit_message>
Remove trailing sentence from beet plot; explain the linear map on slide 10
- beet_vs_metal_dS caption no longer ends with the "matched-size/depth check" line
- transfer slide adds a "How the map is built" card: per-frequency 32-D vector
  (Re/Im of 16 S-params), ridge linear regression y = Wx + b mapping sim->measured
  on the empty baseline, 70/30 frequency split; "sim after linear map" = W x_sim + b

Co-Authored-By: Claude Opus 4.8 <noreply@anthropic.com>
</commit_message>
<xml_diff>
--- a/regression_deck/Deck3_Sim_vs_Measured.pptx
+++ b/regression_deck/Deck3_Sim_vs_Measured.pptx
@@ -2371,7 +2371,7 @@
         </p:blipFill>
         <p:spPr>
           <a:xfrm>
-            <a:off x="457200" y="1737360"/>
+            <a:off x="457200" y="1600200"/>
             <a:ext cx="7772400" cy="3154680"/>
           </a:xfrm>
           <a:prstGeom prst="rect">
@@ -2387,8 +2387,8 @@
         </p:nvSpPr>
         <p:spPr>
           <a:xfrm>
-            <a:off x="8412480" y="1645920"/>
-            <a:ext cx="3246120" cy="3749040"/>
+            <a:off x="8412480" y="1554480"/>
+            <a:ext cx="3246120" cy="3977640"/>
           </a:xfrm>
           <a:prstGeom prst="roundRect">
             <a:avLst>
@@ -2421,7 +2421,7 @@
         </p:nvSpPr>
         <p:spPr>
           <a:xfrm>
-            <a:off x="8595360" y="1801368"/>
+            <a:off x="8595360" y="1691640"/>
             <a:ext cx="2926080" cy="365760"/>
           </a:xfrm>
           <a:prstGeom prst="rect">
@@ -2460,8 +2460,8 @@
         </p:nvSpPr>
         <p:spPr>
           <a:xfrm>
-            <a:off x="8595360" y="2212848"/>
-            <a:ext cx="2971800" cy="3108960"/>
+            <a:off x="8595360" y="2103120"/>
+            <a:ext cx="2971800" cy="3291840"/>
           </a:xfrm>
           <a:prstGeom prst="rect">
             <a:avLst/>
@@ -2539,14 +2539,101 @@
       </p:sp>
       <p:sp>
         <p:nvSpPr>
-          <p:cNvPr id="8" name="Text 5"/>
+          <p:cNvPr id="8" name="Shape 5"/>
           <p:cNvSpPr/>
           <p:nvPr/>
         </p:nvSpPr>
         <p:spPr>
           <a:xfrm>
-            <a:off x="548640" y="6035040"/>
-            <a:ext cx="11091672" cy="548640"/>
+            <a:off x="457200" y="4937760"/>
+            <a:ext cx="7772400" cy="1417320"/>
+          </a:xfrm>
+          <a:prstGeom prst="roundRect">
+            <a:avLst>
+              <a:gd name="adj" fmla="val 5806"/>
+            </a:avLst>
+          </a:prstGeom>
+          <a:solidFill>
+            <a:srgbClr val="FBF4F2"/>
+          </a:solidFill>
+          <a:ln w="12700">
+            <a:solidFill>
+              <a:srgbClr val="E7D6D1"/>
+            </a:solidFill>
+            <a:prstDash val="solid"/>
+          </a:ln>
+          <a:effectLst>
+            <a:outerShdw sx="100000" sy="100000" kx="0" ky="0" algn="bl" rotWithShape="0" blurRad="88900" dist="38100" dir="5400000">
+              <a:srgbClr val="7A5C5E">
+                <a:alpha val="18000"/>
+              </a:srgbClr>
+            </a:outerShdw>
+          </a:effectLst>
+        </p:spPr>
+      </p:sp>
+      <p:sp>
+        <p:nvSpPr>
+          <p:cNvPr id="9" name="Text 6"/>
+          <p:cNvSpPr/>
+          <p:nvPr/>
+        </p:nvSpPr>
+        <p:spPr>
+          <a:xfrm>
+            <a:off x="640080" y="5029200"/>
+            <a:ext cx="7406640" cy="1234440"/>
+          </a:xfrm>
+          <a:prstGeom prst="rect">
+            <a:avLst/>
+          </a:prstGeom>
+          <a:noFill/>
+          <a:ln/>
+        </p:spPr>
+        <p:txBody>
+          <a:bodyPr wrap="square" lIns="0" tIns="0" rIns="0" bIns="0" rtlCol="0" anchor="t"/>
+          <a:lstStyle/>
+          <a:p>
+            <a:pPr indent="0" marL="0">
+              <a:buNone/>
+            </a:pPr>
+            <a:r>
+              <a:rPr lang="en-US" sz="1100" b="1" dirty="0">
+                <a:solidFill>
+                  <a:srgbClr val="BE0000"/>
+                </a:solidFill>
+                <a:latin typeface="Calibri" pitchFamily="34" charset="0"/>
+                <a:ea typeface="Calibri" pitchFamily="34" charset="-122"/>
+                <a:cs typeface="Calibri" pitchFamily="34" charset="-120"/>
+              </a:rPr>
+              <a:t>How the map is built.  </a:t>
+            </a:r>
+            <a:pPr indent="0" marL="0">
+              <a:buNone/>
+            </a:pPr>
+            <a:r>
+              <a:rPr lang="en-US" sz="1100" dirty="0">
+                <a:solidFill>
+                  <a:srgbClr val="2A1618"/>
+                </a:solidFill>
+                <a:latin typeface="Calibri" pitchFamily="34" charset="0"/>
+                <a:ea typeface="Calibri" pitchFamily="34" charset="-122"/>
+                <a:cs typeface="Calibri" pitchFamily="34" charset="-120"/>
+              </a:rPr>
+              <a:t>On the empty baseline, at each frequency f form a 32-D vector x = [Re, Im of the 16 S-parameters]. Fit a ridge (L2) linear regression  y = W x + b  that maps the SIMULATED vector to the MEASURED vector, learning the 32x32 matrix W and offset b. Trained on 70% of frequencies, tested on the held-out 30%. 'Sim after linear map' = W x_sim + b.</a:t>
+            </a:r>
+            <a:endParaRPr lang="en-US" sz="1100" dirty="0"/>
+          </a:p>
+        </p:txBody>
+      </p:sp>
+      <p:sp>
+        <p:nvSpPr>
+          <p:cNvPr id="10" name="Text 7"/>
+          <p:cNvSpPr/>
+          <p:nvPr/>
+        </p:nvSpPr>
+        <p:spPr>
+          <a:xfrm>
+            <a:off x="457200" y="6446520"/>
+            <a:ext cx="11247120" cy="365760"/>
           </a:xfrm>
           <a:prstGeom prst="rect">
             <a:avLst/>
@@ -2562,7 +2649,7 @@
               <a:buNone/>
             </a:pPr>
             <a:r>
-              <a:rPr lang="en-US" sz="1250" i="1" dirty="0">
+              <a:rPr lang="en-US" sz="1100" i="1" dirty="0">
                 <a:solidFill>
                   <a:srgbClr val="836A68"/>
                 </a:solidFill>
@@ -2570,9 +2657,9 @@
                 <a:ea typeface="Calibri" pitchFamily="34" charset="-122"/>
                 <a:cs typeface="Calibri" pitchFamily="34" charset="-120"/>
               </a:rPr>
-              <a:t>Preliminary: only the empty baseline is cleanly paired. Nonlinear domain adaptation (and any use for calibrating sim toward the bench) needs far more paired data: multiple sessions and, ideally, matched tumor positions.</a:t>
-            </a:r>
-            <a:endParaRPr lang="en-US" sz="1250" dirty="0"/>
+              <a:t>Preliminary: only the empty baseline is cleanly paired. Nonlinear domain adaptation needs far more paired data (multiple sessions, matched tumor positions).</a:t>
+            </a:r>
+            <a:endParaRPr lang="en-US" sz="1100" dirty="0"/>
           </a:p>
         </p:txBody>
       </p:sp>

</xml_diff>

<commit_message>
Add dedicated 'How the sim->measured map is learned' method slide to Deck 3
5-step method (pair empty baselines -> 32-D per-freq vector -> 70/30 split ->
ridge fit W,b -> test on held-out 30%), the equation y = Wx + b, and a
"Why R2 = 0.65 is meaningful" callout emphasizing that R2 is measured on unseen
frequencies (genuine generalization, not curve-fitting; the MLP memorized ->
R2<0). Transfer-results slide simplified now that method is its own slide.

Co-Authored-By: Claude Opus 4.8 <noreply@anthropic.com>
</commit_message>
<xml_diff>
--- a/regression_deck/Deck3_Sim_vs_Measured.pptx
+++ b/regression_deck/Deck3_Sim_vs_Measured.pptx
@@ -17,9 +17,10 @@
     <p:sldId id="265" r:id="rId11"/>
     <p:sldId id="266" r:id="rId12"/>
     <p:sldId id="267" r:id="rId13"/>
+    <p:sldId id="268" r:id="rId14"/>
   </p:sldIdLst>
   <p:notesMasterIdLst>
-    <p:notesMasterId r:id="rId14"/>
+    <p:notesMasterId r:id="rId15"/>
   </p:notesMasterIdLst>
   <p:sldSz cx="12188952" cy="6858000"/>
   <p:notesSz cx="6858000" cy="12188952"/>
@@ -801,6 +802,94 @@
             <a:fld id="{F7021451-1387-4CA6-816F-3879F97B5CBC}" type="slidenum">
               <a:rPr lang="en-US"/>
               <a:t>12</a:t>
+            </a:fld>
+            <a:endParaRPr lang="en-US"/>
+          </a:p>
+        </p:txBody>
+      </p:sp>
+    </p:spTree>
+    <p:extLst>
+      <p:ext uri="{BB962C8B-B14F-4D97-AF65-F5344CB8AC3E}">
+        <p14:creationId xmlns:p14="http://schemas.microsoft.com/office/powerpoint/2010/main" val="1024086991"/>
+      </p:ext>
+    </p:extLst>
+  </p:cSld>
+  <p:clrMapOvr>
+    <a:masterClrMapping/>
+  </p:clrMapOvr>
+</p:notes>
+</file>
+
+<file path=ppt/notesSlides/notesSlide13.xml><?xml version="1.0" encoding="utf-8"?>
+<p:notes xmlns:a="http://schemas.openxmlformats.org/drawingml/2006/main" xmlns:r="http://schemas.openxmlformats.org/officeDocument/2006/relationships" xmlns:p="http://schemas.openxmlformats.org/presentationml/2006/main">
+  <p:cSld>
+    <p:spTree>
+      <p:nvGrpSpPr>
+        <p:cNvPr id="1" name=""/>
+        <p:cNvGrpSpPr/>
+        <p:nvPr/>
+      </p:nvGrpSpPr>
+      <p:grpSpPr>
+        <a:xfrm>
+          <a:off x="0" y="0"/>
+          <a:ext cx="0" cy="0"/>
+          <a:chOff x="0" y="0"/>
+          <a:chExt cx="0" cy="0"/>
+        </a:xfrm>
+      </p:grpSpPr>
+      <p:sp>
+        <p:nvSpPr>
+          <p:cNvPr id="2" name="Slide Image Placeholder 1"/>
+          <p:cNvSpPr>
+            <a:spLocks noGrp="1" noRot="1" noChangeAspect="1"/>
+          </p:cNvSpPr>
+          <p:nvPr>
+            <p:ph type="sldImg"/>
+          </p:nvPr>
+        </p:nvSpPr>
+        <p:spPr/>
+      </p:sp>
+      <p:sp>
+        <p:nvSpPr>
+          <p:cNvPr id="3" name="Notes Placeholder 2"/>
+          <p:cNvSpPr>
+            <a:spLocks noGrp="1"/>
+          </p:cNvSpPr>
+          <p:nvPr>
+            <p:ph type="body" idx="1"/>
+          </p:nvPr>
+        </p:nvSpPr>
+        <p:spPr/>
+        <p:txBody>
+          <a:bodyPr/>
+          <a:lstStyle/>
+          <a:p>
+            <a:r>
+              <a:rPr lang="en-US" dirty="0"/>
+              <a:t/>
+            </a:r>
+            <a:endParaRPr lang="en-US" dirty="0"/>
+          </a:p>
+        </p:txBody>
+      </p:sp>
+      <p:sp>
+        <p:nvSpPr>
+          <p:cNvPr id="4" name="Slide Number Placeholder 3"/>
+          <p:cNvSpPr>
+            <a:spLocks noGrp="1"/>
+          </p:cNvSpPr>
+          <p:nvPr>
+            <p:ph type="sldNum" sz="quarter" idx="10"/>
+          </p:nvPr>
+        </p:nvSpPr>
+        <p:spPr/>
+        <p:txBody>
+          <a:bodyPr/>
+          <a:lstStyle/>
+          <a:p>
+            <a:fld id="{F7021451-1387-4CA6-816F-3879F97B5CBC}" type="slidenum">
+              <a:rPr lang="en-US"/>
+              <a:t>13</a:t>
             </a:fld>
             <a:endParaRPr lang="en-US"/>
           </a:p>
@@ -2310,7 +2399,7 @@
                 <a:ea typeface="Cambria" pitchFamily="34" charset="-122"/>
                 <a:cs typeface="Cambria" pitchFamily="34" charset="-120"/>
               </a:rPr>
-              <a:t>Can a model bridge the gap? (exploratory)</a:t>
+              <a:t>How the sim to measured map is learned</a:t>
             </a:r>
             <a:endParaRPr lang="en-US" sz="2900" dirty="0"/>
           </a:p>
@@ -2349,50 +2438,26 @@
                 <a:ea typeface="Calibri" pitchFamily="34" charset="-122"/>
                 <a:cs typeface="Calibri" pitchFamily="34" charset="-120"/>
               </a:rPr>
-              <a:t>Learn a sim to measured map on the empty baseline, test on unseen frequencies</a:t>
+              <a:t>A linear transfer fit on the empty baseline and tested on frequencies it never saw</a:t>
             </a:r>
             <a:endParaRPr lang="en-US" sz="1400" dirty="0"/>
           </a:p>
         </p:txBody>
       </p:sp>
-      <p:pic>
-        <p:nvPicPr>
-          <p:cNvPr id="4" name="Image 0" descr="sim_meas_correlation.png">    </p:cNvPr>
-          <p:cNvPicPr>
-            <a:picLocks noChangeAspect="1"/>
-          </p:cNvPicPr>
-          <p:nvPr/>
-        </p:nvPicPr>
-        <p:blipFill>
-          <a:blip r:embed="rId1"/>
-          <a:stretch>
-            <a:fillRect/>
-          </a:stretch>
-        </p:blipFill>
-        <p:spPr>
-          <a:xfrm>
-            <a:off x="457200" y="1600200"/>
-            <a:ext cx="7772400" cy="3154680"/>
-          </a:xfrm>
-          <a:prstGeom prst="rect">
-            <a:avLst/>
-          </a:prstGeom>
-        </p:spPr>
-      </p:pic>
-      <p:sp>
-        <p:nvSpPr>
-          <p:cNvPr id="5" name="Shape 2"/>
-          <p:cNvSpPr/>
-          <p:nvPr/>
-        </p:nvSpPr>
-        <p:spPr>
-          <a:xfrm>
-            <a:off x="8412480" y="1554480"/>
-            <a:ext cx="3246120" cy="3977640"/>
+      <p:sp>
+        <p:nvSpPr>
+          <p:cNvPr id="4" name="Shape 2"/>
+          <p:cNvSpPr/>
+          <p:nvPr/>
+        </p:nvSpPr>
+        <p:spPr>
+          <a:xfrm>
+            <a:off x="548640" y="1554480"/>
+            <a:ext cx="7040880" cy="822960"/>
           </a:xfrm>
           <a:prstGeom prst="roundRect">
             <a:avLst>
-              <a:gd name="adj" fmla="val 2535"/>
+              <a:gd name="adj" fmla="val 10000"/>
             </a:avLst>
           </a:prstGeom>
           <a:solidFill>
@@ -2415,14 +2480,73 @@
       </p:sp>
       <p:sp>
         <p:nvSpPr>
-          <p:cNvPr id="6" name="Text 3"/>
-          <p:cNvSpPr/>
-          <p:nvPr/>
-        </p:nvSpPr>
-        <p:spPr>
-          <a:xfrm>
-            <a:off x="8595360" y="1691640"/>
-            <a:ext cx="2926080" cy="365760"/>
+          <p:cNvPr id="5" name="Shape 3"/>
+          <p:cNvSpPr/>
+          <p:nvPr/>
+        </p:nvSpPr>
+        <p:spPr>
+          <a:xfrm>
+            <a:off x="749808" y="1737360"/>
+            <a:ext cx="457200" cy="457200"/>
+          </a:xfrm>
+          <a:prstGeom prst="ellipse">
+            <a:avLst/>
+          </a:prstGeom>
+          <a:solidFill>
+            <a:srgbClr val="BE0000"/>
+          </a:solidFill>
+          <a:ln/>
+        </p:spPr>
+      </p:sp>
+      <p:sp>
+        <p:nvSpPr>
+          <p:cNvPr id="6" name="Text 4"/>
+          <p:cNvSpPr/>
+          <p:nvPr/>
+        </p:nvSpPr>
+        <p:spPr>
+          <a:xfrm>
+            <a:off x="749808" y="1737360"/>
+            <a:ext cx="457200" cy="457200"/>
+          </a:xfrm>
+          <a:prstGeom prst="rect">
+            <a:avLst/>
+          </a:prstGeom>
+          <a:noFill/>
+          <a:ln/>
+        </p:spPr>
+        <p:txBody>
+          <a:bodyPr wrap="square" lIns="0" tIns="0" rIns="0" bIns="0" rtlCol="0" anchor="ctr"/>
+          <a:lstStyle/>
+          <a:p>
+            <a:pPr algn="ctr" indent="0" marL="0">
+              <a:buNone/>
+            </a:pPr>
+            <a:r>
+              <a:rPr lang="en-US" sz="1800" b="1" dirty="0">
+                <a:solidFill>
+                  <a:srgbClr val="FFFFFF"/>
+                </a:solidFill>
+                <a:latin typeface="Cambria" pitchFamily="34" charset="0"/>
+                <a:ea typeface="Cambria" pitchFamily="34" charset="-122"/>
+                <a:cs typeface="Cambria" pitchFamily="34" charset="-120"/>
+              </a:rPr>
+              <a:t>1</a:t>
+            </a:r>
+            <a:endParaRPr lang="en-US" sz="1800" dirty="0"/>
+          </a:p>
+        </p:txBody>
+      </p:sp>
+      <p:sp>
+        <p:nvSpPr>
+          <p:cNvPr id="7" name="Text 5"/>
+          <p:cNvSpPr/>
+          <p:nvPr/>
+        </p:nvSpPr>
+        <p:spPr>
+          <a:xfrm>
+            <a:off x="1371600" y="1609344"/>
+            <a:ext cx="2286000" cy="713232"/>
           </a:xfrm>
           <a:prstGeom prst="rect">
             <a:avLst/>
@@ -2438,7 +2562,7 @@
               <a:buNone/>
             </a:pPr>
             <a:r>
-              <a:rPr lang="en-US" sz="1500" b="1" dirty="0">
+              <a:rPr lang="en-US" sz="1400" b="1" dirty="0">
                 <a:solidFill>
                   <a:srgbClr val="BE0000"/>
                 </a:solidFill>
@@ -2446,22 +2570,22 @@
                 <a:ea typeface="Cambria" pitchFamily="34" charset="-122"/>
                 <a:cs typeface="Cambria" pitchFamily="34" charset="-120"/>
               </a:rPr>
-              <a:t>How to read it</a:t>
-            </a:r>
-            <a:endParaRPr lang="en-US" sz="1500" dirty="0"/>
-          </a:p>
-        </p:txBody>
-      </p:sp>
-      <p:sp>
-        <p:nvSpPr>
-          <p:cNvPr id="7" name="Text 4"/>
-          <p:cNvSpPr/>
-          <p:nvPr/>
-        </p:nvSpPr>
-        <p:spPr>
-          <a:xfrm>
-            <a:off x="8595360" y="2103120"/>
-            <a:ext cx="2971800" cy="3291840"/>
+              <a:t>Pair the empty baselines</a:t>
+            </a:r>
+            <a:endParaRPr lang="en-US" sz="1400" dirty="0"/>
+          </a:p>
+        </p:txBody>
+      </p:sp>
+      <p:sp>
+        <p:nvSpPr>
+          <p:cNvPr id="8" name="Text 6"/>
+          <p:cNvSpPr/>
+          <p:nvPr/>
+        </p:nvSpPr>
+        <p:spPr>
+          <a:xfrm>
+            <a:off x="3703320" y="1591056"/>
+            <a:ext cx="3794760" cy="749808"/>
           </a:xfrm>
           <a:prstGeom prst="rect">
             <a:avLst/>
@@ -2470,18 +2594,14 @@
           <a:ln/>
         </p:spPr>
         <p:txBody>
-          <a:bodyPr wrap="square" lIns="0" tIns="0" rIns="0" bIns="0" rtlCol="0" anchor="t"/>
-          <a:lstStyle/>
-          <a:p>
-            <a:pPr marL="342900" indent="-342900">
-              <a:spcAft>
-                <a:spcPts val="800"/>
-              </a:spcAft>
-              <a:buSzPct val="100000"/>
-              <a:buChar char="•"/>
+          <a:bodyPr wrap="square" lIns="0" tIns="0" rIns="0" bIns="0" rtlCol="0" anchor="ctr"/>
+          <a:lstStyle/>
+          <a:p>
+            <a:pPr indent="0" marL="0">
+              <a:buNone/>
             </a:pPr>
             <a:r>
-              <a:rPr lang="en-US" sz="1050" dirty="0">
+              <a:rPr lang="en-US" sz="1070" dirty="0">
                 <a:solidFill>
                   <a:srgbClr val="2A1618"/>
                 </a:solidFill>
@@ -2489,68 +2609,26 @@
                 <a:ea typeface="Calibri" pitchFamily="34" charset="-122"/>
                 <a:cs typeface="Calibri" pitchFamily="34" charset="-120"/>
               </a:rPr>
-              <a:t>Left: for one port, the dashed line is the simulated S11 after the learned map. A perfect map would land on the measured (red) curve; it moves toward it but does not fully match.</a:t>
-            </a:r>
-            <a:endParaRPr lang="en-US" sz="1050" dirty="0"/>
-          </a:p>
-          <a:p>
-            <a:pPr marL="342900" indent="-342900">
-              <a:spcAft>
-                <a:spcPts val="800"/>
-              </a:spcAft>
-              <a:buSzPct val="100000"/>
-              <a:buChar char="•"/>
-            </a:pPr>
-            <a:r>
-              <a:rPr lang="en-US" sz="1050" dirty="0">
-                <a:solidFill>
-                  <a:srgbClr val="2A1618"/>
-                </a:solidFill>
-                <a:latin typeface="Calibri" pitchFamily="34" charset="0"/>
-                <a:ea typeface="Calibri" pitchFamily="34" charset="-122"/>
-                <a:cs typeface="Calibri" pitchFamily="34" charset="-120"/>
-              </a:rPr>
-              <a:t>Right: predicted vs measured on held-out frequencies. Points on the diagonal are exact; R2 = 0.65 means the linear map captures most, not all, of the relationship.</a:t>
-            </a:r>
-            <a:endParaRPr lang="en-US" sz="1050" dirty="0"/>
-          </a:p>
-          <a:p>
-            <a:pPr marL="342900" indent="-342900">
-              <a:spcAft>
-                <a:spcPts val="800"/>
-              </a:spcAft>
-              <a:buSzPct val="100000"/>
-              <a:buChar char="•"/>
-            </a:pPr>
-            <a:r>
-              <a:rPr lang="en-US" sz="1050" dirty="0">
-                <a:solidFill>
-                  <a:srgbClr val="2A1618"/>
-                </a:solidFill>
-                <a:latin typeface="Calibri" pitchFamily="34" charset="0"/>
-                <a:ea typeface="Calibri" pitchFamily="34" charset="-122"/>
-                <a:cs typeface="Calibri" pitchFamily="34" charset="-120"/>
-              </a:rPr>
-              <a:t>A flexible MLP overfits the single paired baseline (R2 &lt; 0).</a:t>
-            </a:r>
-            <a:endParaRPr lang="en-US" sz="1050" dirty="0"/>
-          </a:p>
-        </p:txBody>
-      </p:sp>
-      <p:sp>
-        <p:nvSpPr>
-          <p:cNvPr id="8" name="Shape 5"/>
-          <p:cNvSpPr/>
-          <p:nvPr/>
-        </p:nvSpPr>
-        <p:spPr>
-          <a:xfrm>
-            <a:off x="457200" y="4937760"/>
-            <a:ext cx="7772400" cy="1417320"/>
+              <a:t>Sim empty phantom and measured empty phantom are the same physical state (no tumor), so their S-parameters can be matched frequency by frequency.</a:t>
+            </a:r>
+            <a:endParaRPr lang="en-US" sz="1070" dirty="0"/>
+          </a:p>
+        </p:txBody>
+      </p:sp>
+      <p:sp>
+        <p:nvSpPr>
+          <p:cNvPr id="9" name="Shape 7"/>
+          <p:cNvSpPr/>
+          <p:nvPr/>
+        </p:nvSpPr>
+        <p:spPr>
+          <a:xfrm>
+            <a:off x="548640" y="2487168"/>
+            <a:ext cx="7040880" cy="822960"/>
           </a:xfrm>
           <a:prstGeom prst="roundRect">
             <a:avLst>
-              <a:gd name="adj" fmla="val 5806"/>
+              <a:gd name="adj" fmla="val 10000"/>
             </a:avLst>
           </a:prstGeom>
           <a:solidFill>
@@ -2573,14 +2651,34 @@
       </p:sp>
       <p:sp>
         <p:nvSpPr>
-          <p:cNvPr id="9" name="Text 6"/>
-          <p:cNvSpPr/>
-          <p:nvPr/>
-        </p:nvSpPr>
-        <p:spPr>
-          <a:xfrm>
-            <a:off x="640080" y="5029200"/>
-            <a:ext cx="7406640" cy="1234440"/>
+          <p:cNvPr id="10" name="Shape 8"/>
+          <p:cNvSpPr/>
+          <p:nvPr/>
+        </p:nvSpPr>
+        <p:spPr>
+          <a:xfrm>
+            <a:off x="749808" y="2670048"/>
+            <a:ext cx="457200" cy="457200"/>
+          </a:xfrm>
+          <a:prstGeom prst="ellipse">
+            <a:avLst/>
+          </a:prstGeom>
+          <a:solidFill>
+            <a:srgbClr val="BE0000"/>
+          </a:solidFill>
+          <a:ln/>
+        </p:spPr>
+      </p:sp>
+      <p:sp>
+        <p:nvSpPr>
+          <p:cNvPr id="11" name="Text 9"/>
+          <p:cNvSpPr/>
+          <p:nvPr/>
+        </p:nvSpPr>
+        <p:spPr>
+          <a:xfrm>
+            <a:off x="749808" y="2670048"/>
+            <a:ext cx="457200" cy="457200"/>
           </a:xfrm>
           <a:prstGeom prst="rect">
             <a:avLst/>
@@ -2589,24 +2687,867 @@
           <a:ln/>
         </p:spPr>
         <p:txBody>
-          <a:bodyPr wrap="square" lIns="0" tIns="0" rIns="0" bIns="0" rtlCol="0" anchor="t"/>
+          <a:bodyPr wrap="square" lIns="0" tIns="0" rIns="0" bIns="0" rtlCol="0" anchor="ctr"/>
+          <a:lstStyle/>
+          <a:p>
+            <a:pPr algn="ctr" indent="0" marL="0">
+              <a:buNone/>
+            </a:pPr>
+            <a:r>
+              <a:rPr lang="en-US" sz="1800" b="1" dirty="0">
+                <a:solidFill>
+                  <a:srgbClr val="FFFFFF"/>
+                </a:solidFill>
+                <a:latin typeface="Cambria" pitchFamily="34" charset="0"/>
+                <a:ea typeface="Cambria" pitchFamily="34" charset="-122"/>
+                <a:cs typeface="Cambria" pitchFamily="34" charset="-120"/>
+              </a:rPr>
+              <a:t>2</a:t>
+            </a:r>
+            <a:endParaRPr lang="en-US" sz="1800" dirty="0"/>
+          </a:p>
+        </p:txBody>
+      </p:sp>
+      <p:sp>
+        <p:nvSpPr>
+          <p:cNvPr id="12" name="Text 10"/>
+          <p:cNvSpPr/>
+          <p:nvPr/>
+        </p:nvSpPr>
+        <p:spPr>
+          <a:xfrm>
+            <a:off x="1371600" y="2542032"/>
+            <a:ext cx="2286000" cy="713232"/>
+          </a:xfrm>
+          <a:prstGeom prst="rect">
+            <a:avLst/>
+          </a:prstGeom>
+          <a:noFill/>
+          <a:ln/>
+        </p:spPr>
+        <p:txBody>
+          <a:bodyPr wrap="square" lIns="0" tIns="0" rIns="0" bIns="0" rtlCol="0" anchor="ctr"/>
           <a:lstStyle/>
           <a:p>
             <a:pPr indent="0" marL="0">
               <a:buNone/>
             </a:pPr>
             <a:r>
-              <a:rPr lang="en-US" sz="1100" b="1" dirty="0">
+              <a:rPr lang="en-US" sz="1400" b="1" dirty="0">
                 <a:solidFill>
                   <a:srgbClr val="BE0000"/>
+                </a:solidFill>
+                <a:latin typeface="Cambria" pitchFamily="34" charset="0"/>
+                <a:ea typeface="Cambria" pitchFamily="34" charset="-122"/>
+                <a:cs typeface="Cambria" pitchFamily="34" charset="-120"/>
+              </a:rPr>
+              <a:t>One vector per frequency</a:t>
+            </a:r>
+            <a:endParaRPr lang="en-US" sz="1400" dirty="0"/>
+          </a:p>
+        </p:txBody>
+      </p:sp>
+      <p:sp>
+        <p:nvSpPr>
+          <p:cNvPr id="13" name="Text 11"/>
+          <p:cNvSpPr/>
+          <p:nvPr/>
+        </p:nvSpPr>
+        <p:spPr>
+          <a:xfrm>
+            <a:off x="3703320" y="2523744"/>
+            <a:ext cx="3794760" cy="749808"/>
+          </a:xfrm>
+          <a:prstGeom prst="rect">
+            <a:avLst/>
+          </a:prstGeom>
+          <a:noFill/>
+          <a:ln/>
+        </p:spPr>
+        <p:txBody>
+          <a:bodyPr wrap="square" lIns="0" tIns="0" rIns="0" bIns="0" rtlCol="0" anchor="ctr"/>
+          <a:lstStyle/>
+          <a:p>
+            <a:pPr indent="0" marL="0">
+              <a:buNone/>
+            </a:pPr>
+            <a:r>
+              <a:rPr lang="en-US" sz="1070" dirty="0">
+                <a:solidFill>
+                  <a:srgbClr val="2A1618"/>
                 </a:solidFill>
                 <a:latin typeface="Calibri" pitchFamily="34" charset="0"/>
                 <a:ea typeface="Calibri" pitchFamily="34" charset="-122"/>
                 <a:cs typeface="Calibri" pitchFamily="34" charset="-120"/>
               </a:rPr>
-              <a:t>How the map is built.  </a:t>
-            </a:r>
+              <a:t>At each of 512 frequencies (2 to 8 GHz), stack the real and imaginary parts of the 16 S-parameters into a 32-D vector. Sim = input x, measured = target y.</a:t>
+            </a:r>
+            <a:endParaRPr lang="en-US" sz="1070" dirty="0"/>
+          </a:p>
+        </p:txBody>
+      </p:sp>
+      <p:sp>
+        <p:nvSpPr>
+          <p:cNvPr id="14" name="Shape 12"/>
+          <p:cNvSpPr/>
+          <p:nvPr/>
+        </p:nvSpPr>
+        <p:spPr>
+          <a:xfrm>
+            <a:off x="548640" y="3419856"/>
+            <a:ext cx="7040880" cy="822960"/>
+          </a:xfrm>
+          <a:prstGeom prst="roundRect">
+            <a:avLst>
+              <a:gd name="adj" fmla="val 10000"/>
+            </a:avLst>
+          </a:prstGeom>
+          <a:solidFill>
+            <a:srgbClr val="FBF4F2"/>
+          </a:solidFill>
+          <a:ln w="12700">
+            <a:solidFill>
+              <a:srgbClr val="E7D6D1"/>
+            </a:solidFill>
+            <a:prstDash val="solid"/>
+          </a:ln>
+          <a:effectLst>
+            <a:outerShdw sx="100000" sy="100000" kx="0" ky="0" algn="bl" rotWithShape="0" blurRad="88900" dist="38100" dir="5400000">
+              <a:srgbClr val="7A5C5E">
+                <a:alpha val="18000"/>
+              </a:srgbClr>
+            </a:outerShdw>
+          </a:effectLst>
+        </p:spPr>
+      </p:sp>
+      <p:sp>
+        <p:nvSpPr>
+          <p:cNvPr id="15" name="Shape 13"/>
+          <p:cNvSpPr/>
+          <p:nvPr/>
+        </p:nvSpPr>
+        <p:spPr>
+          <a:xfrm>
+            <a:off x="749808" y="3602736"/>
+            <a:ext cx="457200" cy="457200"/>
+          </a:xfrm>
+          <a:prstGeom prst="ellipse">
+            <a:avLst/>
+          </a:prstGeom>
+          <a:solidFill>
+            <a:srgbClr val="BE0000"/>
+          </a:solidFill>
+          <a:ln/>
+        </p:spPr>
+      </p:sp>
+      <p:sp>
+        <p:nvSpPr>
+          <p:cNvPr id="16" name="Text 14"/>
+          <p:cNvSpPr/>
+          <p:nvPr/>
+        </p:nvSpPr>
+        <p:spPr>
+          <a:xfrm>
+            <a:off x="749808" y="3602736"/>
+            <a:ext cx="457200" cy="457200"/>
+          </a:xfrm>
+          <a:prstGeom prst="rect">
+            <a:avLst/>
+          </a:prstGeom>
+          <a:noFill/>
+          <a:ln/>
+        </p:spPr>
+        <p:txBody>
+          <a:bodyPr wrap="square" lIns="0" tIns="0" rIns="0" bIns="0" rtlCol="0" anchor="ctr"/>
+          <a:lstStyle/>
+          <a:p>
+            <a:pPr algn="ctr" indent="0" marL="0">
+              <a:buNone/>
+            </a:pPr>
+            <a:r>
+              <a:rPr lang="en-US" sz="1800" b="1" dirty="0">
+                <a:solidFill>
+                  <a:srgbClr val="FFFFFF"/>
+                </a:solidFill>
+                <a:latin typeface="Cambria" pitchFamily="34" charset="0"/>
+                <a:ea typeface="Cambria" pitchFamily="34" charset="-122"/>
+                <a:cs typeface="Cambria" pitchFamily="34" charset="-120"/>
+              </a:rPr>
+              <a:t>3</a:t>
+            </a:r>
+            <a:endParaRPr lang="en-US" sz="1800" dirty="0"/>
+          </a:p>
+        </p:txBody>
+      </p:sp>
+      <p:sp>
+        <p:nvSpPr>
+          <p:cNvPr id="17" name="Text 15"/>
+          <p:cNvSpPr/>
+          <p:nvPr/>
+        </p:nvSpPr>
+        <p:spPr>
+          <a:xfrm>
+            <a:off x="1371600" y="3474720"/>
+            <a:ext cx="2286000" cy="713232"/>
+          </a:xfrm>
+          <a:prstGeom prst="rect">
+            <a:avLst/>
+          </a:prstGeom>
+          <a:noFill/>
+          <a:ln/>
+        </p:spPr>
+        <p:txBody>
+          <a:bodyPr wrap="square" lIns="0" tIns="0" rIns="0" bIns="0" rtlCol="0" anchor="ctr"/>
+          <a:lstStyle/>
+          <a:p>
             <a:pPr indent="0" marL="0">
+              <a:buNone/>
+            </a:pPr>
+            <a:r>
+              <a:rPr lang="en-US" sz="1400" b="1" dirty="0">
+                <a:solidFill>
+                  <a:srgbClr val="BE0000"/>
+                </a:solidFill>
+                <a:latin typeface="Cambria" pitchFamily="34" charset="0"/>
+                <a:ea typeface="Cambria" pitchFamily="34" charset="-122"/>
+                <a:cs typeface="Cambria" pitchFamily="34" charset="-120"/>
+              </a:rPr>
+              <a:t>Split the frequencies 70 / 30</a:t>
+            </a:r>
+            <a:endParaRPr lang="en-US" sz="1400" dirty="0"/>
+          </a:p>
+        </p:txBody>
+      </p:sp>
+      <p:sp>
+        <p:nvSpPr>
+          <p:cNvPr id="18" name="Text 16"/>
+          <p:cNvSpPr/>
+          <p:nvPr/>
+        </p:nvSpPr>
+        <p:spPr>
+          <a:xfrm>
+            <a:off x="3703320" y="3456432"/>
+            <a:ext cx="3794760" cy="749808"/>
+          </a:xfrm>
+          <a:prstGeom prst="rect">
+            <a:avLst/>
+          </a:prstGeom>
+          <a:noFill/>
+          <a:ln/>
+        </p:spPr>
+        <p:txBody>
+          <a:bodyPr wrap="square" lIns="0" tIns="0" rIns="0" bIns="0" rtlCol="0" anchor="ctr"/>
+          <a:lstStyle/>
+          <a:p>
+            <a:pPr indent="0" marL="0">
+              <a:buNone/>
+            </a:pPr>
+            <a:r>
+              <a:rPr lang="en-US" sz="1070" dirty="0">
+                <a:solidFill>
+                  <a:srgbClr val="2A1618"/>
+                </a:solidFill>
+                <a:latin typeface="Calibri" pitchFamily="34" charset="0"/>
+                <a:ea typeface="Calibri" pitchFamily="34" charset="-122"/>
+                <a:cs typeface="Calibri" pitchFamily="34" charset="-120"/>
+              </a:rPr>
+              <a:t>Fit on 70% of the frequencies; hold out the other 30% for testing. The map never sees the test frequencies while it is being fit.</a:t>
+            </a:r>
+            <a:endParaRPr lang="en-US" sz="1070" dirty="0"/>
+          </a:p>
+        </p:txBody>
+      </p:sp>
+      <p:sp>
+        <p:nvSpPr>
+          <p:cNvPr id="19" name="Shape 17"/>
+          <p:cNvSpPr/>
+          <p:nvPr/>
+        </p:nvSpPr>
+        <p:spPr>
+          <a:xfrm>
+            <a:off x="548640" y="4352544"/>
+            <a:ext cx="7040880" cy="822960"/>
+          </a:xfrm>
+          <a:prstGeom prst="roundRect">
+            <a:avLst>
+              <a:gd name="adj" fmla="val 10000"/>
+            </a:avLst>
+          </a:prstGeom>
+          <a:solidFill>
+            <a:srgbClr val="FBF4F2"/>
+          </a:solidFill>
+          <a:ln w="12700">
+            <a:solidFill>
+              <a:srgbClr val="E7D6D1"/>
+            </a:solidFill>
+            <a:prstDash val="solid"/>
+          </a:ln>
+          <a:effectLst>
+            <a:outerShdw sx="100000" sy="100000" kx="0" ky="0" algn="bl" rotWithShape="0" blurRad="88900" dist="38100" dir="5400000">
+              <a:srgbClr val="7A5C5E">
+                <a:alpha val="18000"/>
+              </a:srgbClr>
+            </a:outerShdw>
+          </a:effectLst>
+        </p:spPr>
+      </p:sp>
+      <p:sp>
+        <p:nvSpPr>
+          <p:cNvPr id="20" name="Shape 18"/>
+          <p:cNvSpPr/>
+          <p:nvPr/>
+        </p:nvSpPr>
+        <p:spPr>
+          <a:xfrm>
+            <a:off x="749808" y="4535424"/>
+            <a:ext cx="457200" cy="457200"/>
+          </a:xfrm>
+          <a:prstGeom prst="ellipse">
+            <a:avLst/>
+          </a:prstGeom>
+          <a:solidFill>
+            <a:srgbClr val="BE0000"/>
+          </a:solidFill>
+          <a:ln/>
+        </p:spPr>
+      </p:sp>
+      <p:sp>
+        <p:nvSpPr>
+          <p:cNvPr id="21" name="Text 19"/>
+          <p:cNvSpPr/>
+          <p:nvPr/>
+        </p:nvSpPr>
+        <p:spPr>
+          <a:xfrm>
+            <a:off x="749808" y="4535424"/>
+            <a:ext cx="457200" cy="457200"/>
+          </a:xfrm>
+          <a:prstGeom prst="rect">
+            <a:avLst/>
+          </a:prstGeom>
+          <a:noFill/>
+          <a:ln/>
+        </p:spPr>
+        <p:txBody>
+          <a:bodyPr wrap="square" lIns="0" tIns="0" rIns="0" bIns="0" rtlCol="0" anchor="ctr"/>
+          <a:lstStyle/>
+          <a:p>
+            <a:pPr algn="ctr" indent="0" marL="0">
+              <a:buNone/>
+            </a:pPr>
+            <a:r>
+              <a:rPr lang="en-US" sz="1800" b="1" dirty="0">
+                <a:solidFill>
+                  <a:srgbClr val="FFFFFF"/>
+                </a:solidFill>
+                <a:latin typeface="Cambria" pitchFamily="34" charset="0"/>
+                <a:ea typeface="Cambria" pitchFamily="34" charset="-122"/>
+                <a:cs typeface="Cambria" pitchFamily="34" charset="-120"/>
+              </a:rPr>
+              <a:t>4</a:t>
+            </a:r>
+            <a:endParaRPr lang="en-US" sz="1800" dirty="0"/>
+          </a:p>
+        </p:txBody>
+      </p:sp>
+      <p:sp>
+        <p:nvSpPr>
+          <p:cNvPr id="22" name="Text 20"/>
+          <p:cNvSpPr/>
+          <p:nvPr/>
+        </p:nvSpPr>
+        <p:spPr>
+          <a:xfrm>
+            <a:off x="1371600" y="4407408"/>
+            <a:ext cx="2286000" cy="713232"/>
+          </a:xfrm>
+          <a:prstGeom prst="rect">
+            <a:avLst/>
+          </a:prstGeom>
+          <a:noFill/>
+          <a:ln/>
+        </p:spPr>
+        <p:txBody>
+          <a:bodyPr wrap="square" lIns="0" tIns="0" rIns="0" bIns="0" rtlCol="0" anchor="ctr"/>
+          <a:lstStyle/>
+          <a:p>
+            <a:pPr indent="0" marL="0">
+              <a:buNone/>
+            </a:pPr>
+            <a:r>
+              <a:rPr lang="en-US" sz="1400" b="1" dirty="0">
+                <a:solidFill>
+                  <a:srgbClr val="BE0000"/>
+                </a:solidFill>
+                <a:latin typeface="Cambria" pitchFamily="34" charset="0"/>
+                <a:ea typeface="Cambria" pitchFamily="34" charset="-122"/>
+                <a:cs typeface="Cambria" pitchFamily="34" charset="-120"/>
+              </a:rPr>
+              <a:t>Fit the linear map</a:t>
+            </a:r>
+            <a:endParaRPr lang="en-US" sz="1400" dirty="0"/>
+          </a:p>
+        </p:txBody>
+      </p:sp>
+      <p:sp>
+        <p:nvSpPr>
+          <p:cNvPr id="23" name="Text 21"/>
+          <p:cNvSpPr/>
+          <p:nvPr/>
+        </p:nvSpPr>
+        <p:spPr>
+          <a:xfrm>
+            <a:off x="3703320" y="4389120"/>
+            <a:ext cx="3794760" cy="749808"/>
+          </a:xfrm>
+          <a:prstGeom prst="rect">
+            <a:avLst/>
+          </a:prstGeom>
+          <a:noFill/>
+          <a:ln/>
+        </p:spPr>
+        <p:txBody>
+          <a:bodyPr wrap="square" lIns="0" tIns="0" rIns="0" bIns="0" rtlCol="0" anchor="ctr"/>
+          <a:lstStyle/>
+          <a:p>
+            <a:pPr indent="0" marL="0">
+              <a:buNone/>
+            </a:pPr>
+            <a:r>
+              <a:rPr lang="en-US" sz="1070" dirty="0">
+                <a:solidFill>
+                  <a:srgbClr val="2A1618"/>
+                </a:solidFill>
+                <a:latin typeface="Calibri" pitchFamily="34" charset="0"/>
+                <a:ea typeface="Calibri" pitchFamily="34" charset="-122"/>
+                <a:cs typeface="Calibri" pitchFamily="34" charset="-120"/>
+              </a:rPr>
+              <a:t>Ridge (L2) regression learns a 32x32 matrix W and offset b that best convert the sim vector into the measured vector.</a:t>
+            </a:r>
+            <a:endParaRPr lang="en-US" sz="1070" dirty="0"/>
+          </a:p>
+        </p:txBody>
+      </p:sp>
+      <p:sp>
+        <p:nvSpPr>
+          <p:cNvPr id="24" name="Shape 22"/>
+          <p:cNvSpPr/>
+          <p:nvPr/>
+        </p:nvSpPr>
+        <p:spPr>
+          <a:xfrm>
+            <a:off x="548640" y="5285232"/>
+            <a:ext cx="7040880" cy="822960"/>
+          </a:xfrm>
+          <a:prstGeom prst="roundRect">
+            <a:avLst>
+              <a:gd name="adj" fmla="val 10000"/>
+            </a:avLst>
+          </a:prstGeom>
+          <a:solidFill>
+            <a:srgbClr val="FBF4F2"/>
+          </a:solidFill>
+          <a:ln w="12700">
+            <a:solidFill>
+              <a:srgbClr val="E7D6D1"/>
+            </a:solidFill>
+            <a:prstDash val="solid"/>
+          </a:ln>
+          <a:effectLst>
+            <a:outerShdw sx="100000" sy="100000" kx="0" ky="0" algn="bl" rotWithShape="0" blurRad="88900" dist="38100" dir="5400000">
+              <a:srgbClr val="7A5C5E">
+                <a:alpha val="18000"/>
+              </a:srgbClr>
+            </a:outerShdw>
+          </a:effectLst>
+        </p:spPr>
+      </p:sp>
+      <p:sp>
+        <p:nvSpPr>
+          <p:cNvPr id="25" name="Shape 23"/>
+          <p:cNvSpPr/>
+          <p:nvPr/>
+        </p:nvSpPr>
+        <p:spPr>
+          <a:xfrm>
+            <a:off x="749808" y="5468112"/>
+            <a:ext cx="457200" cy="457200"/>
+          </a:xfrm>
+          <a:prstGeom prst="ellipse">
+            <a:avLst/>
+          </a:prstGeom>
+          <a:solidFill>
+            <a:srgbClr val="BE0000"/>
+          </a:solidFill>
+          <a:ln/>
+        </p:spPr>
+      </p:sp>
+      <p:sp>
+        <p:nvSpPr>
+          <p:cNvPr id="26" name="Text 24"/>
+          <p:cNvSpPr/>
+          <p:nvPr/>
+        </p:nvSpPr>
+        <p:spPr>
+          <a:xfrm>
+            <a:off x="749808" y="5468112"/>
+            <a:ext cx="457200" cy="457200"/>
+          </a:xfrm>
+          <a:prstGeom prst="rect">
+            <a:avLst/>
+          </a:prstGeom>
+          <a:noFill/>
+          <a:ln/>
+        </p:spPr>
+        <p:txBody>
+          <a:bodyPr wrap="square" lIns="0" tIns="0" rIns="0" bIns="0" rtlCol="0" anchor="ctr"/>
+          <a:lstStyle/>
+          <a:p>
+            <a:pPr algn="ctr" indent="0" marL="0">
+              <a:buNone/>
+            </a:pPr>
+            <a:r>
+              <a:rPr lang="en-US" sz="1800" b="1" dirty="0">
+                <a:solidFill>
+                  <a:srgbClr val="FFFFFF"/>
+                </a:solidFill>
+                <a:latin typeface="Cambria" pitchFamily="34" charset="0"/>
+                <a:ea typeface="Cambria" pitchFamily="34" charset="-122"/>
+                <a:cs typeface="Cambria" pitchFamily="34" charset="-120"/>
+              </a:rPr>
+              <a:t>5</a:t>
+            </a:r>
+            <a:endParaRPr lang="en-US" sz="1800" dirty="0"/>
+          </a:p>
+        </p:txBody>
+      </p:sp>
+      <p:sp>
+        <p:nvSpPr>
+          <p:cNvPr id="27" name="Text 25"/>
+          <p:cNvSpPr/>
+          <p:nvPr/>
+        </p:nvSpPr>
+        <p:spPr>
+          <a:xfrm>
+            <a:off x="1371600" y="5340096"/>
+            <a:ext cx="2286000" cy="713232"/>
+          </a:xfrm>
+          <a:prstGeom prst="rect">
+            <a:avLst/>
+          </a:prstGeom>
+          <a:noFill/>
+          <a:ln/>
+        </p:spPr>
+        <p:txBody>
+          <a:bodyPr wrap="square" lIns="0" tIns="0" rIns="0" bIns="0" rtlCol="0" anchor="ctr"/>
+          <a:lstStyle/>
+          <a:p>
+            <a:pPr indent="0" marL="0">
+              <a:buNone/>
+            </a:pPr>
+            <a:r>
+              <a:rPr lang="en-US" sz="1400" b="1" dirty="0">
+                <a:solidFill>
+                  <a:srgbClr val="BE0000"/>
+                </a:solidFill>
+                <a:latin typeface="Cambria" pitchFamily="34" charset="0"/>
+                <a:ea typeface="Cambria" pitchFamily="34" charset="-122"/>
+                <a:cs typeface="Cambria" pitchFamily="34" charset="-120"/>
+              </a:rPr>
+              <a:t>Test on the held-out 30%</a:t>
+            </a:r>
+            <a:endParaRPr lang="en-US" sz="1400" dirty="0"/>
+          </a:p>
+        </p:txBody>
+      </p:sp>
+      <p:sp>
+        <p:nvSpPr>
+          <p:cNvPr id="28" name="Text 26"/>
+          <p:cNvSpPr/>
+          <p:nvPr/>
+        </p:nvSpPr>
+        <p:spPr>
+          <a:xfrm>
+            <a:off x="3703320" y="5321808"/>
+            <a:ext cx="3794760" cy="749808"/>
+          </a:xfrm>
+          <a:prstGeom prst="rect">
+            <a:avLst/>
+          </a:prstGeom>
+          <a:noFill/>
+          <a:ln/>
+        </p:spPr>
+        <p:txBody>
+          <a:bodyPr wrap="square" lIns="0" tIns="0" rIns="0" bIns="0" rtlCol="0" anchor="ctr"/>
+          <a:lstStyle/>
+          <a:p>
+            <a:pPr indent="0" marL="0">
+              <a:buNone/>
+            </a:pPr>
+            <a:r>
+              <a:rPr lang="en-US" sz="1070" dirty="0">
+                <a:solidFill>
+                  <a:srgbClr val="2A1618"/>
+                </a:solidFill>
+                <a:latin typeface="Calibri" pitchFamily="34" charset="0"/>
+                <a:ea typeface="Calibri" pitchFamily="34" charset="-122"/>
+                <a:cs typeface="Calibri" pitchFamily="34" charset="-120"/>
+              </a:rPr>
+              <a:t>Apply W and b to the unseen frequencies and compare to the true measured values, giving R2 = 0.65.</a:t>
+            </a:r>
+            <a:endParaRPr lang="en-US" sz="1070" dirty="0"/>
+          </a:p>
+        </p:txBody>
+      </p:sp>
+      <p:sp>
+        <p:nvSpPr>
+          <p:cNvPr id="29" name="Shape 27"/>
+          <p:cNvSpPr/>
+          <p:nvPr/>
+        </p:nvSpPr>
+        <p:spPr>
+          <a:xfrm>
+            <a:off x="7772400" y="1554480"/>
+            <a:ext cx="3886200" cy="1600200"/>
+          </a:xfrm>
+          <a:prstGeom prst="roundRect">
+            <a:avLst>
+              <a:gd name="adj" fmla="val 5143"/>
+            </a:avLst>
+          </a:prstGeom>
+          <a:solidFill>
+            <a:srgbClr val="FBF4F2"/>
+          </a:solidFill>
+          <a:ln w="12700">
+            <a:solidFill>
+              <a:srgbClr val="E7D6D1"/>
+            </a:solidFill>
+            <a:prstDash val="solid"/>
+          </a:ln>
+          <a:effectLst>
+            <a:outerShdw sx="100000" sy="100000" kx="0" ky="0" algn="bl" rotWithShape="0" blurRad="88900" dist="38100" dir="5400000">
+              <a:srgbClr val="7A5C5E">
+                <a:alpha val="18000"/>
+              </a:srgbClr>
+            </a:outerShdw>
+          </a:effectLst>
+        </p:spPr>
+      </p:sp>
+      <p:sp>
+        <p:nvSpPr>
+          <p:cNvPr id="30" name="Text 28"/>
+          <p:cNvSpPr/>
+          <p:nvPr/>
+        </p:nvSpPr>
+        <p:spPr>
+          <a:xfrm>
+            <a:off x="7955280" y="1691640"/>
+            <a:ext cx="3474720" cy="320040"/>
+          </a:xfrm>
+          <a:prstGeom prst="rect">
+            <a:avLst/>
+          </a:prstGeom>
+          <a:noFill/>
+          <a:ln/>
+        </p:spPr>
+        <p:txBody>
+          <a:bodyPr wrap="square" lIns="0" tIns="0" rIns="0" bIns="0" rtlCol="0" anchor="ctr"/>
+          <a:lstStyle/>
+          <a:p>
+            <a:pPr indent="0" marL="0">
+              <a:buNone/>
+            </a:pPr>
+            <a:r>
+              <a:rPr lang="en-US" sz="1400" b="1" dirty="0">
+                <a:solidFill>
+                  <a:srgbClr val="BE0000"/>
+                </a:solidFill>
+                <a:latin typeface="Cambria" pitchFamily="34" charset="0"/>
+                <a:ea typeface="Cambria" pitchFamily="34" charset="-122"/>
+                <a:cs typeface="Cambria" pitchFamily="34" charset="-120"/>
+              </a:rPr>
+              <a:t>The equation</a:t>
+            </a:r>
+            <a:endParaRPr lang="en-US" sz="1400" dirty="0"/>
+          </a:p>
+        </p:txBody>
+      </p:sp>
+      <p:sp>
+        <p:nvSpPr>
+          <p:cNvPr id="31" name="Text 29"/>
+          <p:cNvSpPr/>
+          <p:nvPr/>
+        </p:nvSpPr>
+        <p:spPr>
+          <a:xfrm>
+            <a:off x="7955280" y="2011680"/>
+            <a:ext cx="3520440" cy="457200"/>
+          </a:xfrm>
+          <a:prstGeom prst="rect">
+            <a:avLst/>
+          </a:prstGeom>
+          <a:noFill/>
+          <a:ln/>
+        </p:spPr>
+        <p:txBody>
+          <a:bodyPr wrap="square" lIns="0" tIns="0" rIns="0" bIns="0" rtlCol="0" anchor="ctr"/>
+          <a:lstStyle/>
+          <a:p>
+            <a:pPr algn="ctr" indent="0" marL="0">
+              <a:buNone/>
+            </a:pPr>
+            <a:r>
+              <a:rPr lang="en-US" sz="2200" b="1" dirty="0">
+                <a:solidFill>
+                  <a:srgbClr val="2A1618"/>
+                </a:solidFill>
+                <a:latin typeface="Cambria" pitchFamily="34" charset="0"/>
+                <a:ea typeface="Cambria" pitchFamily="34" charset="-122"/>
+                <a:cs typeface="Cambria" pitchFamily="34" charset="-120"/>
+              </a:rPr>
+              <a:t>y = W x + b</a:t>
+            </a:r>
+            <a:endParaRPr lang="en-US" sz="2200" dirty="0"/>
+          </a:p>
+        </p:txBody>
+      </p:sp>
+      <p:sp>
+        <p:nvSpPr>
+          <p:cNvPr id="32" name="Text 30"/>
+          <p:cNvSpPr/>
+          <p:nvPr/>
+        </p:nvSpPr>
+        <p:spPr>
+          <a:xfrm>
+            <a:off x="7955280" y="2514600"/>
+            <a:ext cx="3520440" cy="548640"/>
+          </a:xfrm>
+          <a:prstGeom prst="rect">
+            <a:avLst/>
+          </a:prstGeom>
+          <a:noFill/>
+          <a:ln/>
+        </p:spPr>
+        <p:txBody>
+          <a:bodyPr wrap="square" lIns="0" tIns="0" rIns="0" bIns="0" rtlCol="0" anchor="t"/>
+          <a:lstStyle/>
+          <a:p>
+            <a:pPr indent="0" marL="0">
+              <a:buNone/>
+            </a:pPr>
+            <a:r>
+              <a:rPr lang="en-US" sz="1000" dirty="0">
+                <a:solidFill>
+                  <a:srgbClr val="836A68"/>
+                </a:solidFill>
+                <a:latin typeface="Calibri" pitchFamily="34" charset="0"/>
+                <a:ea typeface="Calibri" pitchFamily="34" charset="-122"/>
+                <a:cs typeface="Calibri" pitchFamily="34" charset="-120"/>
+              </a:rPr>
+              <a:t>x = sim [Re, Im of 16 S-params] (32-D); y = predicted measured; W (32x32) and b learned on the train frequencies.</a:t>
+            </a:r>
+            <a:endParaRPr lang="en-US" sz="1000" dirty="0"/>
+          </a:p>
+        </p:txBody>
+      </p:sp>
+      <p:sp>
+        <p:nvSpPr>
+          <p:cNvPr id="33" name="Shape 31"/>
+          <p:cNvSpPr/>
+          <p:nvPr/>
+        </p:nvSpPr>
+        <p:spPr>
+          <a:xfrm>
+            <a:off x="7772400" y="3291840"/>
+            <a:ext cx="3886200" cy="2971800"/>
+          </a:xfrm>
+          <a:prstGeom prst="roundRect">
+            <a:avLst>
+              <a:gd name="adj" fmla="val 2769"/>
+            </a:avLst>
+          </a:prstGeom>
+          <a:solidFill>
+            <a:srgbClr val="FBF4F2"/>
+          </a:solidFill>
+          <a:ln w="12700">
+            <a:solidFill>
+              <a:srgbClr val="E7D6D1"/>
+            </a:solidFill>
+            <a:prstDash val="solid"/>
+          </a:ln>
+          <a:effectLst>
+            <a:outerShdw sx="100000" sy="100000" kx="0" ky="0" algn="bl" rotWithShape="0" blurRad="88900" dist="38100" dir="5400000">
+              <a:srgbClr val="7A5C5E">
+                <a:alpha val="18000"/>
+              </a:srgbClr>
+            </a:outerShdw>
+          </a:effectLst>
+        </p:spPr>
+      </p:sp>
+      <p:sp>
+        <p:nvSpPr>
+          <p:cNvPr id="34" name="Text 32"/>
+          <p:cNvSpPr/>
+          <p:nvPr/>
+        </p:nvSpPr>
+        <p:spPr>
+          <a:xfrm>
+            <a:off x="7955280" y="3429000"/>
+            <a:ext cx="3566160" cy="365760"/>
+          </a:xfrm>
+          <a:prstGeom prst="rect">
+            <a:avLst/>
+          </a:prstGeom>
+          <a:noFill/>
+          <a:ln/>
+        </p:spPr>
+        <p:txBody>
+          <a:bodyPr wrap="square" lIns="0" tIns="0" rIns="0" bIns="0" rtlCol="0" anchor="ctr"/>
+          <a:lstStyle/>
+          <a:p>
+            <a:pPr indent="0" marL="0">
+              <a:buNone/>
+            </a:pPr>
+            <a:r>
+              <a:rPr lang="en-US" sz="1400" b="1" dirty="0">
+                <a:solidFill>
+                  <a:srgbClr val="BE0000"/>
+                </a:solidFill>
+                <a:latin typeface="Cambria" pitchFamily="34" charset="0"/>
+                <a:ea typeface="Cambria" pitchFamily="34" charset="-122"/>
+                <a:cs typeface="Cambria" pitchFamily="34" charset="-120"/>
+              </a:rPr>
+              <a:t>Why R2 = 0.65 is meaningful</a:t>
+            </a:r>
+            <a:endParaRPr lang="en-US" sz="1400" dirty="0"/>
+          </a:p>
+        </p:txBody>
+      </p:sp>
+      <p:sp>
+        <p:nvSpPr>
+          <p:cNvPr id="35" name="Text 33"/>
+          <p:cNvSpPr/>
+          <p:nvPr/>
+        </p:nvSpPr>
+        <p:spPr>
+          <a:xfrm>
+            <a:off x="7955280" y="3840480"/>
+            <a:ext cx="3566160" cy="2331720"/>
+          </a:xfrm>
+          <a:prstGeom prst="rect">
+            <a:avLst/>
+          </a:prstGeom>
+          <a:noFill/>
+          <a:ln/>
+        </p:spPr>
+        <p:txBody>
+          <a:bodyPr wrap="square" lIns="0" tIns="0" rIns="0" bIns="0" rtlCol="0" anchor="t"/>
+          <a:lstStyle/>
+          <a:p>
+            <a:pPr indent="0" marL="0">
+              <a:spcAft>
+                <a:spcPts val="900"/>
+              </a:spcAft>
               <a:buNone/>
             </a:pPr>
             <a:r>
@@ -2618,46 +3559,44 @@
                 <a:ea typeface="Calibri" pitchFamily="34" charset="-122"/>
                 <a:cs typeface="Calibri" pitchFamily="34" charset="-120"/>
               </a:rPr>
-              <a:t>On the empty baseline, at each frequency f form a 32-D vector x = [Re, Im of the 16 S-parameters]. Fit a ridge (L2) linear regression  y = W x + b  that maps the SIMULATED vector to the MEASURED vector, learning the 32x32 matrix W and offset b. Trained on 70% of frequencies, tested on the held-out 30%. 'Sim after linear map' = W x_sim + b.</a:t>
+              <a:t>R2 is computed only on frequencies the map never used while fitting, so it measures genuine generalization, not curve-fitting.</a:t>
             </a:r>
             <a:endParaRPr lang="en-US" sz="1100" dirty="0"/>
           </a:p>
-        </p:txBody>
-      </p:sp>
-      <p:sp>
-        <p:nvSpPr>
-          <p:cNvPr id="10" name="Text 7"/>
-          <p:cNvSpPr/>
-          <p:nvPr/>
-        </p:nvSpPr>
-        <p:spPr>
-          <a:xfrm>
-            <a:off x="457200" y="6446520"/>
-            <a:ext cx="11247120" cy="365760"/>
-          </a:xfrm>
-          <a:prstGeom prst="rect">
-            <a:avLst/>
-          </a:prstGeom>
-          <a:noFill/>
-          <a:ln/>
-        </p:spPr>
-        <p:txBody>
-          <a:bodyPr wrap="square" lIns="0" tIns="0" rIns="0" bIns="0" rtlCol="0" anchor="ctr"/>
-          <a:lstStyle/>
-          <a:p>
-            <a:pPr algn="ctr" indent="0" marL="0">
+          <a:p>
+            <a:pPr indent="0" marL="0">
+              <a:spcAft>
+                <a:spcPts val="900"/>
+              </a:spcAft>
               <a:buNone/>
             </a:pPr>
             <a:r>
-              <a:rPr lang="en-US" sz="1100" i="1" dirty="0">
+              <a:rPr lang="en-US" sz="1100" dirty="0">
                 <a:solidFill>
-                  <a:srgbClr val="836A68"/>
+                  <a:srgbClr val="2A1618"/>
                 </a:solidFill>
                 <a:latin typeface="Calibri" pitchFamily="34" charset="0"/>
                 <a:ea typeface="Calibri" pitchFamily="34" charset="-122"/>
                 <a:cs typeface="Calibri" pitchFamily="34" charset="-120"/>
               </a:rPr>
-              <a:t>Preliminary: only the empty baseline is cleanly paired. Nonlinear domain adaptation needs far more paired data (multiple sessions, matched tumor positions).</a:t>
+              <a:t>A model that merely memorized the training frequencies would score near 0 on the held-out set. The flexible MLP did exactly that (R2 &lt; 0).</a:t>
+            </a:r>
+            <a:endParaRPr lang="en-US" sz="1100" dirty="0"/>
+          </a:p>
+          <a:p>
+            <a:pPr indent="0" marL="0">
+              <a:buNone/>
+            </a:pPr>
+            <a:r>
+              <a:rPr lang="en-US" sz="1100" dirty="0">
+                <a:solidFill>
+                  <a:srgbClr val="2A1618"/>
+                </a:solidFill>
+                <a:latin typeface="Calibri" pitchFamily="34" charset="0"/>
+                <a:ea typeface="Calibri" pitchFamily="34" charset="-122"/>
+                <a:cs typeface="Calibri" pitchFamily="34" charset="-120"/>
+              </a:rPr>
+              <a:t>So R2 = 0.65 says a fixed linear transform already recovers most of the measured signal from the sim, on data it has not seen.</a:t>
             </a:r>
             <a:endParaRPr lang="en-US" sz="1100" dirty="0"/>
           </a:p>
@@ -2728,7 +3667,7 @@
                 <a:ea typeface="Cambria" pitchFamily="34" charset="-122"/>
                 <a:cs typeface="Cambria" pitchFamily="34" charset="-120"/>
               </a:rPr>
-              <a:t>Beet (dielectric) vs metal tumor, sim and measured</a:t>
+              <a:t>Can a model bridge the gap? (exploratory)</a:t>
             </a:r>
             <a:endParaRPr lang="en-US" sz="2900" dirty="0"/>
           </a:p>
@@ -2767,7 +3706,7 @@
                 <a:ea typeface="Calibri" pitchFamily="34" charset="-122"/>
                 <a:cs typeface="Calibri" pitchFamily="34" charset="-120"/>
               </a:rPr>
-              <a:t>How much differential signal a realistic dielectric target produces relative to metal</a:t>
+              <a:t>The learned map applied to one port, and its accuracy on unseen frequencies</a:t>
             </a:r>
             <a:endParaRPr lang="en-US" sz="1400" dirty="0"/>
           </a:p>
@@ -2775,7 +3714,7 @@
       </p:sp>
       <p:pic>
         <p:nvPicPr>
-          <p:cNvPr id="4" name="Image 0" descr="beet_vs_metal_dS.png">    </p:cNvPr>
+          <p:cNvPr id="4" name="Image 0" descr="sim_meas_correlation.png">    </p:cNvPr>
           <p:cNvPicPr>
             <a:picLocks noChangeAspect="1"/>
           </p:cNvPicPr>
@@ -2789,14 +3728,211 @@
         </p:blipFill>
         <p:spPr>
           <a:xfrm>
-            <a:off x="822960" y="1737360"/>
-            <a:ext cx="10515600" cy="4892040"/>
+            <a:off x="457200" y="1737360"/>
+            <a:ext cx="7772400" cy="3154680"/>
           </a:xfrm>
           <a:prstGeom prst="rect">
             <a:avLst/>
           </a:prstGeom>
         </p:spPr>
       </p:pic>
+      <p:sp>
+        <p:nvSpPr>
+          <p:cNvPr id="5" name="Shape 2"/>
+          <p:cNvSpPr/>
+          <p:nvPr/>
+        </p:nvSpPr>
+        <p:spPr>
+          <a:xfrm>
+            <a:off x="8412480" y="1645920"/>
+            <a:ext cx="3246120" cy="3794760"/>
+          </a:xfrm>
+          <a:prstGeom prst="roundRect">
+            <a:avLst>
+              <a:gd name="adj" fmla="val 2535"/>
+            </a:avLst>
+          </a:prstGeom>
+          <a:solidFill>
+            <a:srgbClr val="FBF4F2"/>
+          </a:solidFill>
+          <a:ln w="12700">
+            <a:solidFill>
+              <a:srgbClr val="E7D6D1"/>
+            </a:solidFill>
+            <a:prstDash val="solid"/>
+          </a:ln>
+          <a:effectLst>
+            <a:outerShdw sx="100000" sy="100000" kx="0" ky="0" algn="bl" rotWithShape="0" blurRad="88900" dist="38100" dir="5400000">
+              <a:srgbClr val="7A5C5E">
+                <a:alpha val="18000"/>
+              </a:srgbClr>
+            </a:outerShdw>
+          </a:effectLst>
+        </p:spPr>
+      </p:sp>
+      <p:sp>
+        <p:nvSpPr>
+          <p:cNvPr id="6" name="Text 3"/>
+          <p:cNvSpPr/>
+          <p:nvPr/>
+        </p:nvSpPr>
+        <p:spPr>
+          <a:xfrm>
+            <a:off x="8595360" y="1783080"/>
+            <a:ext cx="2926080" cy="365760"/>
+          </a:xfrm>
+          <a:prstGeom prst="rect">
+            <a:avLst/>
+          </a:prstGeom>
+          <a:noFill/>
+          <a:ln/>
+        </p:spPr>
+        <p:txBody>
+          <a:bodyPr wrap="square" lIns="0" tIns="0" rIns="0" bIns="0" rtlCol="0" anchor="ctr"/>
+          <a:lstStyle/>
+          <a:p>
+            <a:pPr indent="0" marL="0">
+              <a:buNone/>
+            </a:pPr>
+            <a:r>
+              <a:rPr lang="en-US" sz="1500" b="1" dirty="0">
+                <a:solidFill>
+                  <a:srgbClr val="BE0000"/>
+                </a:solidFill>
+                <a:latin typeface="Cambria" pitchFamily="34" charset="0"/>
+                <a:ea typeface="Cambria" pitchFamily="34" charset="-122"/>
+                <a:cs typeface="Cambria" pitchFamily="34" charset="-120"/>
+              </a:rPr>
+              <a:t>How to read it</a:t>
+            </a:r>
+            <a:endParaRPr lang="en-US" sz="1500" dirty="0"/>
+          </a:p>
+        </p:txBody>
+      </p:sp>
+      <p:sp>
+        <p:nvSpPr>
+          <p:cNvPr id="7" name="Text 4"/>
+          <p:cNvSpPr/>
+          <p:nvPr/>
+        </p:nvSpPr>
+        <p:spPr>
+          <a:xfrm>
+            <a:off x="8595360" y="2194560"/>
+            <a:ext cx="2971800" cy="3108960"/>
+          </a:xfrm>
+          <a:prstGeom prst="rect">
+            <a:avLst/>
+          </a:prstGeom>
+          <a:noFill/>
+          <a:ln/>
+        </p:spPr>
+        <p:txBody>
+          <a:bodyPr wrap="square" lIns="0" tIns="0" rIns="0" bIns="0" rtlCol="0" anchor="t"/>
+          <a:lstStyle/>
+          <a:p>
+            <a:pPr marL="342900" indent="-342900">
+              <a:spcAft>
+                <a:spcPts val="800"/>
+              </a:spcAft>
+              <a:buSzPct val="100000"/>
+              <a:buChar char="•"/>
+            </a:pPr>
+            <a:r>
+              <a:rPr lang="en-US" sz="1050" dirty="0">
+                <a:solidFill>
+                  <a:srgbClr val="2A1618"/>
+                </a:solidFill>
+                <a:latin typeface="Calibri" pitchFamily="34" charset="0"/>
+                <a:ea typeface="Calibri" pitchFamily="34" charset="-122"/>
+                <a:cs typeface="Calibri" pitchFamily="34" charset="-120"/>
+              </a:rPr>
+              <a:t>Left: the dashed line is the simulated S11 after the map (W x_sim + b). A perfect map would land on the measured (red) curve; it moves toward it but does not fully match.</a:t>
+            </a:r>
+            <a:endParaRPr lang="en-US" sz="1050" dirty="0"/>
+          </a:p>
+          <a:p>
+            <a:pPr marL="342900" indent="-342900">
+              <a:spcAft>
+                <a:spcPts val="800"/>
+              </a:spcAft>
+              <a:buSzPct val="100000"/>
+              <a:buChar char="•"/>
+            </a:pPr>
+            <a:r>
+              <a:rPr lang="en-US" sz="1050" dirty="0">
+                <a:solidFill>
+                  <a:srgbClr val="2A1618"/>
+                </a:solidFill>
+                <a:latin typeface="Calibri" pitchFamily="34" charset="0"/>
+                <a:ea typeface="Calibri" pitchFamily="34" charset="-122"/>
+                <a:cs typeface="Calibri" pitchFamily="34" charset="-120"/>
+              </a:rPr>
+              <a:t>Right: predicted vs measured on the held-out frequencies. Points on the diagonal are exact; the R2 = 0.65 spread shows the map captures most, not all, of the relationship.</a:t>
+            </a:r>
+            <a:endParaRPr lang="en-US" sz="1050" dirty="0"/>
+          </a:p>
+          <a:p>
+            <a:pPr marL="342900" indent="-342900">
+              <a:spcAft>
+                <a:spcPts val="800"/>
+              </a:spcAft>
+              <a:buSzPct val="100000"/>
+              <a:buChar char="•"/>
+            </a:pPr>
+            <a:r>
+              <a:rPr lang="en-US" sz="1050" dirty="0">
+                <a:solidFill>
+                  <a:srgbClr val="2A1618"/>
+                </a:solidFill>
+                <a:latin typeface="Calibri" pitchFamily="34" charset="0"/>
+                <a:ea typeface="Calibri" pitchFamily="34" charset="-122"/>
+                <a:cs typeface="Calibri" pitchFamily="34" charset="-120"/>
+              </a:rPr>
+              <a:t>A flexible MLP overfits and fails to generalize (R2 &lt; 0).</a:t>
+            </a:r>
+            <a:endParaRPr lang="en-US" sz="1050" dirty="0"/>
+          </a:p>
+        </p:txBody>
+      </p:sp>
+      <p:sp>
+        <p:nvSpPr>
+          <p:cNvPr id="8" name="Text 5"/>
+          <p:cNvSpPr/>
+          <p:nvPr/>
+        </p:nvSpPr>
+        <p:spPr>
+          <a:xfrm>
+            <a:off x="548640" y="6035040"/>
+            <a:ext cx="11091672" cy="548640"/>
+          </a:xfrm>
+          <a:prstGeom prst="rect">
+            <a:avLst/>
+          </a:prstGeom>
+          <a:noFill/>
+          <a:ln/>
+        </p:spPr>
+        <p:txBody>
+          <a:bodyPr wrap="square" lIns="0" tIns="0" rIns="0" bIns="0" rtlCol="0" anchor="ctr"/>
+          <a:lstStyle/>
+          <a:p>
+            <a:pPr algn="ctr" indent="0" marL="0">
+              <a:buNone/>
+            </a:pPr>
+            <a:r>
+              <a:rPr lang="en-US" sz="1250" i="1" dirty="0">
+                <a:solidFill>
+                  <a:srgbClr val="836A68"/>
+                </a:solidFill>
+                <a:latin typeface="Calibri" pitchFamily="34" charset="0"/>
+                <a:ea typeface="Calibri" pitchFamily="34" charset="-122"/>
+                <a:cs typeface="Calibri" pitchFamily="34" charset="-120"/>
+              </a:rPr>
+              <a:t>Preliminary: only the empty baseline is cleanly paired. Nonlinear domain adaptation needs far more paired data (multiple sessions, matched tumor positions).</a:t>
+            </a:r>
+            <a:endParaRPr lang="en-US" sz="1250" dirty="0"/>
+          </a:p>
+        </p:txBody>
+      </p:sp>
     </p:spTree>
   </p:cSld>
   <p:clrMapOvr>
@@ -2808,6 +3944,140 @@
 <file path=ppt/slides/slide12.xml><?xml version="1.0" encoding="utf-8"?>
 <p:sld xmlns:a="http://schemas.openxmlformats.org/drawingml/2006/main" xmlns:r="http://schemas.openxmlformats.org/officeDocument/2006/relationships" xmlns:p="http://schemas.openxmlformats.org/presentationml/2006/main">
   <p:cSld name="Slide 12">
+    <p:bg>
+      <p:bgPr>
+        <a:solidFill>
+          <a:srgbClr val="FFFFFF"/>
+        </a:solidFill>
+      </p:bgPr>
+    </p:bg>
+    <p:spTree>
+      <p:nvGrpSpPr>
+        <p:cNvPr id="1" name=""/>
+        <p:cNvGrpSpPr/>
+        <p:nvPr/>
+      </p:nvGrpSpPr>
+      <p:grpSpPr>
+        <a:xfrm>
+          <a:off x="0" y="0"/>
+          <a:ext cx="0" cy="0"/>
+          <a:chOff x="0" y="0"/>
+          <a:chExt cx="0" cy="0"/>
+        </a:xfrm>
+      </p:grpSpPr>
+      <p:sp>
+        <p:nvSpPr>
+          <p:cNvPr id="2" name="Text 0"/>
+          <p:cNvSpPr/>
+          <p:nvPr/>
+        </p:nvSpPr>
+        <p:spPr>
+          <a:xfrm>
+            <a:off x="548640" y="384048"/>
+            <a:ext cx="11091672" cy="640080"/>
+          </a:xfrm>
+          <a:prstGeom prst="rect">
+            <a:avLst/>
+          </a:prstGeom>
+          <a:noFill/>
+          <a:ln/>
+        </p:spPr>
+        <p:txBody>
+          <a:bodyPr wrap="square" lIns="0" tIns="0" rIns="0" bIns="0" rtlCol="0" anchor="ctr"/>
+          <a:lstStyle/>
+          <a:p>
+            <a:pPr indent="0" marL="0">
+              <a:buNone/>
+            </a:pPr>
+            <a:r>
+              <a:rPr lang="en-US" sz="2900" b="1" dirty="0">
+                <a:solidFill>
+                  <a:srgbClr val="2A1618"/>
+                </a:solidFill>
+                <a:latin typeface="Cambria" pitchFamily="34" charset="0"/>
+                <a:ea typeface="Cambria" pitchFamily="34" charset="-122"/>
+                <a:cs typeface="Cambria" pitchFamily="34" charset="-120"/>
+              </a:rPr>
+              <a:t>Beet (dielectric) vs metal tumor, sim and measured</a:t>
+            </a:r>
+            <a:endParaRPr lang="en-US" sz="2900" dirty="0"/>
+          </a:p>
+        </p:txBody>
+      </p:sp>
+      <p:sp>
+        <p:nvSpPr>
+          <p:cNvPr id="3" name="Text 1"/>
+          <p:cNvSpPr/>
+          <p:nvPr/>
+        </p:nvSpPr>
+        <p:spPr>
+          <a:xfrm>
+            <a:off x="548640" y="1033272"/>
+            <a:ext cx="11091672" cy="365760"/>
+          </a:xfrm>
+          <a:prstGeom prst="rect">
+            <a:avLst/>
+          </a:prstGeom>
+          <a:noFill/>
+          <a:ln/>
+        </p:spPr>
+        <p:txBody>
+          <a:bodyPr wrap="square" lIns="0" tIns="0" rIns="0" bIns="0" rtlCol="0" anchor="ctr"/>
+          <a:lstStyle/>
+          <a:p>
+            <a:pPr indent="0" marL="0">
+              <a:buNone/>
+            </a:pPr>
+            <a:r>
+              <a:rPr lang="en-US" sz="1400" b="1" dirty="0">
+                <a:solidFill>
+                  <a:srgbClr val="BE0000"/>
+                </a:solidFill>
+                <a:latin typeface="Calibri" pitchFamily="34" charset="0"/>
+                <a:ea typeface="Calibri" pitchFamily="34" charset="-122"/>
+                <a:cs typeface="Calibri" pitchFamily="34" charset="-120"/>
+              </a:rPr>
+              <a:t>How much differential signal a realistic dielectric target produces relative to metal</a:t>
+            </a:r>
+            <a:endParaRPr lang="en-US" sz="1400" dirty="0"/>
+          </a:p>
+        </p:txBody>
+      </p:sp>
+      <p:pic>
+        <p:nvPicPr>
+          <p:cNvPr id="4" name="Image 0" descr="beet_vs_metal_dS.png">    </p:cNvPr>
+          <p:cNvPicPr>
+            <a:picLocks noChangeAspect="1"/>
+          </p:cNvPicPr>
+          <p:nvPr/>
+        </p:nvPicPr>
+        <p:blipFill>
+          <a:blip r:embed="rId1"/>
+          <a:stretch>
+            <a:fillRect/>
+          </a:stretch>
+        </p:blipFill>
+        <p:spPr>
+          <a:xfrm>
+            <a:off x="822960" y="1737360"/>
+            <a:ext cx="10515600" cy="4892040"/>
+          </a:xfrm>
+          <a:prstGeom prst="rect">
+            <a:avLst/>
+          </a:prstGeom>
+        </p:spPr>
+      </p:pic>
+    </p:spTree>
+  </p:cSld>
+  <p:clrMapOvr>
+    <a:masterClrMapping/>
+  </p:clrMapOvr>
+</p:sld>
+</file>
+
+<file path=ppt/slides/slide13.xml><?xml version="1.0" encoding="utf-8"?>
+<p:sld xmlns:a="http://schemas.openxmlformats.org/drawingml/2006/main" xmlns:r="http://schemas.openxmlformats.org/officeDocument/2006/relationships" xmlns:p="http://schemas.openxmlformats.org/presentationml/2006/main">
+  <p:cSld name="Slide 13">
     <p:bg>
       <p:bgPr>
         <a:solidFill>

</xml_diff>

<commit_message>
Deck 3: add Test 1 zero-shot sim->measured slide (direct transfer collapses)
Train a CNN on simulated tumor dS only, test directly on the measured
bench. In-domain (held-out sim) reaches 15 mm, but zero-shot transfer to
measured hits 74 mm, worse than the 34 mm predict-centre chance line, with
predictions collapsing to one biased corner. Motivates the linear
sim->measured calibration (following slides).

- zero_shot_sim2meas.py: PyTorch CNN, sim tumor dS (remapped to physical
  antenna order), tested on June18 measured; saves results npz
- fig_zero_shot.py: 2-panel figure (error bars + prediction collapse)
- deck3: new slide before the calibration-map method slide

Co-Authored-By: Claude Opus 4.8 <noreply@anthropic.com>
</commit_message>
<xml_diff>
--- a/regression_deck/Deck3_Sim_vs_Measured.pptx
+++ b/regression_deck/Deck3_Sim_vs_Measured.pptx
@@ -18,9 +18,10 @@
     <p:sldId id="266" r:id="rId12"/>
     <p:sldId id="267" r:id="rId13"/>
     <p:sldId id="268" r:id="rId14"/>
+    <p:sldId id="269" r:id="rId15"/>
   </p:sldIdLst>
   <p:notesMasterIdLst>
-    <p:notesMasterId r:id="rId15"/>
+    <p:notesMasterId r:id="rId16"/>
   </p:notesMasterIdLst>
   <p:sldSz cx="12188952" cy="6858000"/>
   <p:notesSz cx="6858000" cy="12188952"/>
@@ -890,6 +891,94 @@
             <a:fld id="{F7021451-1387-4CA6-816F-3879F97B5CBC}" type="slidenum">
               <a:rPr lang="en-US"/>
               <a:t>13</a:t>
+            </a:fld>
+            <a:endParaRPr lang="en-US"/>
+          </a:p>
+        </p:txBody>
+      </p:sp>
+    </p:spTree>
+    <p:extLst>
+      <p:ext uri="{BB962C8B-B14F-4D97-AF65-F5344CB8AC3E}">
+        <p14:creationId xmlns:p14="http://schemas.microsoft.com/office/powerpoint/2010/main" val="1024086991"/>
+      </p:ext>
+    </p:extLst>
+  </p:cSld>
+  <p:clrMapOvr>
+    <a:masterClrMapping/>
+  </p:clrMapOvr>
+</p:notes>
+</file>
+
+<file path=ppt/notesSlides/notesSlide14.xml><?xml version="1.0" encoding="utf-8"?>
+<p:notes xmlns:a="http://schemas.openxmlformats.org/drawingml/2006/main" xmlns:r="http://schemas.openxmlformats.org/officeDocument/2006/relationships" xmlns:p="http://schemas.openxmlformats.org/presentationml/2006/main">
+  <p:cSld>
+    <p:spTree>
+      <p:nvGrpSpPr>
+        <p:cNvPr id="1" name=""/>
+        <p:cNvGrpSpPr/>
+        <p:nvPr/>
+      </p:nvGrpSpPr>
+      <p:grpSpPr>
+        <a:xfrm>
+          <a:off x="0" y="0"/>
+          <a:ext cx="0" cy="0"/>
+          <a:chOff x="0" y="0"/>
+          <a:chExt cx="0" cy="0"/>
+        </a:xfrm>
+      </p:grpSpPr>
+      <p:sp>
+        <p:nvSpPr>
+          <p:cNvPr id="2" name="Slide Image Placeholder 1"/>
+          <p:cNvSpPr>
+            <a:spLocks noGrp="1" noRot="1" noChangeAspect="1"/>
+          </p:cNvSpPr>
+          <p:nvPr>
+            <p:ph type="sldImg"/>
+          </p:nvPr>
+        </p:nvSpPr>
+        <p:spPr/>
+      </p:sp>
+      <p:sp>
+        <p:nvSpPr>
+          <p:cNvPr id="3" name="Notes Placeholder 2"/>
+          <p:cNvSpPr>
+            <a:spLocks noGrp="1"/>
+          </p:cNvSpPr>
+          <p:nvPr>
+            <p:ph type="body" idx="1"/>
+          </p:nvPr>
+        </p:nvSpPr>
+        <p:spPr/>
+        <p:txBody>
+          <a:bodyPr/>
+          <a:lstStyle/>
+          <a:p>
+            <a:r>
+              <a:rPr lang="en-US" dirty="0"/>
+              <a:t/>
+            </a:r>
+            <a:endParaRPr lang="en-US" dirty="0"/>
+          </a:p>
+        </p:txBody>
+      </p:sp>
+      <p:sp>
+        <p:nvSpPr>
+          <p:cNvPr id="4" name="Slide Number Placeholder 3"/>
+          <p:cNvSpPr>
+            <a:spLocks noGrp="1"/>
+          </p:cNvSpPr>
+          <p:nvPr>
+            <p:ph type="sldNum" sz="quarter" idx="10"/>
+          </p:nvPr>
+        </p:nvSpPr>
+        <p:spPr/>
+        <p:txBody>
+          <a:bodyPr/>
+          <a:lstStyle/>
+          <a:p>
+            <a:fld id="{F7021451-1387-4CA6-816F-3879F97B5CBC}" type="slidenum">
+              <a:rPr lang="en-US"/>
+              <a:t>14</a:t>
             </a:fld>
             <a:endParaRPr lang="en-US"/>
           </a:p>
@@ -2399,7 +2488,7 @@
                 <a:ea typeface="Cambria" pitchFamily="34" charset="-122"/>
                 <a:cs typeface="Cambria" pitchFamily="34" charset="-120"/>
               </a:rPr>
-              <a:t>How the sim to measured map is learned</a:t>
+              <a:t>Test 1: zero-shot, train on sim only, test on the bench</a:t>
             </a:r>
             <a:endParaRPr lang="en-US" sz="2900" dirty="0"/>
           </a:p>
@@ -2438,26 +2527,50 @@
                 <a:ea typeface="Calibri" pitchFamily="34" charset="-122"/>
                 <a:cs typeface="Calibri" pitchFamily="34" charset="-120"/>
               </a:rPr>
-              <a:t>A linear transfer fit on the empty baseline and tested on frequencies it never saw</a:t>
+              <a:t>If the CNN sees only simulated tumors, can it locate a real one? Direct transfer collapses</a:t>
             </a:r>
             <a:endParaRPr lang="en-US" sz="1400" dirty="0"/>
           </a:p>
         </p:txBody>
       </p:sp>
-      <p:sp>
-        <p:nvSpPr>
-          <p:cNvPr id="4" name="Shape 2"/>
-          <p:cNvSpPr/>
-          <p:nvPr/>
-        </p:nvSpPr>
-        <p:spPr>
-          <a:xfrm>
-            <a:off x="548640" y="1554480"/>
-            <a:ext cx="7040880" cy="822960"/>
+      <p:pic>
+        <p:nvPicPr>
+          <p:cNvPr id="4" name="Image 0" descr="zero_shot_sim2meas.png">    </p:cNvPr>
+          <p:cNvPicPr>
+            <a:picLocks noChangeAspect="1"/>
+          </p:cNvPicPr>
+          <p:nvPr/>
+        </p:nvPicPr>
+        <p:blipFill>
+          <a:blip r:embed="rId1"/>
+          <a:stretch>
+            <a:fillRect/>
+          </a:stretch>
+        </p:blipFill>
+        <p:spPr>
+          <a:xfrm>
+            <a:off x="320040" y="1463040"/>
+            <a:ext cx="8275320" cy="4434840"/>
+          </a:xfrm>
+          <a:prstGeom prst="rect">
+            <a:avLst/>
+          </a:prstGeom>
+        </p:spPr>
+      </p:pic>
+      <p:sp>
+        <p:nvSpPr>
+          <p:cNvPr id="5" name="Shape 2"/>
+          <p:cNvSpPr/>
+          <p:nvPr/>
+        </p:nvSpPr>
+        <p:spPr>
+          <a:xfrm>
+            <a:off x="8732520" y="1554480"/>
+            <a:ext cx="3108960" cy="4480560"/>
           </a:xfrm>
           <a:prstGeom prst="roundRect">
             <a:avLst>
-              <a:gd name="adj" fmla="val 10000"/>
+              <a:gd name="adj" fmla="val 2647"/>
             </a:avLst>
           </a:prstGeom>
           <a:solidFill>
@@ -2480,73 +2593,14 @@
       </p:sp>
       <p:sp>
         <p:nvSpPr>
-          <p:cNvPr id="5" name="Shape 3"/>
-          <p:cNvSpPr/>
-          <p:nvPr/>
-        </p:nvSpPr>
-        <p:spPr>
-          <a:xfrm>
-            <a:off x="749808" y="1737360"/>
-            <a:ext cx="457200" cy="457200"/>
-          </a:xfrm>
-          <a:prstGeom prst="ellipse">
-            <a:avLst/>
-          </a:prstGeom>
-          <a:solidFill>
-            <a:srgbClr val="BE0000"/>
-          </a:solidFill>
-          <a:ln/>
-        </p:spPr>
-      </p:sp>
-      <p:sp>
-        <p:nvSpPr>
-          <p:cNvPr id="6" name="Text 4"/>
-          <p:cNvSpPr/>
-          <p:nvPr/>
-        </p:nvSpPr>
-        <p:spPr>
-          <a:xfrm>
-            <a:off x="749808" y="1737360"/>
-            <a:ext cx="457200" cy="457200"/>
-          </a:xfrm>
-          <a:prstGeom prst="rect">
-            <a:avLst/>
-          </a:prstGeom>
-          <a:noFill/>
-          <a:ln/>
-        </p:spPr>
-        <p:txBody>
-          <a:bodyPr wrap="square" lIns="0" tIns="0" rIns="0" bIns="0" rtlCol="0" anchor="ctr"/>
-          <a:lstStyle/>
-          <a:p>
-            <a:pPr algn="ctr" indent="0" marL="0">
-              <a:buNone/>
-            </a:pPr>
-            <a:r>
-              <a:rPr lang="en-US" sz="1800" b="1" dirty="0">
-                <a:solidFill>
-                  <a:srgbClr val="FFFFFF"/>
-                </a:solidFill>
-                <a:latin typeface="Cambria" pitchFamily="34" charset="0"/>
-                <a:ea typeface="Cambria" pitchFamily="34" charset="-122"/>
-                <a:cs typeface="Cambria" pitchFamily="34" charset="-120"/>
-              </a:rPr>
-              <a:t>1</a:t>
-            </a:r>
-            <a:endParaRPr lang="en-US" sz="1800" dirty="0"/>
-          </a:p>
-        </p:txBody>
-      </p:sp>
-      <p:sp>
-        <p:nvSpPr>
-          <p:cNvPr id="7" name="Text 5"/>
-          <p:cNvSpPr/>
-          <p:nvPr/>
-        </p:nvSpPr>
-        <p:spPr>
-          <a:xfrm>
-            <a:off x="1371600" y="1609344"/>
-            <a:ext cx="2286000" cy="713232"/>
+          <p:cNvPr id="6" name="Text 3"/>
+          <p:cNvSpPr/>
+          <p:nvPr/>
+        </p:nvSpPr>
+        <p:spPr>
+          <a:xfrm>
+            <a:off x="8915400" y="1691640"/>
+            <a:ext cx="2788920" cy="320040"/>
           </a:xfrm>
           <a:prstGeom prst="rect">
             <a:avLst/>
@@ -2570,7 +2624,7 @@
                 <a:ea typeface="Cambria" pitchFamily="34" charset="-122"/>
                 <a:cs typeface="Cambria" pitchFamily="34" charset="-120"/>
               </a:rPr>
-              <a:t>Pair the empty baselines</a:t>
+              <a:t>What this tests</a:t>
             </a:r>
             <a:endParaRPr lang="en-US" sz="1400" dirty="0"/>
           </a:p>
@@ -2578,14 +2632,14 @@
       </p:sp>
       <p:sp>
         <p:nvSpPr>
-          <p:cNvPr id="8" name="Text 6"/>
-          <p:cNvSpPr/>
-          <p:nvPr/>
-        </p:nvSpPr>
-        <p:spPr>
-          <a:xfrm>
-            <a:off x="3703320" y="1591056"/>
-            <a:ext cx="3794760" cy="749808"/>
+          <p:cNvPr id="7" name="Text 4"/>
+          <p:cNvSpPr/>
+          <p:nvPr/>
+        </p:nvSpPr>
+        <p:spPr>
+          <a:xfrm>
+            <a:off x="8915400" y="2057400"/>
+            <a:ext cx="2788920" cy="1371600"/>
           </a:xfrm>
           <a:prstGeom prst="rect">
             <a:avLst/>
@@ -2594,14 +2648,18 @@
           <a:ln/>
         </p:spPr>
         <p:txBody>
-          <a:bodyPr wrap="square" lIns="0" tIns="0" rIns="0" bIns="0" rtlCol="0" anchor="ctr"/>
-          <a:lstStyle/>
-          <a:p>
-            <a:pPr indent="0" marL="0">
-              <a:buNone/>
+          <a:bodyPr wrap="square" lIns="0" tIns="0" rIns="0" bIns="0" rtlCol="0" anchor="t"/>
+          <a:lstStyle/>
+          <a:p>
+            <a:pPr marL="342900" indent="-342900">
+              <a:spcAft>
+                <a:spcPts val="800"/>
+              </a:spcAft>
+              <a:buSzPct val="100000"/>
+              <a:buChar char="•"/>
             </a:pPr>
             <a:r>
-              <a:rPr lang="en-US" sz="1070" dirty="0">
+              <a:rPr lang="en-US" sz="1030" dirty="0">
                 <a:solidFill>
                   <a:srgbClr val="2A1618"/>
                 </a:solidFill>
@@ -2609,115 +2667,43 @@
                 <a:ea typeface="Calibri" pitchFamily="34" charset="-122"/>
                 <a:cs typeface="Calibri" pitchFamily="34" charset="-120"/>
               </a:rPr>
-              <a:t>Sim empty phantom and measured empty phantom are the same physical state (no tumor), so their S-parameters can be matched frequency by frequency.</a:t>
-            </a:r>
-            <a:endParaRPr lang="en-US" sz="1070" dirty="0"/>
-          </a:p>
-        </p:txBody>
-      </p:sp>
-      <p:sp>
-        <p:nvSpPr>
-          <p:cNvPr id="9" name="Shape 7"/>
-          <p:cNvSpPr/>
-          <p:nvPr/>
-        </p:nvSpPr>
-        <p:spPr>
-          <a:xfrm>
-            <a:off x="548640" y="2487168"/>
-            <a:ext cx="7040880" cy="822960"/>
-          </a:xfrm>
-          <a:prstGeom prst="roundRect">
-            <a:avLst>
-              <a:gd name="adj" fmla="val 10000"/>
-            </a:avLst>
-          </a:prstGeom>
-          <a:solidFill>
-            <a:srgbClr val="FBF4F2"/>
-          </a:solidFill>
-          <a:ln w="12700">
-            <a:solidFill>
-              <a:srgbClr val="E7D6D1"/>
-            </a:solidFill>
-            <a:prstDash val="solid"/>
-          </a:ln>
-          <a:effectLst>
-            <a:outerShdw sx="100000" sy="100000" kx="0" ky="0" algn="bl" rotWithShape="0" blurRad="88900" dist="38100" dir="5400000">
-              <a:srgbClr val="7A5C5E">
-                <a:alpha val="18000"/>
-              </a:srgbClr>
-            </a:outerShdw>
-          </a:effectLst>
-        </p:spPr>
-      </p:sp>
-      <p:sp>
-        <p:nvSpPr>
-          <p:cNvPr id="10" name="Shape 8"/>
-          <p:cNvSpPr/>
-          <p:nvPr/>
-        </p:nvSpPr>
-        <p:spPr>
-          <a:xfrm>
-            <a:off x="749808" y="2670048"/>
-            <a:ext cx="457200" cy="457200"/>
-          </a:xfrm>
-          <a:prstGeom prst="ellipse">
-            <a:avLst/>
-          </a:prstGeom>
-          <a:solidFill>
-            <a:srgbClr val="BE0000"/>
-          </a:solidFill>
-          <a:ln/>
-        </p:spPr>
-      </p:sp>
-      <p:sp>
-        <p:nvSpPr>
-          <p:cNvPr id="11" name="Text 9"/>
-          <p:cNvSpPr/>
-          <p:nvPr/>
-        </p:nvSpPr>
-        <p:spPr>
-          <a:xfrm>
-            <a:off x="749808" y="2670048"/>
-            <a:ext cx="457200" cy="457200"/>
-          </a:xfrm>
-          <a:prstGeom prst="rect">
-            <a:avLst/>
-          </a:prstGeom>
-          <a:noFill/>
-          <a:ln/>
-        </p:spPr>
-        <p:txBody>
-          <a:bodyPr wrap="square" lIns="0" tIns="0" rIns="0" bIns="0" rtlCol="0" anchor="ctr"/>
-          <a:lstStyle/>
-          <a:p>
-            <a:pPr algn="ctr" indent="0" marL="0">
-              <a:buNone/>
+              <a:t>Train a CNN on simulated tumor dS only; no measured data is seen in training.</a:t>
+            </a:r>
+            <a:endParaRPr lang="en-US" sz="1030" dirty="0"/>
+          </a:p>
+          <a:p>
+            <a:pPr marL="342900" indent="-342900">
+              <a:spcAft>
+                <a:spcPts val="800"/>
+              </a:spcAft>
+              <a:buSzPct val="100000"/>
+              <a:buChar char="•"/>
             </a:pPr>
             <a:r>
-              <a:rPr lang="en-US" sz="1800" b="1" dirty="0">
+              <a:rPr lang="en-US" sz="1030" dirty="0">
                 <a:solidFill>
-                  <a:srgbClr val="FFFFFF"/>
+                  <a:srgbClr val="2A1618"/>
                 </a:solidFill>
-                <a:latin typeface="Cambria" pitchFamily="34" charset="0"/>
-                <a:ea typeface="Cambria" pitchFamily="34" charset="-122"/>
-                <a:cs typeface="Cambria" pitchFamily="34" charset="-120"/>
+                <a:latin typeface="Calibri" pitchFamily="34" charset="0"/>
+                <a:ea typeface="Calibri" pitchFamily="34" charset="-122"/>
+                <a:cs typeface="Calibri" pitchFamily="34" charset="-120"/>
               </a:rPr>
-              <a:t>2</a:t>
-            </a:r>
-            <a:endParaRPr lang="en-US" sz="1800" dirty="0"/>
-          </a:p>
-        </p:txBody>
-      </p:sp>
-      <p:sp>
-        <p:nvSpPr>
-          <p:cNvPr id="12" name="Text 10"/>
-          <p:cNvSpPr/>
-          <p:nvPr/>
-        </p:nvSpPr>
-        <p:spPr>
-          <a:xfrm>
-            <a:off x="1371600" y="2542032"/>
-            <a:ext cx="2286000" cy="713232"/>
+              <a:t>Then hand it the measured S-parameters and ask for (x,y).</a:t>
+            </a:r>
+            <a:endParaRPr lang="en-US" sz="1030" dirty="0"/>
+          </a:p>
+        </p:txBody>
+      </p:sp>
+      <p:sp>
+        <p:nvSpPr>
+          <p:cNvPr id="8" name="Text 5"/>
+          <p:cNvSpPr/>
+          <p:nvPr/>
+        </p:nvSpPr>
+        <p:spPr>
+          <a:xfrm>
+            <a:off x="8915400" y="3611880"/>
+            <a:ext cx="2788920" cy="320040"/>
           </a:xfrm>
           <a:prstGeom prst="rect">
             <a:avLst/>
@@ -2741,7 +2727,7 @@
                 <a:ea typeface="Cambria" pitchFamily="34" charset="-122"/>
                 <a:cs typeface="Cambria" pitchFamily="34" charset="-120"/>
               </a:rPr>
-              <a:t>One vector per frequency</a:t>
+              <a:t>The result</a:t>
             </a:r>
             <a:endParaRPr lang="en-US" sz="1400" dirty="0"/>
           </a:p>
@@ -2749,14 +2735,14 @@
       </p:sp>
       <p:sp>
         <p:nvSpPr>
-          <p:cNvPr id="13" name="Text 11"/>
-          <p:cNvSpPr/>
-          <p:nvPr/>
-        </p:nvSpPr>
-        <p:spPr>
-          <a:xfrm>
-            <a:off x="3703320" y="2523744"/>
-            <a:ext cx="3794760" cy="749808"/>
+          <p:cNvPr id="9" name="Text 6"/>
+          <p:cNvSpPr/>
+          <p:nvPr/>
+        </p:nvSpPr>
+        <p:spPr>
+          <a:xfrm>
+            <a:off x="8915400" y="3977640"/>
+            <a:ext cx="2788920" cy="1965960"/>
           </a:xfrm>
           <a:prstGeom prst="rect">
             <a:avLst/>
@@ -2765,14 +2751,18 @@
           <a:ln/>
         </p:spPr>
         <p:txBody>
-          <a:bodyPr wrap="square" lIns="0" tIns="0" rIns="0" bIns="0" rtlCol="0" anchor="ctr"/>
-          <a:lstStyle/>
-          <a:p>
-            <a:pPr indent="0" marL="0">
-              <a:buNone/>
+          <a:bodyPr wrap="square" lIns="0" tIns="0" rIns="0" bIns="0" rtlCol="0" anchor="t"/>
+          <a:lstStyle/>
+          <a:p>
+            <a:pPr marL="342900" indent="-342900">
+              <a:spcAft>
+                <a:spcPts val="800"/>
+              </a:spcAft>
+              <a:buSzPct val="100000"/>
+              <a:buChar char="•"/>
             </a:pPr>
             <a:r>
-              <a:rPr lang="en-US" sz="1070" dirty="0">
+              <a:rPr lang="en-US" sz="1030" dirty="0">
                 <a:solidFill>
                   <a:srgbClr val="2A1618"/>
                 </a:solidFill>
@@ -2780,170 +2770,20 @@
                 <a:ea typeface="Calibri" pitchFamily="34" charset="-122"/>
                 <a:cs typeface="Calibri" pitchFamily="34" charset="-120"/>
               </a:rPr>
-              <a:t>At each of 512 frequencies (2 to 8 GHz), stack the real and imaginary parts of the 16 S-parameters into a 32-D vector. Sim = input x, measured = target y.</a:t>
-            </a:r>
-            <a:endParaRPr lang="en-US" sz="1070" dirty="0"/>
-          </a:p>
-        </p:txBody>
-      </p:sp>
-      <p:sp>
-        <p:nvSpPr>
-          <p:cNvPr id="14" name="Shape 12"/>
-          <p:cNvSpPr/>
-          <p:nvPr/>
-        </p:nvSpPr>
-        <p:spPr>
-          <a:xfrm>
-            <a:off x="548640" y="3419856"/>
-            <a:ext cx="7040880" cy="822960"/>
-          </a:xfrm>
-          <a:prstGeom prst="roundRect">
-            <a:avLst>
-              <a:gd name="adj" fmla="val 10000"/>
-            </a:avLst>
-          </a:prstGeom>
-          <a:solidFill>
-            <a:srgbClr val="FBF4F2"/>
-          </a:solidFill>
-          <a:ln w="12700">
-            <a:solidFill>
-              <a:srgbClr val="E7D6D1"/>
-            </a:solidFill>
-            <a:prstDash val="solid"/>
-          </a:ln>
-          <a:effectLst>
-            <a:outerShdw sx="100000" sy="100000" kx="0" ky="0" algn="bl" rotWithShape="0" blurRad="88900" dist="38100" dir="5400000">
-              <a:srgbClr val="7A5C5E">
-                <a:alpha val="18000"/>
-              </a:srgbClr>
-            </a:outerShdw>
-          </a:effectLst>
-        </p:spPr>
-      </p:sp>
-      <p:sp>
-        <p:nvSpPr>
-          <p:cNvPr id="15" name="Shape 13"/>
-          <p:cNvSpPr/>
-          <p:nvPr/>
-        </p:nvSpPr>
-        <p:spPr>
-          <a:xfrm>
-            <a:off x="749808" y="3602736"/>
-            <a:ext cx="457200" cy="457200"/>
-          </a:xfrm>
-          <a:prstGeom prst="ellipse">
-            <a:avLst/>
-          </a:prstGeom>
-          <a:solidFill>
-            <a:srgbClr val="BE0000"/>
-          </a:solidFill>
-          <a:ln/>
-        </p:spPr>
-      </p:sp>
-      <p:sp>
-        <p:nvSpPr>
-          <p:cNvPr id="16" name="Text 14"/>
-          <p:cNvSpPr/>
-          <p:nvPr/>
-        </p:nvSpPr>
-        <p:spPr>
-          <a:xfrm>
-            <a:off x="749808" y="3602736"/>
-            <a:ext cx="457200" cy="457200"/>
-          </a:xfrm>
-          <a:prstGeom prst="rect">
-            <a:avLst/>
-          </a:prstGeom>
-          <a:noFill/>
-          <a:ln/>
-        </p:spPr>
-        <p:txBody>
-          <a:bodyPr wrap="square" lIns="0" tIns="0" rIns="0" bIns="0" rtlCol="0" anchor="ctr"/>
-          <a:lstStyle/>
-          <a:p>
-            <a:pPr algn="ctr" indent="0" marL="0">
-              <a:buNone/>
+              <a:t>In-domain (held-out sim) it localizes to 15 mm, so the pipeline works.</a:t>
+            </a:r>
+            <a:endParaRPr lang="en-US" sz="1030" dirty="0"/>
+          </a:p>
+          <a:p>
+            <a:pPr marL="342900" indent="-342900">
+              <a:spcAft>
+                <a:spcPts val="800"/>
+              </a:spcAft>
+              <a:buSzPct val="100000"/>
+              <a:buChar char="•"/>
             </a:pPr>
             <a:r>
-              <a:rPr lang="en-US" sz="1800" b="1" dirty="0">
-                <a:solidFill>
-                  <a:srgbClr val="FFFFFF"/>
-                </a:solidFill>
-                <a:latin typeface="Cambria" pitchFamily="34" charset="0"/>
-                <a:ea typeface="Cambria" pitchFamily="34" charset="-122"/>
-                <a:cs typeface="Cambria" pitchFamily="34" charset="-120"/>
-              </a:rPr>
-              <a:t>3</a:t>
-            </a:r>
-            <a:endParaRPr lang="en-US" sz="1800" dirty="0"/>
-          </a:p>
-        </p:txBody>
-      </p:sp>
-      <p:sp>
-        <p:nvSpPr>
-          <p:cNvPr id="17" name="Text 15"/>
-          <p:cNvSpPr/>
-          <p:nvPr/>
-        </p:nvSpPr>
-        <p:spPr>
-          <a:xfrm>
-            <a:off x="1371600" y="3474720"/>
-            <a:ext cx="2286000" cy="713232"/>
-          </a:xfrm>
-          <a:prstGeom prst="rect">
-            <a:avLst/>
-          </a:prstGeom>
-          <a:noFill/>
-          <a:ln/>
-        </p:spPr>
-        <p:txBody>
-          <a:bodyPr wrap="square" lIns="0" tIns="0" rIns="0" bIns="0" rtlCol="0" anchor="ctr"/>
-          <a:lstStyle/>
-          <a:p>
-            <a:pPr indent="0" marL="0">
-              <a:buNone/>
-            </a:pPr>
-            <a:r>
-              <a:rPr lang="en-US" sz="1400" b="1" dirty="0">
-                <a:solidFill>
-                  <a:srgbClr val="BE0000"/>
-                </a:solidFill>
-                <a:latin typeface="Cambria" pitchFamily="34" charset="0"/>
-                <a:ea typeface="Cambria" pitchFamily="34" charset="-122"/>
-                <a:cs typeface="Cambria" pitchFamily="34" charset="-120"/>
-              </a:rPr>
-              <a:t>Split the frequencies 70 / 30</a:t>
-            </a:r>
-            <a:endParaRPr lang="en-US" sz="1400" dirty="0"/>
-          </a:p>
-        </p:txBody>
-      </p:sp>
-      <p:sp>
-        <p:nvSpPr>
-          <p:cNvPr id="18" name="Text 16"/>
-          <p:cNvSpPr/>
-          <p:nvPr/>
-        </p:nvSpPr>
-        <p:spPr>
-          <a:xfrm>
-            <a:off x="3703320" y="3456432"/>
-            <a:ext cx="3794760" cy="749808"/>
-          </a:xfrm>
-          <a:prstGeom prst="rect">
-            <a:avLst/>
-          </a:prstGeom>
-          <a:noFill/>
-          <a:ln/>
-        </p:spPr>
-        <p:txBody>
-          <a:bodyPr wrap="square" lIns="0" tIns="0" rIns="0" bIns="0" rtlCol="0" anchor="ctr"/>
-          <a:lstStyle/>
-          <a:p>
-            <a:pPr indent="0" marL="0">
-              <a:buNone/>
-            </a:pPr>
-            <a:r>
-              <a:rPr lang="en-US" sz="1070" dirty="0">
+              <a:rPr lang="en-US" sz="1030" dirty="0">
                 <a:solidFill>
                   <a:srgbClr val="2A1618"/>
                 </a:solidFill>
@@ -2951,170 +2791,20 @@
                 <a:ea typeface="Calibri" pitchFamily="34" charset="-122"/>
                 <a:cs typeface="Calibri" pitchFamily="34" charset="-120"/>
               </a:rPr>
-              <a:t>Fit on 70% of the frequencies; hold out the other 30% for testing. The map never sees the test frequencies while it is being fit.</a:t>
-            </a:r>
-            <a:endParaRPr lang="en-US" sz="1070" dirty="0"/>
-          </a:p>
-        </p:txBody>
-      </p:sp>
-      <p:sp>
-        <p:nvSpPr>
-          <p:cNvPr id="19" name="Shape 17"/>
-          <p:cNvSpPr/>
-          <p:nvPr/>
-        </p:nvSpPr>
-        <p:spPr>
-          <a:xfrm>
-            <a:off x="548640" y="4352544"/>
-            <a:ext cx="7040880" cy="822960"/>
-          </a:xfrm>
-          <a:prstGeom prst="roundRect">
-            <a:avLst>
-              <a:gd name="adj" fmla="val 10000"/>
-            </a:avLst>
-          </a:prstGeom>
-          <a:solidFill>
-            <a:srgbClr val="FBF4F2"/>
-          </a:solidFill>
-          <a:ln w="12700">
-            <a:solidFill>
-              <a:srgbClr val="E7D6D1"/>
-            </a:solidFill>
-            <a:prstDash val="solid"/>
-          </a:ln>
-          <a:effectLst>
-            <a:outerShdw sx="100000" sy="100000" kx="0" ky="0" algn="bl" rotWithShape="0" blurRad="88900" dist="38100" dir="5400000">
-              <a:srgbClr val="7A5C5E">
-                <a:alpha val="18000"/>
-              </a:srgbClr>
-            </a:outerShdw>
-          </a:effectLst>
-        </p:spPr>
-      </p:sp>
-      <p:sp>
-        <p:nvSpPr>
-          <p:cNvPr id="20" name="Shape 18"/>
-          <p:cNvSpPr/>
-          <p:nvPr/>
-        </p:nvSpPr>
-        <p:spPr>
-          <a:xfrm>
-            <a:off x="749808" y="4535424"/>
-            <a:ext cx="457200" cy="457200"/>
-          </a:xfrm>
-          <a:prstGeom prst="ellipse">
-            <a:avLst/>
-          </a:prstGeom>
-          <a:solidFill>
-            <a:srgbClr val="BE0000"/>
-          </a:solidFill>
-          <a:ln/>
-        </p:spPr>
-      </p:sp>
-      <p:sp>
-        <p:nvSpPr>
-          <p:cNvPr id="21" name="Text 19"/>
-          <p:cNvSpPr/>
-          <p:nvPr/>
-        </p:nvSpPr>
-        <p:spPr>
-          <a:xfrm>
-            <a:off x="749808" y="4535424"/>
-            <a:ext cx="457200" cy="457200"/>
-          </a:xfrm>
-          <a:prstGeom prst="rect">
-            <a:avLst/>
-          </a:prstGeom>
-          <a:noFill/>
-          <a:ln/>
-        </p:spPr>
-        <p:txBody>
-          <a:bodyPr wrap="square" lIns="0" tIns="0" rIns="0" bIns="0" rtlCol="0" anchor="ctr"/>
-          <a:lstStyle/>
-          <a:p>
-            <a:pPr algn="ctr" indent="0" marL="0">
-              <a:buNone/>
+              <a:t>On the bench it hits 74 mm, worse than the 34 mm predict-centre chance line.</a:t>
+            </a:r>
+            <a:endParaRPr lang="en-US" sz="1030" dirty="0"/>
+          </a:p>
+          <a:p>
+            <a:pPr marL="342900" indent="-342900">
+              <a:spcAft>
+                <a:spcPts val="800"/>
+              </a:spcAft>
+              <a:buSzPct val="100000"/>
+              <a:buChar char="•"/>
             </a:pPr>
             <a:r>
-              <a:rPr lang="en-US" sz="1800" b="1" dirty="0">
-                <a:solidFill>
-                  <a:srgbClr val="FFFFFF"/>
-                </a:solidFill>
-                <a:latin typeface="Cambria" pitchFamily="34" charset="0"/>
-                <a:ea typeface="Cambria" pitchFamily="34" charset="-122"/>
-                <a:cs typeface="Cambria" pitchFamily="34" charset="-120"/>
-              </a:rPr>
-              <a:t>4</a:t>
-            </a:r>
-            <a:endParaRPr lang="en-US" sz="1800" dirty="0"/>
-          </a:p>
-        </p:txBody>
-      </p:sp>
-      <p:sp>
-        <p:nvSpPr>
-          <p:cNvPr id="22" name="Text 20"/>
-          <p:cNvSpPr/>
-          <p:nvPr/>
-        </p:nvSpPr>
-        <p:spPr>
-          <a:xfrm>
-            <a:off x="1371600" y="4407408"/>
-            <a:ext cx="2286000" cy="713232"/>
-          </a:xfrm>
-          <a:prstGeom prst="rect">
-            <a:avLst/>
-          </a:prstGeom>
-          <a:noFill/>
-          <a:ln/>
-        </p:spPr>
-        <p:txBody>
-          <a:bodyPr wrap="square" lIns="0" tIns="0" rIns="0" bIns="0" rtlCol="0" anchor="ctr"/>
-          <a:lstStyle/>
-          <a:p>
-            <a:pPr indent="0" marL="0">
-              <a:buNone/>
-            </a:pPr>
-            <a:r>
-              <a:rPr lang="en-US" sz="1400" b="1" dirty="0">
-                <a:solidFill>
-                  <a:srgbClr val="BE0000"/>
-                </a:solidFill>
-                <a:latin typeface="Cambria" pitchFamily="34" charset="0"/>
-                <a:ea typeface="Cambria" pitchFamily="34" charset="-122"/>
-                <a:cs typeface="Cambria" pitchFamily="34" charset="-120"/>
-              </a:rPr>
-              <a:t>Fit the linear map</a:t>
-            </a:r>
-            <a:endParaRPr lang="en-US" sz="1400" dirty="0"/>
-          </a:p>
-        </p:txBody>
-      </p:sp>
-      <p:sp>
-        <p:nvSpPr>
-          <p:cNvPr id="23" name="Text 21"/>
-          <p:cNvSpPr/>
-          <p:nvPr/>
-        </p:nvSpPr>
-        <p:spPr>
-          <a:xfrm>
-            <a:off x="3703320" y="4389120"/>
-            <a:ext cx="3794760" cy="749808"/>
-          </a:xfrm>
-          <a:prstGeom prst="rect">
-            <a:avLst/>
-          </a:prstGeom>
-          <a:noFill/>
-          <a:ln/>
-        </p:spPr>
-        <p:txBody>
-          <a:bodyPr wrap="square" lIns="0" tIns="0" rIns="0" bIns="0" rtlCol="0" anchor="ctr"/>
-          <a:lstStyle/>
-          <a:p>
-            <a:pPr indent="0" marL="0">
-              <a:buNone/>
-            </a:pPr>
-            <a:r>
-              <a:rPr lang="en-US" sz="1070" dirty="0">
+              <a:rPr lang="en-US" sz="1030" dirty="0">
                 <a:solidFill>
                   <a:srgbClr val="2A1618"/>
                 </a:solidFill>
@@ -3122,76 +2812,22 @@
                 <a:ea typeface="Calibri" pitchFamily="34" charset="-122"/>
                 <a:cs typeface="Calibri" pitchFamily="34" charset="-120"/>
               </a:rPr>
-              <a:t>Ridge (L2) regression learns a 32x32 matrix W and offset b that best convert the sim vector into the measured vector.</a:t>
-            </a:r>
-            <a:endParaRPr lang="en-US" sz="1070" dirty="0"/>
-          </a:p>
-        </p:txBody>
-      </p:sp>
-      <p:sp>
-        <p:nvSpPr>
-          <p:cNvPr id="24" name="Shape 22"/>
-          <p:cNvSpPr/>
-          <p:nvPr/>
-        </p:nvSpPr>
-        <p:spPr>
-          <a:xfrm>
-            <a:off x="548640" y="5285232"/>
-            <a:ext cx="7040880" cy="822960"/>
-          </a:xfrm>
-          <a:prstGeom prst="roundRect">
-            <a:avLst>
-              <a:gd name="adj" fmla="val 10000"/>
-            </a:avLst>
-          </a:prstGeom>
-          <a:solidFill>
-            <a:srgbClr val="FBF4F2"/>
-          </a:solidFill>
-          <a:ln w="12700">
-            <a:solidFill>
-              <a:srgbClr val="E7D6D1"/>
-            </a:solidFill>
-            <a:prstDash val="solid"/>
-          </a:ln>
-          <a:effectLst>
-            <a:outerShdw sx="100000" sy="100000" kx="0" ky="0" algn="bl" rotWithShape="0" blurRad="88900" dist="38100" dir="5400000">
-              <a:srgbClr val="7A5C5E">
-                <a:alpha val="18000"/>
-              </a:srgbClr>
-            </a:outerShdw>
-          </a:effectLst>
-        </p:spPr>
-      </p:sp>
-      <p:sp>
-        <p:nvSpPr>
-          <p:cNvPr id="25" name="Shape 23"/>
-          <p:cNvSpPr/>
-          <p:nvPr/>
-        </p:nvSpPr>
-        <p:spPr>
-          <a:xfrm>
-            <a:off x="749808" y="5468112"/>
-            <a:ext cx="457200" cy="457200"/>
-          </a:xfrm>
-          <a:prstGeom prst="ellipse">
-            <a:avLst/>
-          </a:prstGeom>
-          <a:solidFill>
-            <a:srgbClr val="BE0000"/>
-          </a:solidFill>
-          <a:ln/>
-        </p:spPr>
-      </p:sp>
-      <p:sp>
-        <p:nvSpPr>
-          <p:cNvPr id="26" name="Text 24"/>
-          <p:cNvSpPr/>
-          <p:nvPr/>
-        </p:nvSpPr>
-        <p:spPr>
-          <a:xfrm>
-            <a:off x="749808" y="5468112"/>
-            <a:ext cx="457200" cy="457200"/>
+              <a:t>Predictions collapse to one biased corner: the measured signal is out-of-distribution for a sim-only model.</a:t>
+            </a:r>
+            <a:endParaRPr lang="en-US" sz="1030" dirty="0"/>
+          </a:p>
+        </p:txBody>
+      </p:sp>
+      <p:sp>
+        <p:nvSpPr>
+          <p:cNvPr id="10" name="Text 7"/>
+          <p:cNvSpPr/>
+          <p:nvPr/>
+        </p:nvSpPr>
+        <p:spPr>
+          <a:xfrm>
+            <a:off x="320040" y="6035040"/>
+            <a:ext cx="8275320" cy="502920"/>
           </a:xfrm>
           <a:prstGeom prst="rect">
             <a:avLst/>
@@ -3207,236 +2843,7 @@
               <a:buNone/>
             </a:pPr>
             <a:r>
-              <a:rPr lang="en-US" sz="1800" b="1" dirty="0">
-                <a:solidFill>
-                  <a:srgbClr val="FFFFFF"/>
-                </a:solidFill>
-                <a:latin typeface="Cambria" pitchFamily="34" charset="0"/>
-                <a:ea typeface="Cambria" pitchFamily="34" charset="-122"/>
-                <a:cs typeface="Cambria" pitchFamily="34" charset="-120"/>
-              </a:rPr>
-              <a:t>5</a:t>
-            </a:r>
-            <a:endParaRPr lang="en-US" sz="1800" dirty="0"/>
-          </a:p>
-        </p:txBody>
-      </p:sp>
-      <p:sp>
-        <p:nvSpPr>
-          <p:cNvPr id="27" name="Text 25"/>
-          <p:cNvSpPr/>
-          <p:nvPr/>
-        </p:nvSpPr>
-        <p:spPr>
-          <a:xfrm>
-            <a:off x="1371600" y="5340096"/>
-            <a:ext cx="2286000" cy="713232"/>
-          </a:xfrm>
-          <a:prstGeom prst="rect">
-            <a:avLst/>
-          </a:prstGeom>
-          <a:noFill/>
-          <a:ln/>
-        </p:spPr>
-        <p:txBody>
-          <a:bodyPr wrap="square" lIns="0" tIns="0" rIns="0" bIns="0" rtlCol="0" anchor="ctr"/>
-          <a:lstStyle/>
-          <a:p>
-            <a:pPr indent="0" marL="0">
-              <a:buNone/>
-            </a:pPr>
-            <a:r>
-              <a:rPr lang="en-US" sz="1400" b="1" dirty="0">
-                <a:solidFill>
-                  <a:srgbClr val="BE0000"/>
-                </a:solidFill>
-                <a:latin typeface="Cambria" pitchFamily="34" charset="0"/>
-                <a:ea typeface="Cambria" pitchFamily="34" charset="-122"/>
-                <a:cs typeface="Cambria" pitchFamily="34" charset="-120"/>
-              </a:rPr>
-              <a:t>Test on the held-out 30%</a:t>
-            </a:r>
-            <a:endParaRPr lang="en-US" sz="1400" dirty="0"/>
-          </a:p>
-        </p:txBody>
-      </p:sp>
-      <p:sp>
-        <p:nvSpPr>
-          <p:cNvPr id="28" name="Text 26"/>
-          <p:cNvSpPr/>
-          <p:nvPr/>
-        </p:nvSpPr>
-        <p:spPr>
-          <a:xfrm>
-            <a:off x="3703320" y="5321808"/>
-            <a:ext cx="3794760" cy="749808"/>
-          </a:xfrm>
-          <a:prstGeom prst="rect">
-            <a:avLst/>
-          </a:prstGeom>
-          <a:noFill/>
-          <a:ln/>
-        </p:spPr>
-        <p:txBody>
-          <a:bodyPr wrap="square" lIns="0" tIns="0" rIns="0" bIns="0" rtlCol="0" anchor="ctr"/>
-          <a:lstStyle/>
-          <a:p>
-            <a:pPr indent="0" marL="0">
-              <a:buNone/>
-            </a:pPr>
-            <a:r>
-              <a:rPr lang="en-US" sz="1070" dirty="0">
-                <a:solidFill>
-                  <a:srgbClr val="2A1618"/>
-                </a:solidFill>
-                <a:latin typeface="Calibri" pitchFamily="34" charset="0"/>
-                <a:ea typeface="Calibri" pitchFamily="34" charset="-122"/>
-                <a:cs typeface="Calibri" pitchFamily="34" charset="-120"/>
-              </a:rPr>
-              <a:t>Apply W and b to the unseen frequencies and compare to the true measured values, giving R2 = 0.65.</a:t>
-            </a:r>
-            <a:endParaRPr lang="en-US" sz="1070" dirty="0"/>
-          </a:p>
-        </p:txBody>
-      </p:sp>
-      <p:sp>
-        <p:nvSpPr>
-          <p:cNvPr id="29" name="Shape 27"/>
-          <p:cNvSpPr/>
-          <p:nvPr/>
-        </p:nvSpPr>
-        <p:spPr>
-          <a:xfrm>
-            <a:off x="7772400" y="1554480"/>
-            <a:ext cx="3886200" cy="1600200"/>
-          </a:xfrm>
-          <a:prstGeom prst="roundRect">
-            <a:avLst>
-              <a:gd name="adj" fmla="val 5143"/>
-            </a:avLst>
-          </a:prstGeom>
-          <a:solidFill>
-            <a:srgbClr val="FBF4F2"/>
-          </a:solidFill>
-          <a:ln w="12700">
-            <a:solidFill>
-              <a:srgbClr val="E7D6D1"/>
-            </a:solidFill>
-            <a:prstDash val="solid"/>
-          </a:ln>
-          <a:effectLst>
-            <a:outerShdw sx="100000" sy="100000" kx="0" ky="0" algn="bl" rotWithShape="0" blurRad="88900" dist="38100" dir="5400000">
-              <a:srgbClr val="7A5C5E">
-                <a:alpha val="18000"/>
-              </a:srgbClr>
-            </a:outerShdw>
-          </a:effectLst>
-        </p:spPr>
-      </p:sp>
-      <p:sp>
-        <p:nvSpPr>
-          <p:cNvPr id="30" name="Text 28"/>
-          <p:cNvSpPr/>
-          <p:nvPr/>
-        </p:nvSpPr>
-        <p:spPr>
-          <a:xfrm>
-            <a:off x="7955280" y="1691640"/>
-            <a:ext cx="3474720" cy="320040"/>
-          </a:xfrm>
-          <a:prstGeom prst="rect">
-            <a:avLst/>
-          </a:prstGeom>
-          <a:noFill/>
-          <a:ln/>
-        </p:spPr>
-        <p:txBody>
-          <a:bodyPr wrap="square" lIns="0" tIns="0" rIns="0" bIns="0" rtlCol="0" anchor="ctr"/>
-          <a:lstStyle/>
-          <a:p>
-            <a:pPr indent="0" marL="0">
-              <a:buNone/>
-            </a:pPr>
-            <a:r>
-              <a:rPr lang="en-US" sz="1400" b="1" dirty="0">
-                <a:solidFill>
-                  <a:srgbClr val="BE0000"/>
-                </a:solidFill>
-                <a:latin typeface="Cambria" pitchFamily="34" charset="0"/>
-                <a:ea typeface="Cambria" pitchFamily="34" charset="-122"/>
-                <a:cs typeface="Cambria" pitchFamily="34" charset="-120"/>
-              </a:rPr>
-              <a:t>The equation</a:t>
-            </a:r>
-            <a:endParaRPr lang="en-US" sz="1400" dirty="0"/>
-          </a:p>
-        </p:txBody>
-      </p:sp>
-      <p:sp>
-        <p:nvSpPr>
-          <p:cNvPr id="31" name="Text 29"/>
-          <p:cNvSpPr/>
-          <p:nvPr/>
-        </p:nvSpPr>
-        <p:spPr>
-          <a:xfrm>
-            <a:off x="7955280" y="2011680"/>
-            <a:ext cx="3520440" cy="457200"/>
-          </a:xfrm>
-          <a:prstGeom prst="rect">
-            <a:avLst/>
-          </a:prstGeom>
-          <a:noFill/>
-          <a:ln/>
-        </p:spPr>
-        <p:txBody>
-          <a:bodyPr wrap="square" lIns="0" tIns="0" rIns="0" bIns="0" rtlCol="0" anchor="ctr"/>
-          <a:lstStyle/>
-          <a:p>
-            <a:pPr algn="ctr" indent="0" marL="0">
-              <a:buNone/>
-            </a:pPr>
-            <a:r>
-              <a:rPr lang="en-US" sz="2200" b="1" dirty="0">
-                <a:solidFill>
-                  <a:srgbClr val="2A1618"/>
-                </a:solidFill>
-                <a:latin typeface="Cambria" pitchFamily="34" charset="0"/>
-                <a:ea typeface="Cambria" pitchFamily="34" charset="-122"/>
-                <a:cs typeface="Cambria" pitchFamily="34" charset="-120"/>
-              </a:rPr>
-              <a:t>y = W x + b</a:t>
-            </a:r>
-            <a:endParaRPr lang="en-US" sz="2200" dirty="0"/>
-          </a:p>
-        </p:txBody>
-      </p:sp>
-      <p:sp>
-        <p:nvSpPr>
-          <p:cNvPr id="32" name="Text 30"/>
-          <p:cNvSpPr/>
-          <p:nvPr/>
-        </p:nvSpPr>
-        <p:spPr>
-          <a:xfrm>
-            <a:off x="7955280" y="2514600"/>
-            <a:ext cx="3520440" cy="548640"/>
-          </a:xfrm>
-          <a:prstGeom prst="rect">
-            <a:avLst/>
-          </a:prstGeom>
-          <a:noFill/>
-          <a:ln/>
-        </p:spPr>
-        <p:txBody>
-          <a:bodyPr wrap="square" lIns="0" tIns="0" rIns="0" bIns="0" rtlCol="0" anchor="t"/>
-          <a:lstStyle/>
-          <a:p>
-            <a:pPr indent="0" marL="0">
-              <a:buNone/>
-            </a:pPr>
-            <a:r>
-              <a:rPr lang="en-US" sz="1000" dirty="0">
+              <a:rPr lang="en-US" sz="1200" i="1" dirty="0">
                 <a:solidFill>
                   <a:srgbClr val="836A68"/>
                 </a:solidFill>
@@ -3444,161 +2851,9 @@
                 <a:ea typeface="Calibri" pitchFamily="34" charset="-122"/>
                 <a:cs typeface="Calibri" pitchFamily="34" charset="-120"/>
               </a:rPr>
-              <a:t>x = sim [Re, Im of 16 S-params] (32-D); y = predicted measured; W (32x32) and b learned on the train frequencies.</a:t>
-            </a:r>
-            <a:endParaRPr lang="en-US" sz="1000" dirty="0"/>
-          </a:p>
-        </p:txBody>
-      </p:sp>
-      <p:sp>
-        <p:nvSpPr>
-          <p:cNvPr id="33" name="Shape 31"/>
-          <p:cNvSpPr/>
-          <p:nvPr/>
-        </p:nvSpPr>
-        <p:spPr>
-          <a:xfrm>
-            <a:off x="7772400" y="3291840"/>
-            <a:ext cx="3886200" cy="2971800"/>
-          </a:xfrm>
-          <a:prstGeom prst="roundRect">
-            <a:avLst>
-              <a:gd name="adj" fmla="val 2769"/>
-            </a:avLst>
-          </a:prstGeom>
-          <a:solidFill>
-            <a:srgbClr val="FBF4F2"/>
-          </a:solidFill>
-          <a:ln w="12700">
-            <a:solidFill>
-              <a:srgbClr val="E7D6D1"/>
-            </a:solidFill>
-            <a:prstDash val="solid"/>
-          </a:ln>
-          <a:effectLst>
-            <a:outerShdw sx="100000" sy="100000" kx="0" ky="0" algn="bl" rotWithShape="0" blurRad="88900" dist="38100" dir="5400000">
-              <a:srgbClr val="7A5C5E">
-                <a:alpha val="18000"/>
-              </a:srgbClr>
-            </a:outerShdw>
-          </a:effectLst>
-        </p:spPr>
-      </p:sp>
-      <p:sp>
-        <p:nvSpPr>
-          <p:cNvPr id="34" name="Text 32"/>
-          <p:cNvSpPr/>
-          <p:nvPr/>
-        </p:nvSpPr>
-        <p:spPr>
-          <a:xfrm>
-            <a:off x="7955280" y="3429000"/>
-            <a:ext cx="3566160" cy="365760"/>
-          </a:xfrm>
-          <a:prstGeom prst="rect">
-            <a:avLst/>
-          </a:prstGeom>
-          <a:noFill/>
-          <a:ln/>
-        </p:spPr>
-        <p:txBody>
-          <a:bodyPr wrap="square" lIns="0" tIns="0" rIns="0" bIns="0" rtlCol="0" anchor="ctr"/>
-          <a:lstStyle/>
-          <a:p>
-            <a:pPr indent="0" marL="0">
-              <a:buNone/>
-            </a:pPr>
-            <a:r>
-              <a:rPr lang="en-US" sz="1400" b="1" dirty="0">
-                <a:solidFill>
-                  <a:srgbClr val="BE0000"/>
-                </a:solidFill>
-                <a:latin typeface="Cambria" pitchFamily="34" charset="0"/>
-                <a:ea typeface="Cambria" pitchFamily="34" charset="-122"/>
-                <a:cs typeface="Cambria" pitchFamily="34" charset="-120"/>
-              </a:rPr>
-              <a:t>Why R2 = 0.65 is meaningful</a:t>
-            </a:r>
-            <a:endParaRPr lang="en-US" sz="1400" dirty="0"/>
-          </a:p>
-        </p:txBody>
-      </p:sp>
-      <p:sp>
-        <p:nvSpPr>
-          <p:cNvPr id="35" name="Text 33"/>
-          <p:cNvSpPr/>
-          <p:nvPr/>
-        </p:nvSpPr>
-        <p:spPr>
-          <a:xfrm>
-            <a:off x="7955280" y="3840480"/>
-            <a:ext cx="3566160" cy="2331720"/>
-          </a:xfrm>
-          <a:prstGeom prst="rect">
-            <a:avLst/>
-          </a:prstGeom>
-          <a:noFill/>
-          <a:ln/>
-        </p:spPr>
-        <p:txBody>
-          <a:bodyPr wrap="square" lIns="0" tIns="0" rIns="0" bIns="0" rtlCol="0" anchor="t"/>
-          <a:lstStyle/>
-          <a:p>
-            <a:pPr indent="0" marL="0">
-              <a:spcAft>
-                <a:spcPts val="900"/>
-              </a:spcAft>
-              <a:buNone/>
-            </a:pPr>
-            <a:r>
-              <a:rPr lang="en-US" sz="1100" dirty="0">
-                <a:solidFill>
-                  <a:srgbClr val="2A1618"/>
-                </a:solidFill>
-                <a:latin typeface="Calibri" pitchFamily="34" charset="0"/>
-                <a:ea typeface="Calibri" pitchFamily="34" charset="-122"/>
-                <a:cs typeface="Calibri" pitchFamily="34" charset="-120"/>
-              </a:rPr>
-              <a:t>R2 is computed only on frequencies the map never used while fitting, so it measures genuine generalization, not curve-fitting.</a:t>
-            </a:r>
-            <a:endParaRPr lang="en-US" sz="1100" dirty="0"/>
-          </a:p>
-          <a:p>
-            <a:pPr indent="0" marL="0">
-              <a:spcAft>
-                <a:spcPts val="900"/>
-              </a:spcAft>
-              <a:buNone/>
-            </a:pPr>
-            <a:r>
-              <a:rPr lang="en-US" sz="1100" dirty="0">
-                <a:solidFill>
-                  <a:srgbClr val="2A1618"/>
-                </a:solidFill>
-                <a:latin typeface="Calibri" pitchFamily="34" charset="0"/>
-                <a:ea typeface="Calibri" pitchFamily="34" charset="-122"/>
-                <a:cs typeface="Calibri" pitchFamily="34" charset="-120"/>
-              </a:rPr>
-              <a:t>A model that merely memorized the training frequencies would score near 0 on the held-out set. The flexible MLP did exactly that (R2 &lt; 0).</a:t>
-            </a:r>
-            <a:endParaRPr lang="en-US" sz="1100" dirty="0"/>
-          </a:p>
-          <a:p>
-            <a:pPr indent="0" marL="0">
-              <a:buNone/>
-            </a:pPr>
-            <a:r>
-              <a:rPr lang="en-US" sz="1100" dirty="0">
-                <a:solidFill>
-                  <a:srgbClr val="2A1618"/>
-                </a:solidFill>
-                <a:latin typeface="Calibri" pitchFamily="34" charset="0"/>
-                <a:ea typeface="Calibri" pitchFamily="34" charset="-122"/>
-                <a:cs typeface="Calibri" pitchFamily="34" charset="-120"/>
-              </a:rPr>
-              <a:t>So R2 = 0.65 says a fixed linear transform already recovers most of the measured signal from the sim, on data it has not seen.</a:t>
-            </a:r>
-            <a:endParaRPr lang="en-US" sz="1100" dirty="0"/>
+              <a:t>The antenna domain gap breaks direct transfer. The sim signal must be calibrated toward the bench first (next slides).</a:t>
+            </a:r>
+            <a:endParaRPr lang="en-US" sz="1200" dirty="0"/>
           </a:p>
         </p:txBody>
       </p:sp>
@@ -3667,7 +2922,7 @@
                 <a:ea typeface="Cambria" pitchFamily="34" charset="-122"/>
                 <a:cs typeface="Cambria" pitchFamily="34" charset="-120"/>
               </a:rPr>
-              <a:t>Can a model bridge the gap? (exploratory)</a:t>
+              <a:t>How the sim to measured map is learned</a:t>
             </a:r>
             <a:endParaRPr lang="en-US" sz="2900" dirty="0"/>
           </a:p>
@@ -3706,50 +2961,26 @@
                 <a:ea typeface="Calibri" pitchFamily="34" charset="-122"/>
                 <a:cs typeface="Calibri" pitchFamily="34" charset="-120"/>
               </a:rPr>
-              <a:t>The learned map applied to one port, and its accuracy on unseen frequencies</a:t>
+              <a:t>A linear transfer fit on the empty baseline and tested on frequencies it never saw</a:t>
             </a:r>
             <a:endParaRPr lang="en-US" sz="1400" dirty="0"/>
           </a:p>
         </p:txBody>
       </p:sp>
-      <p:pic>
-        <p:nvPicPr>
-          <p:cNvPr id="4" name="Image 0" descr="sim_meas_correlation.png">    </p:cNvPr>
-          <p:cNvPicPr>
-            <a:picLocks noChangeAspect="1"/>
-          </p:cNvPicPr>
-          <p:nvPr/>
-        </p:nvPicPr>
-        <p:blipFill>
-          <a:blip r:embed="rId1"/>
-          <a:stretch>
-            <a:fillRect/>
-          </a:stretch>
-        </p:blipFill>
-        <p:spPr>
-          <a:xfrm>
-            <a:off x="457200" y="1737360"/>
-            <a:ext cx="7772400" cy="3154680"/>
-          </a:xfrm>
-          <a:prstGeom prst="rect">
-            <a:avLst/>
-          </a:prstGeom>
-        </p:spPr>
-      </p:pic>
-      <p:sp>
-        <p:nvSpPr>
-          <p:cNvPr id="5" name="Shape 2"/>
-          <p:cNvSpPr/>
-          <p:nvPr/>
-        </p:nvSpPr>
-        <p:spPr>
-          <a:xfrm>
-            <a:off x="8412480" y="1645920"/>
-            <a:ext cx="3246120" cy="3794760"/>
+      <p:sp>
+        <p:nvSpPr>
+          <p:cNvPr id="4" name="Shape 2"/>
+          <p:cNvSpPr/>
+          <p:nvPr/>
+        </p:nvSpPr>
+        <p:spPr>
+          <a:xfrm>
+            <a:off x="548640" y="1554480"/>
+            <a:ext cx="7040880" cy="822960"/>
           </a:xfrm>
           <a:prstGeom prst="roundRect">
             <a:avLst>
-              <a:gd name="adj" fmla="val 2535"/>
+              <a:gd name="adj" fmla="val 10000"/>
             </a:avLst>
           </a:prstGeom>
           <a:solidFill>
@@ -3772,14 +3003,73 @@
       </p:sp>
       <p:sp>
         <p:nvSpPr>
-          <p:cNvPr id="6" name="Text 3"/>
-          <p:cNvSpPr/>
-          <p:nvPr/>
-        </p:nvSpPr>
-        <p:spPr>
-          <a:xfrm>
-            <a:off x="8595360" y="1783080"/>
-            <a:ext cx="2926080" cy="365760"/>
+          <p:cNvPr id="5" name="Shape 3"/>
+          <p:cNvSpPr/>
+          <p:nvPr/>
+        </p:nvSpPr>
+        <p:spPr>
+          <a:xfrm>
+            <a:off x="749808" y="1737360"/>
+            <a:ext cx="457200" cy="457200"/>
+          </a:xfrm>
+          <a:prstGeom prst="ellipse">
+            <a:avLst/>
+          </a:prstGeom>
+          <a:solidFill>
+            <a:srgbClr val="BE0000"/>
+          </a:solidFill>
+          <a:ln/>
+        </p:spPr>
+      </p:sp>
+      <p:sp>
+        <p:nvSpPr>
+          <p:cNvPr id="6" name="Text 4"/>
+          <p:cNvSpPr/>
+          <p:nvPr/>
+        </p:nvSpPr>
+        <p:spPr>
+          <a:xfrm>
+            <a:off x="749808" y="1737360"/>
+            <a:ext cx="457200" cy="457200"/>
+          </a:xfrm>
+          <a:prstGeom prst="rect">
+            <a:avLst/>
+          </a:prstGeom>
+          <a:noFill/>
+          <a:ln/>
+        </p:spPr>
+        <p:txBody>
+          <a:bodyPr wrap="square" lIns="0" tIns="0" rIns="0" bIns="0" rtlCol="0" anchor="ctr"/>
+          <a:lstStyle/>
+          <a:p>
+            <a:pPr algn="ctr" indent="0" marL="0">
+              <a:buNone/>
+            </a:pPr>
+            <a:r>
+              <a:rPr lang="en-US" sz="1800" b="1" dirty="0">
+                <a:solidFill>
+                  <a:srgbClr val="FFFFFF"/>
+                </a:solidFill>
+                <a:latin typeface="Cambria" pitchFamily="34" charset="0"/>
+                <a:ea typeface="Cambria" pitchFamily="34" charset="-122"/>
+                <a:cs typeface="Cambria" pitchFamily="34" charset="-120"/>
+              </a:rPr>
+              <a:t>1</a:t>
+            </a:r>
+            <a:endParaRPr lang="en-US" sz="1800" dirty="0"/>
+          </a:p>
+        </p:txBody>
+      </p:sp>
+      <p:sp>
+        <p:nvSpPr>
+          <p:cNvPr id="7" name="Text 5"/>
+          <p:cNvSpPr/>
+          <p:nvPr/>
+        </p:nvSpPr>
+        <p:spPr>
+          <a:xfrm>
+            <a:off x="1371600" y="1609344"/>
+            <a:ext cx="2286000" cy="713232"/>
           </a:xfrm>
           <a:prstGeom prst="rect">
             <a:avLst/>
@@ -3795,7 +3085,7 @@
               <a:buNone/>
             </a:pPr>
             <a:r>
-              <a:rPr lang="en-US" sz="1500" b="1" dirty="0">
+              <a:rPr lang="en-US" sz="1400" b="1" dirty="0">
                 <a:solidFill>
                   <a:srgbClr val="BE0000"/>
                 </a:solidFill>
@@ -3803,22 +3093,22 @@
                 <a:ea typeface="Cambria" pitchFamily="34" charset="-122"/>
                 <a:cs typeface="Cambria" pitchFamily="34" charset="-120"/>
               </a:rPr>
-              <a:t>How to read it</a:t>
-            </a:r>
-            <a:endParaRPr lang="en-US" sz="1500" dirty="0"/>
-          </a:p>
-        </p:txBody>
-      </p:sp>
-      <p:sp>
-        <p:nvSpPr>
-          <p:cNvPr id="7" name="Text 4"/>
-          <p:cNvSpPr/>
-          <p:nvPr/>
-        </p:nvSpPr>
-        <p:spPr>
-          <a:xfrm>
-            <a:off x="8595360" y="2194560"/>
-            <a:ext cx="2971800" cy="3108960"/>
+              <a:t>Pair the empty baselines</a:t>
+            </a:r>
+            <a:endParaRPr lang="en-US" sz="1400" dirty="0"/>
+          </a:p>
+        </p:txBody>
+      </p:sp>
+      <p:sp>
+        <p:nvSpPr>
+          <p:cNvPr id="8" name="Text 6"/>
+          <p:cNvSpPr/>
+          <p:nvPr/>
+        </p:nvSpPr>
+        <p:spPr>
+          <a:xfrm>
+            <a:off x="3703320" y="1591056"/>
+            <a:ext cx="3794760" cy="749808"/>
           </a:xfrm>
           <a:prstGeom prst="rect">
             <a:avLst/>
@@ -3827,18 +3117,14 @@
           <a:ln/>
         </p:spPr>
         <p:txBody>
-          <a:bodyPr wrap="square" lIns="0" tIns="0" rIns="0" bIns="0" rtlCol="0" anchor="t"/>
-          <a:lstStyle/>
-          <a:p>
-            <a:pPr marL="342900" indent="-342900">
-              <a:spcAft>
-                <a:spcPts val="800"/>
-              </a:spcAft>
-              <a:buSzPct val="100000"/>
-              <a:buChar char="•"/>
+          <a:bodyPr wrap="square" lIns="0" tIns="0" rIns="0" bIns="0" rtlCol="0" anchor="ctr"/>
+          <a:lstStyle/>
+          <a:p>
+            <a:pPr indent="0" marL="0">
+              <a:buNone/>
             </a:pPr>
             <a:r>
-              <a:rPr lang="en-US" sz="1050" dirty="0">
+              <a:rPr lang="en-US" sz="1070" dirty="0">
                 <a:solidFill>
                   <a:srgbClr val="2A1618"/>
                 </a:solidFill>
@@ -3846,20 +3132,170 @@
                 <a:ea typeface="Calibri" pitchFamily="34" charset="-122"/>
                 <a:cs typeface="Calibri" pitchFamily="34" charset="-120"/>
               </a:rPr>
-              <a:t>Left: the dashed line is the simulated S11 after the map (W x_sim + b). A perfect map would land on the measured (red) curve; it moves toward it but does not fully match.</a:t>
-            </a:r>
-            <a:endParaRPr lang="en-US" sz="1050" dirty="0"/>
-          </a:p>
-          <a:p>
-            <a:pPr marL="342900" indent="-342900">
-              <a:spcAft>
-                <a:spcPts val="800"/>
-              </a:spcAft>
-              <a:buSzPct val="100000"/>
-              <a:buChar char="•"/>
+              <a:t>Sim empty phantom and measured empty phantom are the same physical state (no tumor), so their S-parameters can be matched frequency by frequency.</a:t>
+            </a:r>
+            <a:endParaRPr lang="en-US" sz="1070" dirty="0"/>
+          </a:p>
+        </p:txBody>
+      </p:sp>
+      <p:sp>
+        <p:nvSpPr>
+          <p:cNvPr id="9" name="Shape 7"/>
+          <p:cNvSpPr/>
+          <p:nvPr/>
+        </p:nvSpPr>
+        <p:spPr>
+          <a:xfrm>
+            <a:off x="548640" y="2487168"/>
+            <a:ext cx="7040880" cy="822960"/>
+          </a:xfrm>
+          <a:prstGeom prst="roundRect">
+            <a:avLst>
+              <a:gd name="adj" fmla="val 10000"/>
+            </a:avLst>
+          </a:prstGeom>
+          <a:solidFill>
+            <a:srgbClr val="FBF4F2"/>
+          </a:solidFill>
+          <a:ln w="12700">
+            <a:solidFill>
+              <a:srgbClr val="E7D6D1"/>
+            </a:solidFill>
+            <a:prstDash val="solid"/>
+          </a:ln>
+          <a:effectLst>
+            <a:outerShdw sx="100000" sy="100000" kx="0" ky="0" algn="bl" rotWithShape="0" blurRad="88900" dist="38100" dir="5400000">
+              <a:srgbClr val="7A5C5E">
+                <a:alpha val="18000"/>
+              </a:srgbClr>
+            </a:outerShdw>
+          </a:effectLst>
+        </p:spPr>
+      </p:sp>
+      <p:sp>
+        <p:nvSpPr>
+          <p:cNvPr id="10" name="Shape 8"/>
+          <p:cNvSpPr/>
+          <p:nvPr/>
+        </p:nvSpPr>
+        <p:spPr>
+          <a:xfrm>
+            <a:off x="749808" y="2670048"/>
+            <a:ext cx="457200" cy="457200"/>
+          </a:xfrm>
+          <a:prstGeom prst="ellipse">
+            <a:avLst/>
+          </a:prstGeom>
+          <a:solidFill>
+            <a:srgbClr val="BE0000"/>
+          </a:solidFill>
+          <a:ln/>
+        </p:spPr>
+      </p:sp>
+      <p:sp>
+        <p:nvSpPr>
+          <p:cNvPr id="11" name="Text 9"/>
+          <p:cNvSpPr/>
+          <p:nvPr/>
+        </p:nvSpPr>
+        <p:spPr>
+          <a:xfrm>
+            <a:off x="749808" y="2670048"/>
+            <a:ext cx="457200" cy="457200"/>
+          </a:xfrm>
+          <a:prstGeom prst="rect">
+            <a:avLst/>
+          </a:prstGeom>
+          <a:noFill/>
+          <a:ln/>
+        </p:spPr>
+        <p:txBody>
+          <a:bodyPr wrap="square" lIns="0" tIns="0" rIns="0" bIns="0" rtlCol="0" anchor="ctr"/>
+          <a:lstStyle/>
+          <a:p>
+            <a:pPr algn="ctr" indent="0" marL="0">
+              <a:buNone/>
             </a:pPr>
             <a:r>
-              <a:rPr lang="en-US" sz="1050" dirty="0">
+              <a:rPr lang="en-US" sz="1800" b="1" dirty="0">
+                <a:solidFill>
+                  <a:srgbClr val="FFFFFF"/>
+                </a:solidFill>
+                <a:latin typeface="Cambria" pitchFamily="34" charset="0"/>
+                <a:ea typeface="Cambria" pitchFamily="34" charset="-122"/>
+                <a:cs typeface="Cambria" pitchFamily="34" charset="-120"/>
+              </a:rPr>
+              <a:t>2</a:t>
+            </a:r>
+            <a:endParaRPr lang="en-US" sz="1800" dirty="0"/>
+          </a:p>
+        </p:txBody>
+      </p:sp>
+      <p:sp>
+        <p:nvSpPr>
+          <p:cNvPr id="12" name="Text 10"/>
+          <p:cNvSpPr/>
+          <p:nvPr/>
+        </p:nvSpPr>
+        <p:spPr>
+          <a:xfrm>
+            <a:off x="1371600" y="2542032"/>
+            <a:ext cx="2286000" cy="713232"/>
+          </a:xfrm>
+          <a:prstGeom prst="rect">
+            <a:avLst/>
+          </a:prstGeom>
+          <a:noFill/>
+          <a:ln/>
+        </p:spPr>
+        <p:txBody>
+          <a:bodyPr wrap="square" lIns="0" tIns="0" rIns="0" bIns="0" rtlCol="0" anchor="ctr"/>
+          <a:lstStyle/>
+          <a:p>
+            <a:pPr indent="0" marL="0">
+              <a:buNone/>
+            </a:pPr>
+            <a:r>
+              <a:rPr lang="en-US" sz="1400" b="1" dirty="0">
+                <a:solidFill>
+                  <a:srgbClr val="BE0000"/>
+                </a:solidFill>
+                <a:latin typeface="Cambria" pitchFamily="34" charset="0"/>
+                <a:ea typeface="Cambria" pitchFamily="34" charset="-122"/>
+                <a:cs typeface="Cambria" pitchFamily="34" charset="-120"/>
+              </a:rPr>
+              <a:t>One vector per frequency</a:t>
+            </a:r>
+            <a:endParaRPr lang="en-US" sz="1400" dirty="0"/>
+          </a:p>
+        </p:txBody>
+      </p:sp>
+      <p:sp>
+        <p:nvSpPr>
+          <p:cNvPr id="13" name="Text 11"/>
+          <p:cNvSpPr/>
+          <p:nvPr/>
+        </p:nvSpPr>
+        <p:spPr>
+          <a:xfrm>
+            <a:off x="3703320" y="2523744"/>
+            <a:ext cx="3794760" cy="749808"/>
+          </a:xfrm>
+          <a:prstGeom prst="rect">
+            <a:avLst/>
+          </a:prstGeom>
+          <a:noFill/>
+          <a:ln/>
+        </p:spPr>
+        <p:txBody>
+          <a:bodyPr wrap="square" lIns="0" tIns="0" rIns="0" bIns="0" rtlCol="0" anchor="ctr"/>
+          <a:lstStyle/>
+          <a:p>
+            <a:pPr indent="0" marL="0">
+              <a:buNone/>
+            </a:pPr>
+            <a:r>
+              <a:rPr lang="en-US" sz="1070" dirty="0">
                 <a:solidFill>
                   <a:srgbClr val="2A1618"/>
                 </a:solidFill>
@@ -3867,20 +3303,170 @@
                 <a:ea typeface="Calibri" pitchFamily="34" charset="-122"/>
                 <a:cs typeface="Calibri" pitchFamily="34" charset="-120"/>
               </a:rPr>
-              <a:t>Right: predicted vs measured on the held-out frequencies. Points on the diagonal are exact; the R2 = 0.65 spread shows the map captures most, not all, of the relationship.</a:t>
-            </a:r>
-            <a:endParaRPr lang="en-US" sz="1050" dirty="0"/>
-          </a:p>
-          <a:p>
-            <a:pPr marL="342900" indent="-342900">
-              <a:spcAft>
-                <a:spcPts val="800"/>
-              </a:spcAft>
-              <a:buSzPct val="100000"/>
-              <a:buChar char="•"/>
+              <a:t>At each of 512 frequencies (2 to 8 GHz), stack the real and imaginary parts of the 16 S-parameters into a 32-D vector. Sim = input x, measured = target y.</a:t>
+            </a:r>
+            <a:endParaRPr lang="en-US" sz="1070" dirty="0"/>
+          </a:p>
+        </p:txBody>
+      </p:sp>
+      <p:sp>
+        <p:nvSpPr>
+          <p:cNvPr id="14" name="Shape 12"/>
+          <p:cNvSpPr/>
+          <p:nvPr/>
+        </p:nvSpPr>
+        <p:spPr>
+          <a:xfrm>
+            <a:off x="548640" y="3419856"/>
+            <a:ext cx="7040880" cy="822960"/>
+          </a:xfrm>
+          <a:prstGeom prst="roundRect">
+            <a:avLst>
+              <a:gd name="adj" fmla="val 10000"/>
+            </a:avLst>
+          </a:prstGeom>
+          <a:solidFill>
+            <a:srgbClr val="FBF4F2"/>
+          </a:solidFill>
+          <a:ln w="12700">
+            <a:solidFill>
+              <a:srgbClr val="E7D6D1"/>
+            </a:solidFill>
+            <a:prstDash val="solid"/>
+          </a:ln>
+          <a:effectLst>
+            <a:outerShdw sx="100000" sy="100000" kx="0" ky="0" algn="bl" rotWithShape="0" blurRad="88900" dist="38100" dir="5400000">
+              <a:srgbClr val="7A5C5E">
+                <a:alpha val="18000"/>
+              </a:srgbClr>
+            </a:outerShdw>
+          </a:effectLst>
+        </p:spPr>
+      </p:sp>
+      <p:sp>
+        <p:nvSpPr>
+          <p:cNvPr id="15" name="Shape 13"/>
+          <p:cNvSpPr/>
+          <p:nvPr/>
+        </p:nvSpPr>
+        <p:spPr>
+          <a:xfrm>
+            <a:off x="749808" y="3602736"/>
+            <a:ext cx="457200" cy="457200"/>
+          </a:xfrm>
+          <a:prstGeom prst="ellipse">
+            <a:avLst/>
+          </a:prstGeom>
+          <a:solidFill>
+            <a:srgbClr val="BE0000"/>
+          </a:solidFill>
+          <a:ln/>
+        </p:spPr>
+      </p:sp>
+      <p:sp>
+        <p:nvSpPr>
+          <p:cNvPr id="16" name="Text 14"/>
+          <p:cNvSpPr/>
+          <p:nvPr/>
+        </p:nvSpPr>
+        <p:spPr>
+          <a:xfrm>
+            <a:off x="749808" y="3602736"/>
+            <a:ext cx="457200" cy="457200"/>
+          </a:xfrm>
+          <a:prstGeom prst="rect">
+            <a:avLst/>
+          </a:prstGeom>
+          <a:noFill/>
+          <a:ln/>
+        </p:spPr>
+        <p:txBody>
+          <a:bodyPr wrap="square" lIns="0" tIns="0" rIns="0" bIns="0" rtlCol="0" anchor="ctr"/>
+          <a:lstStyle/>
+          <a:p>
+            <a:pPr algn="ctr" indent="0" marL="0">
+              <a:buNone/>
             </a:pPr>
             <a:r>
-              <a:rPr lang="en-US" sz="1050" dirty="0">
+              <a:rPr lang="en-US" sz="1800" b="1" dirty="0">
+                <a:solidFill>
+                  <a:srgbClr val="FFFFFF"/>
+                </a:solidFill>
+                <a:latin typeface="Cambria" pitchFamily="34" charset="0"/>
+                <a:ea typeface="Cambria" pitchFamily="34" charset="-122"/>
+                <a:cs typeface="Cambria" pitchFamily="34" charset="-120"/>
+              </a:rPr>
+              <a:t>3</a:t>
+            </a:r>
+            <a:endParaRPr lang="en-US" sz="1800" dirty="0"/>
+          </a:p>
+        </p:txBody>
+      </p:sp>
+      <p:sp>
+        <p:nvSpPr>
+          <p:cNvPr id="17" name="Text 15"/>
+          <p:cNvSpPr/>
+          <p:nvPr/>
+        </p:nvSpPr>
+        <p:spPr>
+          <a:xfrm>
+            <a:off x="1371600" y="3474720"/>
+            <a:ext cx="2286000" cy="713232"/>
+          </a:xfrm>
+          <a:prstGeom prst="rect">
+            <a:avLst/>
+          </a:prstGeom>
+          <a:noFill/>
+          <a:ln/>
+        </p:spPr>
+        <p:txBody>
+          <a:bodyPr wrap="square" lIns="0" tIns="0" rIns="0" bIns="0" rtlCol="0" anchor="ctr"/>
+          <a:lstStyle/>
+          <a:p>
+            <a:pPr indent="0" marL="0">
+              <a:buNone/>
+            </a:pPr>
+            <a:r>
+              <a:rPr lang="en-US" sz="1400" b="1" dirty="0">
+                <a:solidFill>
+                  <a:srgbClr val="BE0000"/>
+                </a:solidFill>
+                <a:latin typeface="Cambria" pitchFamily="34" charset="0"/>
+                <a:ea typeface="Cambria" pitchFamily="34" charset="-122"/>
+                <a:cs typeface="Cambria" pitchFamily="34" charset="-120"/>
+              </a:rPr>
+              <a:t>Split the frequencies 70 / 30</a:t>
+            </a:r>
+            <a:endParaRPr lang="en-US" sz="1400" dirty="0"/>
+          </a:p>
+        </p:txBody>
+      </p:sp>
+      <p:sp>
+        <p:nvSpPr>
+          <p:cNvPr id="18" name="Text 16"/>
+          <p:cNvSpPr/>
+          <p:nvPr/>
+        </p:nvSpPr>
+        <p:spPr>
+          <a:xfrm>
+            <a:off x="3703320" y="3456432"/>
+            <a:ext cx="3794760" cy="749808"/>
+          </a:xfrm>
+          <a:prstGeom prst="rect">
+            <a:avLst/>
+          </a:prstGeom>
+          <a:noFill/>
+          <a:ln/>
+        </p:spPr>
+        <p:txBody>
+          <a:bodyPr wrap="square" lIns="0" tIns="0" rIns="0" bIns="0" rtlCol="0" anchor="ctr"/>
+          <a:lstStyle/>
+          <a:p>
+            <a:pPr indent="0" marL="0">
+              <a:buNone/>
+            </a:pPr>
+            <a:r>
+              <a:rPr lang="en-US" sz="1070" dirty="0">
                 <a:solidFill>
                   <a:srgbClr val="2A1618"/>
                 </a:solidFill>
@@ -3888,22 +3474,76 @@
                 <a:ea typeface="Calibri" pitchFamily="34" charset="-122"/>
                 <a:cs typeface="Calibri" pitchFamily="34" charset="-120"/>
               </a:rPr>
-              <a:t>A flexible MLP overfits and fails to generalize (R2 &lt; 0).</a:t>
-            </a:r>
-            <a:endParaRPr lang="en-US" sz="1050" dirty="0"/>
-          </a:p>
-        </p:txBody>
-      </p:sp>
-      <p:sp>
-        <p:nvSpPr>
-          <p:cNvPr id="8" name="Text 5"/>
-          <p:cNvSpPr/>
-          <p:nvPr/>
-        </p:nvSpPr>
-        <p:spPr>
-          <a:xfrm>
-            <a:off x="548640" y="6035040"/>
-            <a:ext cx="11091672" cy="548640"/>
+              <a:t>Fit on 70% of the frequencies; hold out the other 30% for testing. The map never sees the test frequencies while it is being fit.</a:t>
+            </a:r>
+            <a:endParaRPr lang="en-US" sz="1070" dirty="0"/>
+          </a:p>
+        </p:txBody>
+      </p:sp>
+      <p:sp>
+        <p:nvSpPr>
+          <p:cNvPr id="19" name="Shape 17"/>
+          <p:cNvSpPr/>
+          <p:nvPr/>
+        </p:nvSpPr>
+        <p:spPr>
+          <a:xfrm>
+            <a:off x="548640" y="4352544"/>
+            <a:ext cx="7040880" cy="822960"/>
+          </a:xfrm>
+          <a:prstGeom prst="roundRect">
+            <a:avLst>
+              <a:gd name="adj" fmla="val 10000"/>
+            </a:avLst>
+          </a:prstGeom>
+          <a:solidFill>
+            <a:srgbClr val="FBF4F2"/>
+          </a:solidFill>
+          <a:ln w="12700">
+            <a:solidFill>
+              <a:srgbClr val="E7D6D1"/>
+            </a:solidFill>
+            <a:prstDash val="solid"/>
+          </a:ln>
+          <a:effectLst>
+            <a:outerShdw sx="100000" sy="100000" kx="0" ky="0" algn="bl" rotWithShape="0" blurRad="88900" dist="38100" dir="5400000">
+              <a:srgbClr val="7A5C5E">
+                <a:alpha val="18000"/>
+              </a:srgbClr>
+            </a:outerShdw>
+          </a:effectLst>
+        </p:spPr>
+      </p:sp>
+      <p:sp>
+        <p:nvSpPr>
+          <p:cNvPr id="20" name="Shape 18"/>
+          <p:cNvSpPr/>
+          <p:nvPr/>
+        </p:nvSpPr>
+        <p:spPr>
+          <a:xfrm>
+            <a:off x="749808" y="4535424"/>
+            <a:ext cx="457200" cy="457200"/>
+          </a:xfrm>
+          <a:prstGeom prst="ellipse">
+            <a:avLst/>
+          </a:prstGeom>
+          <a:solidFill>
+            <a:srgbClr val="BE0000"/>
+          </a:solidFill>
+          <a:ln/>
+        </p:spPr>
+      </p:sp>
+      <p:sp>
+        <p:nvSpPr>
+          <p:cNvPr id="21" name="Text 19"/>
+          <p:cNvSpPr/>
+          <p:nvPr/>
+        </p:nvSpPr>
+        <p:spPr>
+          <a:xfrm>
+            <a:off x="749808" y="4535424"/>
+            <a:ext cx="457200" cy="457200"/>
           </a:xfrm>
           <a:prstGeom prst="rect">
             <a:avLst/>
@@ -3919,7 +3559,407 @@
               <a:buNone/>
             </a:pPr>
             <a:r>
-              <a:rPr lang="en-US" sz="1250" i="1" dirty="0">
+              <a:rPr lang="en-US" sz="1800" b="1" dirty="0">
+                <a:solidFill>
+                  <a:srgbClr val="FFFFFF"/>
+                </a:solidFill>
+                <a:latin typeface="Cambria" pitchFamily="34" charset="0"/>
+                <a:ea typeface="Cambria" pitchFamily="34" charset="-122"/>
+                <a:cs typeface="Cambria" pitchFamily="34" charset="-120"/>
+              </a:rPr>
+              <a:t>4</a:t>
+            </a:r>
+            <a:endParaRPr lang="en-US" sz="1800" dirty="0"/>
+          </a:p>
+        </p:txBody>
+      </p:sp>
+      <p:sp>
+        <p:nvSpPr>
+          <p:cNvPr id="22" name="Text 20"/>
+          <p:cNvSpPr/>
+          <p:nvPr/>
+        </p:nvSpPr>
+        <p:spPr>
+          <a:xfrm>
+            <a:off x="1371600" y="4407408"/>
+            <a:ext cx="2286000" cy="713232"/>
+          </a:xfrm>
+          <a:prstGeom prst="rect">
+            <a:avLst/>
+          </a:prstGeom>
+          <a:noFill/>
+          <a:ln/>
+        </p:spPr>
+        <p:txBody>
+          <a:bodyPr wrap="square" lIns="0" tIns="0" rIns="0" bIns="0" rtlCol="0" anchor="ctr"/>
+          <a:lstStyle/>
+          <a:p>
+            <a:pPr indent="0" marL="0">
+              <a:buNone/>
+            </a:pPr>
+            <a:r>
+              <a:rPr lang="en-US" sz="1400" b="1" dirty="0">
+                <a:solidFill>
+                  <a:srgbClr val="BE0000"/>
+                </a:solidFill>
+                <a:latin typeface="Cambria" pitchFamily="34" charset="0"/>
+                <a:ea typeface="Cambria" pitchFamily="34" charset="-122"/>
+                <a:cs typeface="Cambria" pitchFamily="34" charset="-120"/>
+              </a:rPr>
+              <a:t>Fit the linear map</a:t>
+            </a:r>
+            <a:endParaRPr lang="en-US" sz="1400" dirty="0"/>
+          </a:p>
+        </p:txBody>
+      </p:sp>
+      <p:sp>
+        <p:nvSpPr>
+          <p:cNvPr id="23" name="Text 21"/>
+          <p:cNvSpPr/>
+          <p:nvPr/>
+        </p:nvSpPr>
+        <p:spPr>
+          <a:xfrm>
+            <a:off x="3703320" y="4389120"/>
+            <a:ext cx="3794760" cy="749808"/>
+          </a:xfrm>
+          <a:prstGeom prst="rect">
+            <a:avLst/>
+          </a:prstGeom>
+          <a:noFill/>
+          <a:ln/>
+        </p:spPr>
+        <p:txBody>
+          <a:bodyPr wrap="square" lIns="0" tIns="0" rIns="0" bIns="0" rtlCol="0" anchor="ctr"/>
+          <a:lstStyle/>
+          <a:p>
+            <a:pPr indent="0" marL="0">
+              <a:buNone/>
+            </a:pPr>
+            <a:r>
+              <a:rPr lang="en-US" sz="1070" dirty="0">
+                <a:solidFill>
+                  <a:srgbClr val="2A1618"/>
+                </a:solidFill>
+                <a:latin typeface="Calibri" pitchFamily="34" charset="0"/>
+                <a:ea typeface="Calibri" pitchFamily="34" charset="-122"/>
+                <a:cs typeface="Calibri" pitchFamily="34" charset="-120"/>
+              </a:rPr>
+              <a:t>Ridge (L2) regression learns a 32x32 matrix W and offset b that best convert the sim vector into the measured vector.</a:t>
+            </a:r>
+            <a:endParaRPr lang="en-US" sz="1070" dirty="0"/>
+          </a:p>
+        </p:txBody>
+      </p:sp>
+      <p:sp>
+        <p:nvSpPr>
+          <p:cNvPr id="24" name="Shape 22"/>
+          <p:cNvSpPr/>
+          <p:nvPr/>
+        </p:nvSpPr>
+        <p:spPr>
+          <a:xfrm>
+            <a:off x="548640" y="5285232"/>
+            <a:ext cx="7040880" cy="822960"/>
+          </a:xfrm>
+          <a:prstGeom prst="roundRect">
+            <a:avLst>
+              <a:gd name="adj" fmla="val 10000"/>
+            </a:avLst>
+          </a:prstGeom>
+          <a:solidFill>
+            <a:srgbClr val="FBF4F2"/>
+          </a:solidFill>
+          <a:ln w="12700">
+            <a:solidFill>
+              <a:srgbClr val="E7D6D1"/>
+            </a:solidFill>
+            <a:prstDash val="solid"/>
+          </a:ln>
+          <a:effectLst>
+            <a:outerShdw sx="100000" sy="100000" kx="0" ky="0" algn="bl" rotWithShape="0" blurRad="88900" dist="38100" dir="5400000">
+              <a:srgbClr val="7A5C5E">
+                <a:alpha val="18000"/>
+              </a:srgbClr>
+            </a:outerShdw>
+          </a:effectLst>
+        </p:spPr>
+      </p:sp>
+      <p:sp>
+        <p:nvSpPr>
+          <p:cNvPr id="25" name="Shape 23"/>
+          <p:cNvSpPr/>
+          <p:nvPr/>
+        </p:nvSpPr>
+        <p:spPr>
+          <a:xfrm>
+            <a:off x="749808" y="5468112"/>
+            <a:ext cx="457200" cy="457200"/>
+          </a:xfrm>
+          <a:prstGeom prst="ellipse">
+            <a:avLst/>
+          </a:prstGeom>
+          <a:solidFill>
+            <a:srgbClr val="BE0000"/>
+          </a:solidFill>
+          <a:ln/>
+        </p:spPr>
+      </p:sp>
+      <p:sp>
+        <p:nvSpPr>
+          <p:cNvPr id="26" name="Text 24"/>
+          <p:cNvSpPr/>
+          <p:nvPr/>
+        </p:nvSpPr>
+        <p:spPr>
+          <a:xfrm>
+            <a:off x="749808" y="5468112"/>
+            <a:ext cx="457200" cy="457200"/>
+          </a:xfrm>
+          <a:prstGeom prst="rect">
+            <a:avLst/>
+          </a:prstGeom>
+          <a:noFill/>
+          <a:ln/>
+        </p:spPr>
+        <p:txBody>
+          <a:bodyPr wrap="square" lIns="0" tIns="0" rIns="0" bIns="0" rtlCol="0" anchor="ctr"/>
+          <a:lstStyle/>
+          <a:p>
+            <a:pPr algn="ctr" indent="0" marL="0">
+              <a:buNone/>
+            </a:pPr>
+            <a:r>
+              <a:rPr lang="en-US" sz="1800" b="1" dirty="0">
+                <a:solidFill>
+                  <a:srgbClr val="FFFFFF"/>
+                </a:solidFill>
+                <a:latin typeface="Cambria" pitchFamily="34" charset="0"/>
+                <a:ea typeface="Cambria" pitchFamily="34" charset="-122"/>
+                <a:cs typeface="Cambria" pitchFamily="34" charset="-120"/>
+              </a:rPr>
+              <a:t>5</a:t>
+            </a:r>
+            <a:endParaRPr lang="en-US" sz="1800" dirty="0"/>
+          </a:p>
+        </p:txBody>
+      </p:sp>
+      <p:sp>
+        <p:nvSpPr>
+          <p:cNvPr id="27" name="Text 25"/>
+          <p:cNvSpPr/>
+          <p:nvPr/>
+        </p:nvSpPr>
+        <p:spPr>
+          <a:xfrm>
+            <a:off x="1371600" y="5340096"/>
+            <a:ext cx="2286000" cy="713232"/>
+          </a:xfrm>
+          <a:prstGeom prst="rect">
+            <a:avLst/>
+          </a:prstGeom>
+          <a:noFill/>
+          <a:ln/>
+        </p:spPr>
+        <p:txBody>
+          <a:bodyPr wrap="square" lIns="0" tIns="0" rIns="0" bIns="0" rtlCol="0" anchor="ctr"/>
+          <a:lstStyle/>
+          <a:p>
+            <a:pPr indent="0" marL="0">
+              <a:buNone/>
+            </a:pPr>
+            <a:r>
+              <a:rPr lang="en-US" sz="1400" b="1" dirty="0">
+                <a:solidFill>
+                  <a:srgbClr val="BE0000"/>
+                </a:solidFill>
+                <a:latin typeface="Cambria" pitchFamily="34" charset="0"/>
+                <a:ea typeface="Cambria" pitchFamily="34" charset="-122"/>
+                <a:cs typeface="Cambria" pitchFamily="34" charset="-120"/>
+              </a:rPr>
+              <a:t>Test on the held-out 30%</a:t>
+            </a:r>
+            <a:endParaRPr lang="en-US" sz="1400" dirty="0"/>
+          </a:p>
+        </p:txBody>
+      </p:sp>
+      <p:sp>
+        <p:nvSpPr>
+          <p:cNvPr id="28" name="Text 26"/>
+          <p:cNvSpPr/>
+          <p:nvPr/>
+        </p:nvSpPr>
+        <p:spPr>
+          <a:xfrm>
+            <a:off x="3703320" y="5321808"/>
+            <a:ext cx="3794760" cy="749808"/>
+          </a:xfrm>
+          <a:prstGeom prst="rect">
+            <a:avLst/>
+          </a:prstGeom>
+          <a:noFill/>
+          <a:ln/>
+        </p:spPr>
+        <p:txBody>
+          <a:bodyPr wrap="square" lIns="0" tIns="0" rIns="0" bIns="0" rtlCol="0" anchor="ctr"/>
+          <a:lstStyle/>
+          <a:p>
+            <a:pPr indent="0" marL="0">
+              <a:buNone/>
+            </a:pPr>
+            <a:r>
+              <a:rPr lang="en-US" sz="1070" dirty="0">
+                <a:solidFill>
+                  <a:srgbClr val="2A1618"/>
+                </a:solidFill>
+                <a:latin typeface="Calibri" pitchFamily="34" charset="0"/>
+                <a:ea typeface="Calibri" pitchFamily="34" charset="-122"/>
+                <a:cs typeface="Calibri" pitchFamily="34" charset="-120"/>
+              </a:rPr>
+              <a:t>Apply W and b to the unseen frequencies and compare to the true measured values, giving R2 = 0.65.</a:t>
+            </a:r>
+            <a:endParaRPr lang="en-US" sz="1070" dirty="0"/>
+          </a:p>
+        </p:txBody>
+      </p:sp>
+      <p:sp>
+        <p:nvSpPr>
+          <p:cNvPr id="29" name="Shape 27"/>
+          <p:cNvSpPr/>
+          <p:nvPr/>
+        </p:nvSpPr>
+        <p:spPr>
+          <a:xfrm>
+            <a:off x="7772400" y="1554480"/>
+            <a:ext cx="3886200" cy="1600200"/>
+          </a:xfrm>
+          <a:prstGeom prst="roundRect">
+            <a:avLst>
+              <a:gd name="adj" fmla="val 5143"/>
+            </a:avLst>
+          </a:prstGeom>
+          <a:solidFill>
+            <a:srgbClr val="FBF4F2"/>
+          </a:solidFill>
+          <a:ln w="12700">
+            <a:solidFill>
+              <a:srgbClr val="E7D6D1"/>
+            </a:solidFill>
+            <a:prstDash val="solid"/>
+          </a:ln>
+          <a:effectLst>
+            <a:outerShdw sx="100000" sy="100000" kx="0" ky="0" algn="bl" rotWithShape="0" blurRad="88900" dist="38100" dir="5400000">
+              <a:srgbClr val="7A5C5E">
+                <a:alpha val="18000"/>
+              </a:srgbClr>
+            </a:outerShdw>
+          </a:effectLst>
+        </p:spPr>
+      </p:sp>
+      <p:sp>
+        <p:nvSpPr>
+          <p:cNvPr id="30" name="Text 28"/>
+          <p:cNvSpPr/>
+          <p:nvPr/>
+        </p:nvSpPr>
+        <p:spPr>
+          <a:xfrm>
+            <a:off x="7955280" y="1691640"/>
+            <a:ext cx="3474720" cy="320040"/>
+          </a:xfrm>
+          <a:prstGeom prst="rect">
+            <a:avLst/>
+          </a:prstGeom>
+          <a:noFill/>
+          <a:ln/>
+        </p:spPr>
+        <p:txBody>
+          <a:bodyPr wrap="square" lIns="0" tIns="0" rIns="0" bIns="0" rtlCol="0" anchor="ctr"/>
+          <a:lstStyle/>
+          <a:p>
+            <a:pPr indent="0" marL="0">
+              <a:buNone/>
+            </a:pPr>
+            <a:r>
+              <a:rPr lang="en-US" sz="1400" b="1" dirty="0">
+                <a:solidFill>
+                  <a:srgbClr val="BE0000"/>
+                </a:solidFill>
+                <a:latin typeface="Cambria" pitchFamily="34" charset="0"/>
+                <a:ea typeface="Cambria" pitchFamily="34" charset="-122"/>
+                <a:cs typeface="Cambria" pitchFamily="34" charset="-120"/>
+              </a:rPr>
+              <a:t>The equation</a:t>
+            </a:r>
+            <a:endParaRPr lang="en-US" sz="1400" dirty="0"/>
+          </a:p>
+        </p:txBody>
+      </p:sp>
+      <p:sp>
+        <p:nvSpPr>
+          <p:cNvPr id="31" name="Text 29"/>
+          <p:cNvSpPr/>
+          <p:nvPr/>
+        </p:nvSpPr>
+        <p:spPr>
+          <a:xfrm>
+            <a:off x="7955280" y="2011680"/>
+            <a:ext cx="3520440" cy="457200"/>
+          </a:xfrm>
+          <a:prstGeom prst="rect">
+            <a:avLst/>
+          </a:prstGeom>
+          <a:noFill/>
+          <a:ln/>
+        </p:spPr>
+        <p:txBody>
+          <a:bodyPr wrap="square" lIns="0" tIns="0" rIns="0" bIns="0" rtlCol="0" anchor="ctr"/>
+          <a:lstStyle/>
+          <a:p>
+            <a:pPr algn="ctr" indent="0" marL="0">
+              <a:buNone/>
+            </a:pPr>
+            <a:r>
+              <a:rPr lang="en-US" sz="2200" b="1" dirty="0">
+                <a:solidFill>
+                  <a:srgbClr val="2A1618"/>
+                </a:solidFill>
+                <a:latin typeface="Cambria" pitchFamily="34" charset="0"/>
+                <a:ea typeface="Cambria" pitchFamily="34" charset="-122"/>
+                <a:cs typeface="Cambria" pitchFamily="34" charset="-120"/>
+              </a:rPr>
+              <a:t>y = W x + b</a:t>
+            </a:r>
+            <a:endParaRPr lang="en-US" sz="2200" dirty="0"/>
+          </a:p>
+        </p:txBody>
+      </p:sp>
+      <p:sp>
+        <p:nvSpPr>
+          <p:cNvPr id="32" name="Text 30"/>
+          <p:cNvSpPr/>
+          <p:nvPr/>
+        </p:nvSpPr>
+        <p:spPr>
+          <a:xfrm>
+            <a:off x="7955280" y="2514600"/>
+            <a:ext cx="3520440" cy="548640"/>
+          </a:xfrm>
+          <a:prstGeom prst="rect">
+            <a:avLst/>
+          </a:prstGeom>
+          <a:noFill/>
+          <a:ln/>
+        </p:spPr>
+        <p:txBody>
+          <a:bodyPr wrap="square" lIns="0" tIns="0" rIns="0" bIns="0" rtlCol="0" anchor="t"/>
+          <a:lstStyle/>
+          <a:p>
+            <a:pPr indent="0" marL="0">
+              <a:buNone/>
+            </a:pPr>
+            <a:r>
+              <a:rPr lang="en-US" sz="1000" dirty="0">
                 <a:solidFill>
                   <a:srgbClr val="836A68"/>
                 </a:solidFill>
@@ -3927,9 +3967,161 @@
                 <a:ea typeface="Calibri" pitchFamily="34" charset="-122"/>
                 <a:cs typeface="Calibri" pitchFamily="34" charset="-120"/>
               </a:rPr>
-              <a:t>Preliminary: only the empty baseline is cleanly paired. Nonlinear domain adaptation needs far more paired data (multiple sessions, matched tumor positions).</a:t>
-            </a:r>
-            <a:endParaRPr lang="en-US" sz="1250" dirty="0"/>
+              <a:t>x = sim [Re, Im of 16 S-params] (32-D); y = predicted measured; W (32x32) and b learned on the train frequencies.</a:t>
+            </a:r>
+            <a:endParaRPr lang="en-US" sz="1000" dirty="0"/>
+          </a:p>
+        </p:txBody>
+      </p:sp>
+      <p:sp>
+        <p:nvSpPr>
+          <p:cNvPr id="33" name="Shape 31"/>
+          <p:cNvSpPr/>
+          <p:nvPr/>
+        </p:nvSpPr>
+        <p:spPr>
+          <a:xfrm>
+            <a:off x="7772400" y="3291840"/>
+            <a:ext cx="3886200" cy="2971800"/>
+          </a:xfrm>
+          <a:prstGeom prst="roundRect">
+            <a:avLst>
+              <a:gd name="adj" fmla="val 2769"/>
+            </a:avLst>
+          </a:prstGeom>
+          <a:solidFill>
+            <a:srgbClr val="FBF4F2"/>
+          </a:solidFill>
+          <a:ln w="12700">
+            <a:solidFill>
+              <a:srgbClr val="E7D6D1"/>
+            </a:solidFill>
+            <a:prstDash val="solid"/>
+          </a:ln>
+          <a:effectLst>
+            <a:outerShdw sx="100000" sy="100000" kx="0" ky="0" algn="bl" rotWithShape="0" blurRad="88900" dist="38100" dir="5400000">
+              <a:srgbClr val="7A5C5E">
+                <a:alpha val="18000"/>
+              </a:srgbClr>
+            </a:outerShdw>
+          </a:effectLst>
+        </p:spPr>
+      </p:sp>
+      <p:sp>
+        <p:nvSpPr>
+          <p:cNvPr id="34" name="Text 32"/>
+          <p:cNvSpPr/>
+          <p:nvPr/>
+        </p:nvSpPr>
+        <p:spPr>
+          <a:xfrm>
+            <a:off x="7955280" y="3429000"/>
+            <a:ext cx="3566160" cy="365760"/>
+          </a:xfrm>
+          <a:prstGeom prst="rect">
+            <a:avLst/>
+          </a:prstGeom>
+          <a:noFill/>
+          <a:ln/>
+        </p:spPr>
+        <p:txBody>
+          <a:bodyPr wrap="square" lIns="0" tIns="0" rIns="0" bIns="0" rtlCol="0" anchor="ctr"/>
+          <a:lstStyle/>
+          <a:p>
+            <a:pPr indent="0" marL="0">
+              <a:buNone/>
+            </a:pPr>
+            <a:r>
+              <a:rPr lang="en-US" sz="1400" b="1" dirty="0">
+                <a:solidFill>
+                  <a:srgbClr val="BE0000"/>
+                </a:solidFill>
+                <a:latin typeface="Cambria" pitchFamily="34" charset="0"/>
+                <a:ea typeface="Cambria" pitchFamily="34" charset="-122"/>
+                <a:cs typeface="Cambria" pitchFamily="34" charset="-120"/>
+              </a:rPr>
+              <a:t>Why R2 = 0.65 is meaningful</a:t>
+            </a:r>
+            <a:endParaRPr lang="en-US" sz="1400" dirty="0"/>
+          </a:p>
+        </p:txBody>
+      </p:sp>
+      <p:sp>
+        <p:nvSpPr>
+          <p:cNvPr id="35" name="Text 33"/>
+          <p:cNvSpPr/>
+          <p:nvPr/>
+        </p:nvSpPr>
+        <p:spPr>
+          <a:xfrm>
+            <a:off x="7955280" y="3840480"/>
+            <a:ext cx="3566160" cy="2331720"/>
+          </a:xfrm>
+          <a:prstGeom prst="rect">
+            <a:avLst/>
+          </a:prstGeom>
+          <a:noFill/>
+          <a:ln/>
+        </p:spPr>
+        <p:txBody>
+          <a:bodyPr wrap="square" lIns="0" tIns="0" rIns="0" bIns="0" rtlCol="0" anchor="t"/>
+          <a:lstStyle/>
+          <a:p>
+            <a:pPr indent="0" marL="0">
+              <a:spcAft>
+                <a:spcPts val="900"/>
+              </a:spcAft>
+              <a:buNone/>
+            </a:pPr>
+            <a:r>
+              <a:rPr lang="en-US" sz="1100" dirty="0">
+                <a:solidFill>
+                  <a:srgbClr val="2A1618"/>
+                </a:solidFill>
+                <a:latin typeface="Calibri" pitchFamily="34" charset="0"/>
+                <a:ea typeface="Calibri" pitchFamily="34" charset="-122"/>
+                <a:cs typeface="Calibri" pitchFamily="34" charset="-120"/>
+              </a:rPr>
+              <a:t>R2 is computed only on frequencies the map never used while fitting, so it measures genuine generalization, not curve-fitting.</a:t>
+            </a:r>
+            <a:endParaRPr lang="en-US" sz="1100" dirty="0"/>
+          </a:p>
+          <a:p>
+            <a:pPr indent="0" marL="0">
+              <a:spcAft>
+                <a:spcPts val="900"/>
+              </a:spcAft>
+              <a:buNone/>
+            </a:pPr>
+            <a:r>
+              <a:rPr lang="en-US" sz="1100" dirty="0">
+                <a:solidFill>
+                  <a:srgbClr val="2A1618"/>
+                </a:solidFill>
+                <a:latin typeface="Calibri" pitchFamily="34" charset="0"/>
+                <a:ea typeface="Calibri" pitchFamily="34" charset="-122"/>
+                <a:cs typeface="Calibri" pitchFamily="34" charset="-120"/>
+              </a:rPr>
+              <a:t>A model that merely memorized the training frequencies would score near 0 on the held-out set. The flexible MLP did exactly that (R2 &lt; 0).</a:t>
+            </a:r>
+            <a:endParaRPr lang="en-US" sz="1100" dirty="0"/>
+          </a:p>
+          <a:p>
+            <a:pPr indent="0" marL="0">
+              <a:buNone/>
+            </a:pPr>
+            <a:r>
+              <a:rPr lang="en-US" sz="1100" dirty="0">
+                <a:solidFill>
+                  <a:srgbClr val="2A1618"/>
+                </a:solidFill>
+                <a:latin typeface="Calibri" pitchFamily="34" charset="0"/>
+                <a:ea typeface="Calibri" pitchFamily="34" charset="-122"/>
+                <a:cs typeface="Calibri" pitchFamily="34" charset="-120"/>
+              </a:rPr>
+              <a:t>So R2 = 0.65 says a fixed linear transform already recovers most of the measured signal from the sim, on data it has not seen.</a:t>
+            </a:r>
+            <a:endParaRPr lang="en-US" sz="1100" dirty="0"/>
           </a:p>
         </p:txBody>
       </p:sp>
@@ -3998,7 +4190,7 @@
                 <a:ea typeface="Cambria" pitchFamily="34" charset="-122"/>
                 <a:cs typeface="Cambria" pitchFamily="34" charset="-120"/>
               </a:rPr>
-              <a:t>Beet (dielectric) vs metal tumor, sim and measured</a:t>
+              <a:t>Can a model bridge the gap? (exploratory)</a:t>
             </a:r>
             <a:endParaRPr lang="en-US" sz="2900" dirty="0"/>
           </a:p>
@@ -4037,7 +4229,7 @@
                 <a:ea typeface="Calibri" pitchFamily="34" charset="-122"/>
                 <a:cs typeface="Calibri" pitchFamily="34" charset="-120"/>
               </a:rPr>
-              <a:t>How much differential signal a realistic dielectric target produces relative to metal</a:t>
+              <a:t>The learned map applied to one port, and its accuracy on unseen frequencies</a:t>
             </a:r>
             <a:endParaRPr lang="en-US" sz="1400" dirty="0"/>
           </a:p>
@@ -4045,7 +4237,7 @@
       </p:sp>
       <p:pic>
         <p:nvPicPr>
-          <p:cNvPr id="4" name="Image 0" descr="beet_vs_metal_dS.png">    </p:cNvPr>
+          <p:cNvPr id="4" name="Image 0" descr="sim_meas_correlation.png">    </p:cNvPr>
           <p:cNvPicPr>
             <a:picLocks noChangeAspect="1"/>
           </p:cNvPicPr>
@@ -4059,14 +4251,211 @@
         </p:blipFill>
         <p:spPr>
           <a:xfrm>
-            <a:off x="822960" y="1737360"/>
-            <a:ext cx="10515600" cy="4892040"/>
+            <a:off x="457200" y="1737360"/>
+            <a:ext cx="7772400" cy="3154680"/>
           </a:xfrm>
           <a:prstGeom prst="rect">
             <a:avLst/>
           </a:prstGeom>
         </p:spPr>
       </p:pic>
+      <p:sp>
+        <p:nvSpPr>
+          <p:cNvPr id="5" name="Shape 2"/>
+          <p:cNvSpPr/>
+          <p:nvPr/>
+        </p:nvSpPr>
+        <p:spPr>
+          <a:xfrm>
+            <a:off x="8412480" y="1645920"/>
+            <a:ext cx="3246120" cy="3794760"/>
+          </a:xfrm>
+          <a:prstGeom prst="roundRect">
+            <a:avLst>
+              <a:gd name="adj" fmla="val 2535"/>
+            </a:avLst>
+          </a:prstGeom>
+          <a:solidFill>
+            <a:srgbClr val="FBF4F2"/>
+          </a:solidFill>
+          <a:ln w="12700">
+            <a:solidFill>
+              <a:srgbClr val="E7D6D1"/>
+            </a:solidFill>
+            <a:prstDash val="solid"/>
+          </a:ln>
+          <a:effectLst>
+            <a:outerShdw sx="100000" sy="100000" kx="0" ky="0" algn="bl" rotWithShape="0" blurRad="88900" dist="38100" dir="5400000">
+              <a:srgbClr val="7A5C5E">
+                <a:alpha val="18000"/>
+              </a:srgbClr>
+            </a:outerShdw>
+          </a:effectLst>
+        </p:spPr>
+      </p:sp>
+      <p:sp>
+        <p:nvSpPr>
+          <p:cNvPr id="6" name="Text 3"/>
+          <p:cNvSpPr/>
+          <p:nvPr/>
+        </p:nvSpPr>
+        <p:spPr>
+          <a:xfrm>
+            <a:off x="8595360" y="1783080"/>
+            <a:ext cx="2926080" cy="365760"/>
+          </a:xfrm>
+          <a:prstGeom prst="rect">
+            <a:avLst/>
+          </a:prstGeom>
+          <a:noFill/>
+          <a:ln/>
+        </p:spPr>
+        <p:txBody>
+          <a:bodyPr wrap="square" lIns="0" tIns="0" rIns="0" bIns="0" rtlCol="0" anchor="ctr"/>
+          <a:lstStyle/>
+          <a:p>
+            <a:pPr indent="0" marL="0">
+              <a:buNone/>
+            </a:pPr>
+            <a:r>
+              <a:rPr lang="en-US" sz="1500" b="1" dirty="0">
+                <a:solidFill>
+                  <a:srgbClr val="BE0000"/>
+                </a:solidFill>
+                <a:latin typeface="Cambria" pitchFamily="34" charset="0"/>
+                <a:ea typeface="Cambria" pitchFamily="34" charset="-122"/>
+                <a:cs typeface="Cambria" pitchFamily="34" charset="-120"/>
+              </a:rPr>
+              <a:t>How to read it</a:t>
+            </a:r>
+            <a:endParaRPr lang="en-US" sz="1500" dirty="0"/>
+          </a:p>
+        </p:txBody>
+      </p:sp>
+      <p:sp>
+        <p:nvSpPr>
+          <p:cNvPr id="7" name="Text 4"/>
+          <p:cNvSpPr/>
+          <p:nvPr/>
+        </p:nvSpPr>
+        <p:spPr>
+          <a:xfrm>
+            <a:off x="8595360" y="2194560"/>
+            <a:ext cx="2971800" cy="3108960"/>
+          </a:xfrm>
+          <a:prstGeom prst="rect">
+            <a:avLst/>
+          </a:prstGeom>
+          <a:noFill/>
+          <a:ln/>
+        </p:spPr>
+        <p:txBody>
+          <a:bodyPr wrap="square" lIns="0" tIns="0" rIns="0" bIns="0" rtlCol="0" anchor="t"/>
+          <a:lstStyle/>
+          <a:p>
+            <a:pPr marL="342900" indent="-342900">
+              <a:spcAft>
+                <a:spcPts val="800"/>
+              </a:spcAft>
+              <a:buSzPct val="100000"/>
+              <a:buChar char="•"/>
+            </a:pPr>
+            <a:r>
+              <a:rPr lang="en-US" sz="1050" dirty="0">
+                <a:solidFill>
+                  <a:srgbClr val="2A1618"/>
+                </a:solidFill>
+                <a:latin typeface="Calibri" pitchFamily="34" charset="0"/>
+                <a:ea typeface="Calibri" pitchFamily="34" charset="-122"/>
+                <a:cs typeface="Calibri" pitchFamily="34" charset="-120"/>
+              </a:rPr>
+              <a:t>Left: the dashed line is the simulated S11 after the map (W x_sim + b). A perfect map would land on the measured (red) curve; it moves toward it but does not fully match.</a:t>
+            </a:r>
+            <a:endParaRPr lang="en-US" sz="1050" dirty="0"/>
+          </a:p>
+          <a:p>
+            <a:pPr marL="342900" indent="-342900">
+              <a:spcAft>
+                <a:spcPts val="800"/>
+              </a:spcAft>
+              <a:buSzPct val="100000"/>
+              <a:buChar char="•"/>
+            </a:pPr>
+            <a:r>
+              <a:rPr lang="en-US" sz="1050" dirty="0">
+                <a:solidFill>
+                  <a:srgbClr val="2A1618"/>
+                </a:solidFill>
+                <a:latin typeface="Calibri" pitchFamily="34" charset="0"/>
+                <a:ea typeface="Calibri" pitchFamily="34" charset="-122"/>
+                <a:cs typeface="Calibri" pitchFamily="34" charset="-120"/>
+              </a:rPr>
+              <a:t>Right: predicted vs measured on the held-out frequencies. Points on the diagonal are exact; the R2 = 0.65 spread shows the map captures most, not all, of the relationship.</a:t>
+            </a:r>
+            <a:endParaRPr lang="en-US" sz="1050" dirty="0"/>
+          </a:p>
+          <a:p>
+            <a:pPr marL="342900" indent="-342900">
+              <a:spcAft>
+                <a:spcPts val="800"/>
+              </a:spcAft>
+              <a:buSzPct val="100000"/>
+              <a:buChar char="•"/>
+            </a:pPr>
+            <a:r>
+              <a:rPr lang="en-US" sz="1050" dirty="0">
+                <a:solidFill>
+                  <a:srgbClr val="2A1618"/>
+                </a:solidFill>
+                <a:latin typeface="Calibri" pitchFamily="34" charset="0"/>
+                <a:ea typeface="Calibri" pitchFamily="34" charset="-122"/>
+                <a:cs typeface="Calibri" pitchFamily="34" charset="-120"/>
+              </a:rPr>
+              <a:t>A flexible MLP overfits and fails to generalize (R2 &lt; 0).</a:t>
+            </a:r>
+            <a:endParaRPr lang="en-US" sz="1050" dirty="0"/>
+          </a:p>
+        </p:txBody>
+      </p:sp>
+      <p:sp>
+        <p:nvSpPr>
+          <p:cNvPr id="8" name="Text 5"/>
+          <p:cNvSpPr/>
+          <p:nvPr/>
+        </p:nvSpPr>
+        <p:spPr>
+          <a:xfrm>
+            <a:off x="548640" y="6035040"/>
+            <a:ext cx="11091672" cy="548640"/>
+          </a:xfrm>
+          <a:prstGeom prst="rect">
+            <a:avLst/>
+          </a:prstGeom>
+          <a:noFill/>
+          <a:ln/>
+        </p:spPr>
+        <p:txBody>
+          <a:bodyPr wrap="square" lIns="0" tIns="0" rIns="0" bIns="0" rtlCol="0" anchor="ctr"/>
+          <a:lstStyle/>
+          <a:p>
+            <a:pPr algn="ctr" indent="0" marL="0">
+              <a:buNone/>
+            </a:pPr>
+            <a:r>
+              <a:rPr lang="en-US" sz="1250" i="1" dirty="0">
+                <a:solidFill>
+                  <a:srgbClr val="836A68"/>
+                </a:solidFill>
+                <a:latin typeface="Calibri" pitchFamily="34" charset="0"/>
+                <a:ea typeface="Calibri" pitchFamily="34" charset="-122"/>
+                <a:cs typeface="Calibri" pitchFamily="34" charset="-120"/>
+              </a:rPr>
+              <a:t>Preliminary: only the empty baseline is cleanly paired. Nonlinear domain adaptation needs far more paired data (multiple sessions, matched tumor positions).</a:t>
+            </a:r>
+            <a:endParaRPr lang="en-US" sz="1250" dirty="0"/>
+          </a:p>
+        </p:txBody>
+      </p:sp>
     </p:spTree>
   </p:cSld>
   <p:clrMapOvr>
@@ -4078,6 +4467,140 @@
 <file path=ppt/slides/slide13.xml><?xml version="1.0" encoding="utf-8"?>
 <p:sld xmlns:a="http://schemas.openxmlformats.org/drawingml/2006/main" xmlns:r="http://schemas.openxmlformats.org/officeDocument/2006/relationships" xmlns:p="http://schemas.openxmlformats.org/presentationml/2006/main">
   <p:cSld name="Slide 13">
+    <p:bg>
+      <p:bgPr>
+        <a:solidFill>
+          <a:srgbClr val="FFFFFF"/>
+        </a:solidFill>
+      </p:bgPr>
+    </p:bg>
+    <p:spTree>
+      <p:nvGrpSpPr>
+        <p:cNvPr id="1" name=""/>
+        <p:cNvGrpSpPr/>
+        <p:nvPr/>
+      </p:nvGrpSpPr>
+      <p:grpSpPr>
+        <a:xfrm>
+          <a:off x="0" y="0"/>
+          <a:ext cx="0" cy="0"/>
+          <a:chOff x="0" y="0"/>
+          <a:chExt cx="0" cy="0"/>
+        </a:xfrm>
+      </p:grpSpPr>
+      <p:sp>
+        <p:nvSpPr>
+          <p:cNvPr id="2" name="Text 0"/>
+          <p:cNvSpPr/>
+          <p:nvPr/>
+        </p:nvSpPr>
+        <p:spPr>
+          <a:xfrm>
+            <a:off x="548640" y="384048"/>
+            <a:ext cx="11091672" cy="640080"/>
+          </a:xfrm>
+          <a:prstGeom prst="rect">
+            <a:avLst/>
+          </a:prstGeom>
+          <a:noFill/>
+          <a:ln/>
+        </p:spPr>
+        <p:txBody>
+          <a:bodyPr wrap="square" lIns="0" tIns="0" rIns="0" bIns="0" rtlCol="0" anchor="ctr"/>
+          <a:lstStyle/>
+          <a:p>
+            <a:pPr indent="0" marL="0">
+              <a:buNone/>
+            </a:pPr>
+            <a:r>
+              <a:rPr lang="en-US" sz="2900" b="1" dirty="0">
+                <a:solidFill>
+                  <a:srgbClr val="2A1618"/>
+                </a:solidFill>
+                <a:latin typeface="Cambria" pitchFamily="34" charset="0"/>
+                <a:ea typeface="Cambria" pitchFamily="34" charset="-122"/>
+                <a:cs typeface="Cambria" pitchFamily="34" charset="-120"/>
+              </a:rPr>
+              <a:t>Beet (dielectric) vs metal tumor, sim and measured</a:t>
+            </a:r>
+            <a:endParaRPr lang="en-US" sz="2900" dirty="0"/>
+          </a:p>
+        </p:txBody>
+      </p:sp>
+      <p:sp>
+        <p:nvSpPr>
+          <p:cNvPr id="3" name="Text 1"/>
+          <p:cNvSpPr/>
+          <p:nvPr/>
+        </p:nvSpPr>
+        <p:spPr>
+          <a:xfrm>
+            <a:off x="548640" y="1033272"/>
+            <a:ext cx="11091672" cy="365760"/>
+          </a:xfrm>
+          <a:prstGeom prst="rect">
+            <a:avLst/>
+          </a:prstGeom>
+          <a:noFill/>
+          <a:ln/>
+        </p:spPr>
+        <p:txBody>
+          <a:bodyPr wrap="square" lIns="0" tIns="0" rIns="0" bIns="0" rtlCol="0" anchor="ctr"/>
+          <a:lstStyle/>
+          <a:p>
+            <a:pPr indent="0" marL="0">
+              <a:buNone/>
+            </a:pPr>
+            <a:r>
+              <a:rPr lang="en-US" sz="1400" b="1" dirty="0">
+                <a:solidFill>
+                  <a:srgbClr val="BE0000"/>
+                </a:solidFill>
+                <a:latin typeface="Calibri" pitchFamily="34" charset="0"/>
+                <a:ea typeface="Calibri" pitchFamily="34" charset="-122"/>
+                <a:cs typeface="Calibri" pitchFamily="34" charset="-120"/>
+              </a:rPr>
+              <a:t>How much differential signal a realistic dielectric target produces relative to metal</a:t>
+            </a:r>
+            <a:endParaRPr lang="en-US" sz="1400" dirty="0"/>
+          </a:p>
+        </p:txBody>
+      </p:sp>
+      <p:pic>
+        <p:nvPicPr>
+          <p:cNvPr id="4" name="Image 0" descr="beet_vs_metal_dS.png">    </p:cNvPr>
+          <p:cNvPicPr>
+            <a:picLocks noChangeAspect="1"/>
+          </p:cNvPicPr>
+          <p:nvPr/>
+        </p:nvPicPr>
+        <p:blipFill>
+          <a:blip r:embed="rId1"/>
+          <a:stretch>
+            <a:fillRect/>
+          </a:stretch>
+        </p:blipFill>
+        <p:spPr>
+          <a:xfrm>
+            <a:off x="822960" y="1737360"/>
+            <a:ext cx="10515600" cy="4892040"/>
+          </a:xfrm>
+          <a:prstGeom prst="rect">
+            <a:avLst/>
+          </a:prstGeom>
+        </p:spPr>
+      </p:pic>
+    </p:spTree>
+  </p:cSld>
+  <p:clrMapOvr>
+    <a:masterClrMapping/>
+  </p:clrMapOvr>
+</p:sld>
+</file>
+
+<file path=ppt/slides/slide14.xml><?xml version="1.0" encoding="utf-8"?>
+<p:sld xmlns:a="http://schemas.openxmlformats.org/drawingml/2006/main" xmlns:r="http://schemas.openxmlformats.org/officeDocument/2006/relationships" xmlns:p="http://schemas.openxmlformats.org/presentationml/2006/main">
+  <p:cSld name="Slide 14">
     <p:bg>
       <p:bgPr>
         <a:solidFill>

</xml_diff>